<commit_message>
cambios en la documentacion
</commit_message>
<xml_diff>
--- a/documentacion_extra/presentacion/cuidaDos.pptx
+++ b/documentacion_extra/presentacion/cuidaDos.pptx
@@ -17,43 +17,37 @@
     <p:sldId id="265" r:id="rId15"/>
     <p:sldId id="266" r:id="rId16"/>
     <p:sldId id="267" r:id="rId17"/>
-    <p:sldId id="268" r:id="rId18"/>
-    <p:sldId id="269" r:id="rId19"/>
   </p:sldIdLst>
   <p:sldSz cx="18288000" cy="10287000"/>
   <p:notesSz cx="6858000" cy="9144000"/>
   <p:embeddedFontLst>
     <p:embeddedFont>
       <p:font typeface="Montserrat Bold" charset="1" panose="00000800000000000000"/>
+      <p:regular r:id="rId18"/>
+    </p:embeddedFont>
+    <p:embeddedFont>
+      <p:font typeface="Montserrat" charset="1" panose="00000500000000000000"/>
+      <p:regular r:id="rId19"/>
+    </p:embeddedFont>
+    <p:embeddedFont>
+      <p:font typeface="Fraunces Bold" charset="1" panose="00000000000000000000"/>
       <p:regular r:id="rId20"/>
     </p:embeddedFont>
     <p:embeddedFont>
-      <p:font typeface="Montserrat" charset="1" panose="00000500000000000000"/>
+      <p:font typeface="Poppins" charset="1" panose="00000500000000000000"/>
       <p:regular r:id="rId21"/>
     </p:embeddedFont>
     <p:embeddedFont>
-      <p:font typeface="Fraunces Bold" charset="1" panose="00000000000000000000"/>
+      <p:font typeface="Open Sans" charset="1" panose="020B0606030504020204"/>
       <p:regular r:id="rId22"/>
     </p:embeddedFont>
     <p:embeddedFont>
-      <p:font typeface="Poppins" charset="1" panose="00000500000000000000"/>
+      <p:font typeface="Poppins Bold" charset="1" panose="00000800000000000000"/>
       <p:regular r:id="rId23"/>
     </p:embeddedFont>
     <p:embeddedFont>
-      <p:font typeface="Open Sans" charset="1" panose="020B0606030504020204"/>
+      <p:font typeface="Fraunces" charset="1" panose="00000000000000000000"/>
       <p:regular r:id="rId24"/>
-    </p:embeddedFont>
-    <p:embeddedFont>
-      <p:font typeface="Poppins Bold" charset="1" panose="00000800000000000000"/>
-      <p:regular r:id="rId25"/>
-    </p:embeddedFont>
-    <p:embeddedFont>
-      <p:font typeface="Fraunces" charset="1" panose="00000000000000000000"/>
-      <p:regular r:id="rId26"/>
-    </p:embeddedFont>
-    <p:embeddedFont>
-      <p:font typeface="Archivo Black" charset="1" panose="020B0A03020202020B04"/>
-      <p:regular r:id="rId27"/>
     </p:embeddedFont>
   </p:embeddedFontLst>
   <p:defaultTextStyle>
@@ -3333,55 +3327,9 @@
           </a:blipFill>
         </p:spPr>
       </p:sp>
-      <p:sp>
-        <p:nvSpPr>
-          <p:cNvPr name="Freeform 8" id="8"/>
-          <p:cNvSpPr/>
-          <p:nvPr/>
-        </p:nvSpPr>
-        <p:spPr>
-          <a:xfrm flipH="false" flipV="false" rot="0">
-            <a:off x="12833394" y="6585475"/>
-            <a:ext cx="2011615" cy="2011615"/>
-          </a:xfrm>
-          <a:custGeom>
-            <a:avLst/>
-            <a:gdLst/>
-            <a:ahLst/>
-            <a:cxnLst/>
-            <a:rect r="r" b="b" t="t" l="l"/>
-            <a:pathLst>
-              <a:path h="2011615" w="2011615">
-                <a:moveTo>
-                  <a:pt x="0" y="0"/>
-                </a:moveTo>
-                <a:lnTo>
-                  <a:pt x="2011614" y="0"/>
-                </a:lnTo>
-                <a:lnTo>
-                  <a:pt x="2011614" y="2011615"/>
-                </a:lnTo>
-                <a:lnTo>
-                  <a:pt x="0" y="2011615"/>
-                </a:lnTo>
-                <a:lnTo>
-                  <a:pt x="0" y="0"/>
-                </a:lnTo>
-                <a:close/>
-              </a:path>
-            </a:pathLst>
-          </a:custGeom>
-          <a:blipFill>
-            <a:blip r:embed="rId5"/>
-            <a:stretch>
-              <a:fillRect l="0" t="0" r="0" b="0"/>
-            </a:stretch>
-          </a:blipFill>
-        </p:spPr>
-      </p:sp>
       <p:grpSp>
         <p:nvGrpSpPr>
-          <p:cNvPr name="Group 9" id="9"/>
+          <p:cNvPr name="Group 8" id="8"/>
           <p:cNvGrpSpPr/>
           <p:nvPr/>
         </p:nvGrpSpPr>
@@ -3395,7 +3343,7 @@
         </p:grpSpPr>
         <p:sp>
           <p:nvSpPr>
-            <p:cNvPr name="Freeform 10" id="10"/>
+            <p:cNvPr name="Freeform 9" id="9"/>
             <p:cNvSpPr/>
             <p:nvPr/>
           </p:nvSpPr>
@@ -3447,7 +3395,7 @@
         </p:sp>
         <p:sp>
           <p:nvSpPr>
-            <p:cNvPr name="TextBox 11" id="11"/>
+            <p:cNvPr name="TextBox 10" id="10"/>
             <p:cNvSpPr txBox="true"/>
             <p:nvPr/>
           </p:nvSpPr>
@@ -3473,6 +3421,52 @@
           </p:txBody>
         </p:sp>
       </p:grpSp>
+      <p:sp>
+        <p:nvSpPr>
+          <p:cNvPr name="Freeform 11" id="11"/>
+          <p:cNvSpPr/>
+          <p:nvPr/>
+        </p:nvSpPr>
+        <p:spPr>
+          <a:xfrm flipH="false" flipV="false" rot="0">
+            <a:off x="13118589" y="6896711"/>
+            <a:ext cx="1699666" cy="1699666"/>
+          </a:xfrm>
+          <a:custGeom>
+            <a:avLst/>
+            <a:gdLst/>
+            <a:ahLst/>
+            <a:cxnLst/>
+            <a:rect r="r" b="b" t="t" l="l"/>
+            <a:pathLst>
+              <a:path h="1699666" w="1699666">
+                <a:moveTo>
+                  <a:pt x="0" y="0"/>
+                </a:moveTo>
+                <a:lnTo>
+                  <a:pt x="1699666" y="0"/>
+                </a:lnTo>
+                <a:lnTo>
+                  <a:pt x="1699666" y="1699666"/>
+                </a:lnTo>
+                <a:lnTo>
+                  <a:pt x="0" y="1699666"/>
+                </a:lnTo>
+                <a:lnTo>
+                  <a:pt x="0" y="0"/>
+                </a:lnTo>
+                <a:close/>
+              </a:path>
+            </a:pathLst>
+          </a:custGeom>
+          <a:blipFill>
+            <a:blip r:embed="rId5"/>
+            <a:stretch>
+              <a:fillRect l="0" t="0" r="0" b="0"/>
+            </a:stretch>
+          </a:blipFill>
+        </p:spPr>
+      </p:sp>
       <p:sp>
         <p:nvSpPr>
           <p:cNvPr name="TextBox 12" id="12"/>
@@ -3700,593 +3694,7 @@
         </p:nvGrpSpPr>
         <p:grpSpPr>
           <a:xfrm rot="0">
-            <a:off x="6137244" y="580867"/>
-            <a:ext cx="3910547" cy="895666"/>
-            <a:chOff x="0" y="0"/>
-            <a:chExt cx="909243" cy="208252"/>
-          </a:xfrm>
-        </p:grpSpPr>
-        <p:sp>
-          <p:nvSpPr>
-            <p:cNvPr name="Freeform 6" id="6"/>
-            <p:cNvSpPr/>
-            <p:nvPr/>
-          </p:nvSpPr>
-          <p:spPr>
-            <a:xfrm flipH="false" flipV="false" rot="0">
-              <a:off x="0" y="0"/>
-              <a:ext cx="909243" cy="208252"/>
-            </a:xfrm>
-            <a:custGeom>
-              <a:avLst/>
-              <a:gdLst/>
-              <a:ahLst/>
-              <a:cxnLst/>
-              <a:rect r="r" b="b" t="t" l="l"/>
-              <a:pathLst>
-                <a:path h="208252" w="909243">
-                  <a:moveTo>
-                    <a:pt x="15838" y="0"/>
-                  </a:moveTo>
-                  <a:lnTo>
-                    <a:pt x="893405" y="0"/>
-                  </a:lnTo>
-                  <a:cubicBezTo>
-                    <a:pt x="897605" y="0"/>
-                    <a:pt x="901634" y="1669"/>
-                    <a:pt x="904604" y="4639"/>
-                  </a:cubicBezTo>
-                  <a:cubicBezTo>
-                    <a:pt x="907574" y="7609"/>
-                    <a:pt x="909243" y="11638"/>
-                    <a:pt x="909243" y="15838"/>
-                  </a:cubicBezTo>
-                  <a:lnTo>
-                    <a:pt x="909243" y="192414"/>
-                  </a:lnTo>
-                  <a:cubicBezTo>
-                    <a:pt x="909243" y="196614"/>
-                    <a:pt x="907574" y="200643"/>
-                    <a:pt x="904604" y="203613"/>
-                  </a:cubicBezTo>
-                  <a:cubicBezTo>
-                    <a:pt x="901634" y="206583"/>
-                    <a:pt x="897605" y="208252"/>
-                    <a:pt x="893405" y="208252"/>
-                  </a:cubicBezTo>
-                  <a:lnTo>
-                    <a:pt x="15838" y="208252"/>
-                  </a:lnTo>
-                  <a:cubicBezTo>
-                    <a:pt x="11638" y="208252"/>
-                    <a:pt x="7609" y="206583"/>
-                    <a:pt x="4639" y="203613"/>
-                  </a:cubicBezTo>
-                  <a:cubicBezTo>
-                    <a:pt x="1669" y="200643"/>
-                    <a:pt x="0" y="196614"/>
-                    <a:pt x="0" y="192414"/>
-                  </a:cubicBezTo>
-                  <a:lnTo>
-                    <a:pt x="0" y="15838"/>
-                  </a:lnTo>
-                  <a:cubicBezTo>
-                    <a:pt x="0" y="11638"/>
-                    <a:pt x="1669" y="7609"/>
-                    <a:pt x="4639" y="4639"/>
-                  </a:cubicBezTo>
-                  <a:cubicBezTo>
-                    <a:pt x="7609" y="1669"/>
-                    <a:pt x="11638" y="0"/>
-                    <a:pt x="15838" y="0"/>
-                  </a:cubicBezTo>
-                  <a:close/>
-                </a:path>
-              </a:pathLst>
-            </a:custGeom>
-            <a:solidFill>
-              <a:srgbClr val="93D14B"/>
-            </a:solidFill>
-          </p:spPr>
-        </p:sp>
-        <p:sp>
-          <p:nvSpPr>
-            <p:cNvPr name="TextBox 7" id="7"/>
-            <p:cNvSpPr txBox="true"/>
-            <p:nvPr/>
-          </p:nvSpPr>
-          <p:spPr>
-            <a:xfrm>
-              <a:off x="0" y="-76200"/>
-              <a:ext cx="909243" cy="284452"/>
-            </a:xfrm>
-            <a:prstGeom prst="rect">
-              <a:avLst/>
-            </a:prstGeom>
-          </p:spPr>
-          <p:txBody>
-            <a:bodyPr anchor="t" rtlCol="false" tIns="50800" lIns="50800" bIns="50800" rIns="50800"/>
-            <a:lstStyle/>
-            <a:p>
-              <a:pPr algn="ctr" marL="0" indent="0" lvl="0">
-                <a:lnSpc>
-                  <a:spcPts val="4114"/>
-                </a:lnSpc>
-                <a:spcBef>
-                  <a:spcPct val="0"/>
-                </a:spcBef>
-              </a:pPr>
-              <a:r>
-                <a:rPr lang="en-US" b="true" sz="2981" spc="29">
-                  <a:solidFill>
-                    <a:srgbClr val="FFFFFF"/>
-                  </a:solidFill>
-                  <a:latin typeface="Poppins Bold"/>
-                  <a:ea typeface="Poppins Bold"/>
-                  <a:cs typeface="Poppins Bold"/>
-                  <a:sym typeface="Poppins Bold"/>
-                </a:rPr>
-                <a:t>ADMIN</a:t>
-              </a:r>
-            </a:p>
-          </p:txBody>
-        </p:sp>
-      </p:grpSp>
-      <p:sp>
-        <p:nvSpPr>
-          <p:cNvPr name="Freeform 8" id="8"/>
-          <p:cNvSpPr/>
-          <p:nvPr/>
-        </p:nvSpPr>
-        <p:spPr>
-          <a:xfrm flipH="false" flipV="false" rot="0">
-            <a:off x="3853242" y="3408876"/>
-            <a:ext cx="8153925" cy="4714137"/>
-          </a:xfrm>
-          <a:custGeom>
-            <a:avLst/>
-            <a:gdLst/>
-            <a:ahLst/>
-            <a:cxnLst/>
-            <a:rect r="r" b="b" t="t" l="l"/>
-            <a:pathLst>
-              <a:path h="4714137" w="8153925">
-                <a:moveTo>
-                  <a:pt x="0" y="0"/>
-                </a:moveTo>
-                <a:lnTo>
-                  <a:pt x="8153924" y="0"/>
-                </a:lnTo>
-                <a:lnTo>
-                  <a:pt x="8153924" y="4714137"/>
-                </a:lnTo>
-                <a:lnTo>
-                  <a:pt x="0" y="4714137"/>
-                </a:lnTo>
-                <a:lnTo>
-                  <a:pt x="0" y="0"/>
-                </a:lnTo>
-                <a:close/>
-              </a:path>
-            </a:pathLst>
-          </a:custGeom>
-          <a:blipFill>
-            <a:blip r:embed="rId2"/>
-            <a:stretch>
-              <a:fillRect l="-1390" t="0" r="-1390" b="0"/>
-            </a:stretch>
-          </a:blipFill>
-        </p:spPr>
-      </p:sp>
-      <p:sp>
-        <p:nvSpPr>
-          <p:cNvPr name="Freeform 9" id="9"/>
-          <p:cNvSpPr/>
-          <p:nvPr/>
-        </p:nvSpPr>
-        <p:spPr>
-          <a:xfrm flipH="false" flipV="false" rot="0">
-            <a:off x="3853242" y="8659398"/>
-            <a:ext cx="8153925" cy="1197803"/>
-          </a:xfrm>
-          <a:custGeom>
-            <a:avLst/>
-            <a:gdLst/>
-            <a:ahLst/>
-            <a:cxnLst/>
-            <a:rect r="r" b="b" t="t" l="l"/>
-            <a:pathLst>
-              <a:path h="1197803" w="8153925">
-                <a:moveTo>
-                  <a:pt x="0" y="0"/>
-                </a:moveTo>
-                <a:lnTo>
-                  <a:pt x="8153924" y="0"/>
-                </a:lnTo>
-                <a:lnTo>
-                  <a:pt x="8153924" y="1197804"/>
-                </a:lnTo>
-                <a:lnTo>
-                  <a:pt x="0" y="1197804"/>
-                </a:lnTo>
-                <a:lnTo>
-                  <a:pt x="0" y="0"/>
-                </a:lnTo>
-                <a:close/>
-              </a:path>
-            </a:pathLst>
-          </a:custGeom>
-          <a:blipFill>
-            <a:blip r:embed="rId3"/>
-            <a:stretch>
-              <a:fillRect l="0" t="0" r="0" b="-14874"/>
-            </a:stretch>
-          </a:blipFill>
-        </p:spPr>
-      </p:sp>
-      <p:sp>
-        <p:nvSpPr>
-          <p:cNvPr name="Freeform 10" id="10"/>
-          <p:cNvSpPr/>
-          <p:nvPr/>
-        </p:nvSpPr>
-        <p:spPr>
-          <a:xfrm flipH="false" flipV="false" rot="0">
-            <a:off x="12387619" y="3408876"/>
-            <a:ext cx="3854721" cy="1734624"/>
-          </a:xfrm>
-          <a:custGeom>
-            <a:avLst/>
-            <a:gdLst/>
-            <a:ahLst/>
-            <a:cxnLst/>
-            <a:rect r="r" b="b" t="t" l="l"/>
-            <a:pathLst>
-              <a:path h="1734624" w="3854721">
-                <a:moveTo>
-                  <a:pt x="0" y="0"/>
-                </a:moveTo>
-                <a:lnTo>
-                  <a:pt x="3854721" y="0"/>
-                </a:lnTo>
-                <a:lnTo>
-                  <a:pt x="3854721" y="1734624"/>
-                </a:lnTo>
-                <a:lnTo>
-                  <a:pt x="0" y="1734624"/>
-                </a:lnTo>
-                <a:lnTo>
-                  <a:pt x="0" y="0"/>
-                </a:lnTo>
-                <a:close/>
-              </a:path>
-            </a:pathLst>
-          </a:custGeom>
-          <a:blipFill>
-            <a:blip r:embed="rId4"/>
-            <a:stretch>
-              <a:fillRect l="0" t="0" r="0" b="0"/>
-            </a:stretch>
-          </a:blipFill>
-        </p:spPr>
-      </p:sp>
-      <p:sp>
-        <p:nvSpPr>
-          <p:cNvPr name="Freeform 11" id="11"/>
-          <p:cNvSpPr/>
-          <p:nvPr/>
-        </p:nvSpPr>
-        <p:spPr>
-          <a:xfrm flipH="false" flipV="false" rot="0">
-            <a:off x="13738790" y="8321483"/>
-            <a:ext cx="1382147" cy="1535718"/>
-          </a:xfrm>
-          <a:custGeom>
-            <a:avLst/>
-            <a:gdLst/>
-            <a:ahLst/>
-            <a:cxnLst/>
-            <a:rect r="r" b="b" t="t" l="l"/>
-            <a:pathLst>
-              <a:path h="1535718" w="1382147">
-                <a:moveTo>
-                  <a:pt x="0" y="0"/>
-                </a:moveTo>
-                <a:lnTo>
-                  <a:pt x="1382146" y="0"/>
-                </a:lnTo>
-                <a:lnTo>
-                  <a:pt x="1382146" y="1535719"/>
-                </a:lnTo>
-                <a:lnTo>
-                  <a:pt x="0" y="1535719"/>
-                </a:lnTo>
-                <a:lnTo>
-                  <a:pt x="0" y="0"/>
-                </a:lnTo>
-                <a:close/>
-              </a:path>
-            </a:pathLst>
-          </a:custGeom>
-          <a:blipFill>
-            <a:blip r:embed="rId5">
-              <a:extLst>
-                <a:ext uri="{96DAC541-7B7A-43D3-8B79-37D633B846F1}">
-                  <asvg:svgBlip xmlns:asvg="http://schemas.microsoft.com/office/drawing/2016/SVG/main" r:embed="rId6"/>
-                </a:ext>
-              </a:extLst>
-            </a:blip>
-            <a:stretch>
-              <a:fillRect l="0" t="0" r="0" b="0"/>
-            </a:stretch>
-          </a:blipFill>
-        </p:spPr>
-      </p:sp>
-      <p:sp>
-        <p:nvSpPr>
-          <p:cNvPr name="Freeform 12" id="12"/>
-          <p:cNvSpPr/>
-          <p:nvPr/>
-        </p:nvSpPr>
-        <p:spPr>
-          <a:xfrm flipH="false" flipV="false" rot="0">
-            <a:off x="12387619" y="5443408"/>
-            <a:ext cx="3914299" cy="2514937"/>
-          </a:xfrm>
-          <a:custGeom>
-            <a:avLst/>
-            <a:gdLst/>
-            <a:ahLst/>
-            <a:cxnLst/>
-            <a:rect r="r" b="b" t="t" l="l"/>
-            <a:pathLst>
-              <a:path h="2514937" w="3914299">
-                <a:moveTo>
-                  <a:pt x="0" y="0"/>
-                </a:moveTo>
-                <a:lnTo>
-                  <a:pt x="3914300" y="0"/>
-                </a:lnTo>
-                <a:lnTo>
-                  <a:pt x="3914300" y="2514937"/>
-                </a:lnTo>
-                <a:lnTo>
-                  <a:pt x="0" y="2514937"/>
-                </a:lnTo>
-                <a:lnTo>
-                  <a:pt x="0" y="0"/>
-                </a:lnTo>
-                <a:close/>
-              </a:path>
-            </a:pathLst>
-          </a:custGeom>
-          <a:blipFill>
-            <a:blip r:embed="rId7"/>
-            <a:stretch>
-              <a:fillRect l="0" t="0" r="0" b="0"/>
-            </a:stretch>
-          </a:blipFill>
-        </p:spPr>
-      </p:sp>
-      <p:sp>
-        <p:nvSpPr>
-          <p:cNvPr name="TextBox 13" id="13"/>
-          <p:cNvSpPr txBox="true"/>
-          <p:nvPr/>
-        </p:nvSpPr>
-        <p:spPr>
-          <a:xfrm rot="0">
-            <a:off x="2498467" y="2204835"/>
-            <a:ext cx="12459057" cy="531495"/>
-          </a:xfrm>
-          <a:prstGeom prst="rect">
-            <a:avLst/>
-          </a:prstGeom>
-        </p:spPr>
-        <p:txBody>
-          <a:bodyPr anchor="t" rtlCol="false" tIns="0" lIns="0" bIns="0" rIns="0">
-            <a:spAutoFit/>
-          </a:bodyPr>
-          <a:lstStyle/>
-          <a:p>
-            <a:pPr algn="l">
-              <a:lnSpc>
-                <a:spcPts val="4139"/>
-              </a:lnSpc>
-            </a:pPr>
-            <a:r>
-              <a:rPr lang="en-US" sz="2999" spc="293">
-                <a:solidFill>
-                  <a:srgbClr val="FFFFFF"/>
-                </a:solidFill>
-                <a:latin typeface="Poppins"/>
-                <a:ea typeface="Poppins"/>
-                <a:cs typeface="Poppins"/>
-                <a:sym typeface="Poppins"/>
-              </a:rPr>
-              <a:t>Consultar dashboard (métrica de uso del aplicativo)</a:t>
-            </a:r>
-          </a:p>
-        </p:txBody>
-      </p:sp>
-      <p:sp>
-        <p:nvSpPr>
-          <p:cNvPr name="TextBox 14" id="14"/>
-          <p:cNvSpPr txBox="true"/>
-          <p:nvPr/>
-        </p:nvSpPr>
-        <p:spPr>
-          <a:xfrm rot="0">
-            <a:off x="16852559" y="9658764"/>
-            <a:ext cx="152400" cy="200025"/>
-          </a:xfrm>
-          <a:prstGeom prst="rect">
-            <a:avLst/>
-          </a:prstGeom>
-        </p:spPr>
-        <p:txBody>
-          <a:bodyPr anchor="t" rtlCol="false" tIns="0" lIns="0" bIns="0" rIns="0" wrap="none">
-            <a:spAutoFit/>
-          </a:bodyPr>
-          <a:lstStyle/>
-          <a:p>
-            <a:pPr algn="ctr">
-              <a:lnSpc>
-                <a:spcPts val="2800"/>
-              </a:lnSpc>
-              <a:spcBef>
-                <a:spcPct val="0"/>
-              </a:spcBef>
-            </a:pPr>
-            <a:r>
-              <a:rPr lang="en-US" sz="2000">
-                <a:solidFill>
-                  <a:srgbClr val="FFFFFF"/>
-                </a:solidFill>
-                <a:latin typeface="Open Sans"/>
-                <a:ea typeface="Open Sans"/>
-                <a:cs typeface="Open Sans"/>
-                <a:sym typeface="Open Sans"/>
-              </a:rPr>
-              <a:t>Página 10</a:t>
-            </a:r>
-          </a:p>
-        </p:txBody>
-      </p:sp>
-    </p:spTree>
-  </p:cSld>
-  <p:clrMapOvr>
-    <a:masterClrMapping/>
-  </p:clrMapOvr>
-</p:sld>
-</file>
-
-<file path=ppt/slides/slide11.xml><?xml version="1.0" encoding="utf-8"?>
-<p:sld xmlns:p="http://schemas.openxmlformats.org/presentationml/2006/main" xmlns:a="http://schemas.openxmlformats.org/drawingml/2006/main" xmlns:r="http://schemas.openxmlformats.org/officeDocument/2006/relationships">
-  <p:cSld>
-    <p:bg>
-      <p:bgPr>
-        <a:solidFill>
-          <a:srgbClr val="344F51"/>
-        </a:solidFill>
-      </p:bgPr>
-    </p:bg>
-    <p:spTree>
-      <p:nvGrpSpPr>
-        <p:cNvPr id="1" name=""/>
-        <p:cNvGrpSpPr/>
-        <p:nvPr/>
-      </p:nvGrpSpPr>
-      <p:grpSpPr>
-        <a:xfrm>
-          <a:off x="0" y="0"/>
-          <a:ext cx="0" cy="0"/>
-          <a:chOff x="0" y="0"/>
-          <a:chExt cx="0" cy="0"/>
-        </a:xfrm>
-      </p:grpSpPr>
-      <p:grpSp>
-        <p:nvGrpSpPr>
-          <p:cNvPr name="Group 2" id="2"/>
-          <p:cNvGrpSpPr/>
-          <p:nvPr/>
-        </p:nvGrpSpPr>
-        <p:grpSpPr>
-          <a:xfrm rot="0">
-            <a:off x="12085550" y="-131220"/>
-            <a:ext cx="9534019" cy="1112295"/>
-            <a:chOff x="0" y="0"/>
-            <a:chExt cx="1876002" cy="218865"/>
-          </a:xfrm>
-        </p:grpSpPr>
-        <p:sp>
-          <p:nvSpPr>
-            <p:cNvPr name="Freeform 3" id="3"/>
-            <p:cNvSpPr/>
-            <p:nvPr/>
-          </p:nvSpPr>
-          <p:spPr>
-            <a:xfrm flipH="false" flipV="false" rot="0">
-              <a:off x="0" y="0"/>
-              <a:ext cx="1876002" cy="218865"/>
-            </a:xfrm>
-            <a:custGeom>
-              <a:avLst/>
-              <a:gdLst/>
-              <a:ahLst/>
-              <a:cxnLst/>
-              <a:rect r="r" b="b" t="t" l="l"/>
-              <a:pathLst>
-                <a:path h="218865" w="1876002">
-                  <a:moveTo>
-                    <a:pt x="1672802" y="0"/>
-                  </a:moveTo>
-                  <a:lnTo>
-                    <a:pt x="0" y="0"/>
-                  </a:lnTo>
-                  <a:lnTo>
-                    <a:pt x="203200" y="218865"/>
-                  </a:lnTo>
-                  <a:lnTo>
-                    <a:pt x="1876002" y="218865"/>
-                  </a:lnTo>
-                  <a:lnTo>
-                    <a:pt x="1672802" y="0"/>
-                  </a:lnTo>
-                  <a:close/>
-                </a:path>
-              </a:pathLst>
-            </a:custGeom>
-            <a:solidFill>
-              <a:srgbClr val="51786E"/>
-            </a:solidFill>
-            <a:ln cap="sq">
-              <a:noFill/>
-              <a:prstDash val="solid"/>
-              <a:miter/>
-            </a:ln>
-          </p:spPr>
-        </p:sp>
-        <p:sp>
-          <p:nvSpPr>
-            <p:cNvPr name="TextBox 4" id="4"/>
-            <p:cNvSpPr txBox="true"/>
-            <p:nvPr/>
-          </p:nvSpPr>
-          <p:spPr>
-            <a:xfrm>
-              <a:off x="101600" y="-19050"/>
-              <a:ext cx="1672802" cy="237915"/>
-            </a:xfrm>
-            <a:prstGeom prst="rect">
-              <a:avLst/>
-            </a:prstGeom>
-          </p:spPr>
-          <p:txBody>
-            <a:bodyPr anchor="ctr" rtlCol="false" tIns="50800" lIns="50800" bIns="50800" rIns="50800"/>
-            <a:lstStyle/>
-            <a:p>
-              <a:pPr algn="ctr" marL="0" indent="0" lvl="0">
-                <a:lnSpc>
-                  <a:spcPts val="2859"/>
-                </a:lnSpc>
-                <a:spcBef>
-                  <a:spcPct val="0"/>
-                </a:spcBef>
-              </a:pPr>
-            </a:p>
-          </p:txBody>
-        </p:sp>
-      </p:grpSp>
-      <p:grpSp>
-        <p:nvGrpSpPr>
-          <p:cNvPr name="Group 5" id="5"/>
-          <p:cNvGrpSpPr/>
-          <p:nvPr/>
-        </p:nvGrpSpPr>
-        <p:grpSpPr>
-          <a:xfrm rot="0">
-            <a:off x="4852707" y="981075"/>
+            <a:off x="5283879" y="1315484"/>
             <a:ext cx="6499611" cy="810936"/>
             <a:chOff x="0" y="0"/>
             <a:chExt cx="1511227" cy="188551"/>
@@ -4421,8 +3829,8 @@
         </p:nvSpPr>
         <p:spPr>
           <a:xfrm flipH="false" flipV="false" rot="0">
-            <a:off x="3268237" y="4361642"/>
-            <a:ext cx="3745142" cy="4896658"/>
+            <a:off x="3951697" y="4491266"/>
+            <a:ext cx="4427498" cy="4893648"/>
           </a:xfrm>
           <a:custGeom>
             <a:avLst/>
@@ -4431,18 +3839,18 @@
             <a:cxnLst/>
             <a:rect r="r" b="b" t="t" l="l"/>
             <a:pathLst>
-              <a:path h="4896658" w="3745142">
+              <a:path h="4893648" w="4427498">
                 <a:moveTo>
                   <a:pt x="0" y="0"/>
                 </a:moveTo>
                 <a:lnTo>
-                  <a:pt x="3745142" y="0"/>
-                </a:lnTo>
-                <a:lnTo>
-                  <a:pt x="3745142" y="4896658"/>
-                </a:lnTo>
-                <a:lnTo>
-                  <a:pt x="0" y="4896658"/>
+                  <a:pt x="4427499" y="0"/>
+                </a:lnTo>
+                <a:lnTo>
+                  <a:pt x="4427499" y="4893648"/>
+                </a:lnTo>
+                <a:lnTo>
+                  <a:pt x="0" y="4893648"/>
                 </a:lnTo>
                 <a:lnTo>
                   <a:pt x="0" y="0"/>
@@ -4454,7 +3862,7 @@
           <a:blipFill>
             <a:blip r:embed="rId2"/>
             <a:stretch>
-              <a:fillRect l="-3663" t="-5342" r="0" b="0"/>
+              <a:fillRect l="-3663" t="-6319" r="0" b="-18292"/>
             </a:stretch>
           </a:blipFill>
         </p:spPr>
@@ -4467,8 +3875,8 @@
         </p:nvSpPr>
         <p:spPr>
           <a:xfrm flipH="false" flipV="false" rot="0">
-            <a:off x="973941" y="5943706"/>
-            <a:ext cx="1732321" cy="1732531"/>
+            <a:off x="1694915" y="5941099"/>
+            <a:ext cx="1779097" cy="1779312"/>
           </a:xfrm>
           <a:custGeom>
             <a:avLst/>
@@ -4477,18 +3885,18 @@
             <a:cxnLst/>
             <a:rect r="r" b="b" t="t" l="l"/>
             <a:pathLst>
-              <a:path h="1732531" w="1732321">
+              <a:path h="1779312" w="1779097">
                 <a:moveTo>
                   <a:pt x="0" y="0"/>
                 </a:moveTo>
                 <a:lnTo>
-                  <a:pt x="1732321" y="0"/>
-                </a:lnTo>
-                <a:lnTo>
-                  <a:pt x="1732321" y="1732530"/>
-                </a:lnTo>
-                <a:lnTo>
-                  <a:pt x="0" y="1732530"/>
+                  <a:pt x="1779096" y="0"/>
+                </a:lnTo>
+                <a:lnTo>
+                  <a:pt x="1779096" y="1779312"/>
+                </a:lnTo>
+                <a:lnTo>
+                  <a:pt x="0" y="1779312"/>
                 </a:lnTo>
                 <a:lnTo>
                   <a:pt x="0" y="0"/>
@@ -4513,8 +3921,8 @@
         </p:nvSpPr>
         <p:spPr>
           <a:xfrm flipH="false" flipV="false" rot="0">
-            <a:off x="12384693" y="4452445"/>
-            <a:ext cx="3089437" cy="4805855"/>
+            <a:off x="11575651" y="4409572"/>
+            <a:ext cx="3942704" cy="5287740"/>
           </a:xfrm>
           <a:custGeom>
             <a:avLst/>
@@ -4523,18 +3931,18 @@
             <a:cxnLst/>
             <a:rect r="r" b="b" t="t" l="l"/>
             <a:pathLst>
-              <a:path h="4805855" w="3089437">
+              <a:path h="5287740" w="3942704">
                 <a:moveTo>
                   <a:pt x="0" y="0"/>
                 </a:moveTo>
                 <a:lnTo>
-                  <a:pt x="3089437" y="0"/>
-                </a:lnTo>
-                <a:lnTo>
-                  <a:pt x="3089437" y="4805855"/>
-                </a:lnTo>
-                <a:lnTo>
-                  <a:pt x="0" y="4805855"/>
+                  <a:pt x="3942704" y="0"/>
+                </a:lnTo>
+                <a:lnTo>
+                  <a:pt x="3942704" y="5287739"/>
+                </a:lnTo>
+                <a:lnTo>
+                  <a:pt x="0" y="5287739"/>
                 </a:lnTo>
                 <a:lnTo>
                   <a:pt x="0" y="0"/>
@@ -4546,7 +3954,7 @@
           <a:blipFill>
             <a:blip r:embed="rId4"/>
             <a:stretch>
-              <a:fillRect l="-2708" t="0" r="-2708" b="0"/>
+              <a:fillRect l="-2708" t="0" r="-2708" b="-15988"/>
             </a:stretch>
           </a:blipFill>
         </p:spPr>
@@ -4559,8 +3967,8 @@
         </p:nvSpPr>
         <p:spPr>
           <a:xfrm flipH="false" flipV="false" rot="0">
-            <a:off x="10308081" y="5943706"/>
-            <a:ext cx="1514637" cy="1732531"/>
+            <a:off x="9444931" y="5941099"/>
+            <a:ext cx="1555535" cy="1779312"/>
           </a:xfrm>
           <a:custGeom>
             <a:avLst/>
@@ -4569,18 +3977,18 @@
             <a:cxnLst/>
             <a:rect r="r" b="b" t="t" l="l"/>
             <a:pathLst>
-              <a:path h="1732531" w="1514637">
+              <a:path h="1779312" w="1555535">
                 <a:moveTo>
                   <a:pt x="0" y="0"/>
                 </a:moveTo>
                 <a:lnTo>
-                  <a:pt x="1514637" y="0"/>
-                </a:lnTo>
-                <a:lnTo>
-                  <a:pt x="1514637" y="1732530"/>
-                </a:lnTo>
-                <a:lnTo>
-                  <a:pt x="0" y="1732530"/>
+                  <a:pt x="1555535" y="0"/>
+                </a:lnTo>
+                <a:lnTo>
+                  <a:pt x="1555535" y="1779312"/>
+                </a:lnTo>
+                <a:lnTo>
+                  <a:pt x="0" y="1779312"/>
                 </a:lnTo>
                 <a:lnTo>
                   <a:pt x="0" y="0"/>
@@ -4605,8 +4013,8 @@
         </p:nvSpPr>
         <p:spPr>
           <a:xfrm rot="0">
-            <a:off x="1169414" y="3084858"/>
-            <a:ext cx="7510957" cy="1055370"/>
+            <a:off x="1694915" y="3157556"/>
+            <a:ext cx="6838770" cy="967740"/>
           </a:xfrm>
           <a:prstGeom prst="rect">
             <a:avLst/>
@@ -4620,11 +4028,11 @@
           <a:p>
             <a:pPr algn="l">
               <a:lnSpc>
-                <a:spcPts val="4139"/>
+                <a:spcPts val="3769"/>
               </a:lnSpc>
             </a:pPr>
             <a:r>
-              <a:rPr lang="en-US" sz="2999" spc="293">
+              <a:rPr lang="en-US" sz="2731" spc="267">
                 <a:solidFill>
                   <a:srgbClr val="FFFFFF"/>
                 </a:solidFill>
@@ -4646,8 +4054,8 @@
         </p:nvSpPr>
         <p:spPr>
           <a:xfrm rot="0">
-            <a:off x="9733108" y="3084858"/>
-            <a:ext cx="8047518" cy="1055370"/>
+            <a:off x="8736787" y="3157556"/>
+            <a:ext cx="7327313" cy="967740"/>
           </a:xfrm>
           <a:prstGeom prst="rect">
             <a:avLst/>
@@ -4661,11 +4069,11 @@
           <a:p>
             <a:pPr algn="l">
               <a:lnSpc>
-                <a:spcPts val="4139"/>
+                <a:spcPts val="3769"/>
               </a:lnSpc>
             </a:pPr>
             <a:r>
-              <a:rPr lang="en-US" sz="2999" spc="293">
+              <a:rPr lang="en-US" sz="2731" spc="267">
                 <a:solidFill>
                   <a:srgbClr val="FFFFFF"/>
                 </a:solidFill>
@@ -4718,7 +4126,7 @@
                 <a:cs typeface="Open Sans"/>
                 <a:sym typeface="Open Sans"/>
               </a:rPr>
-              <a:t>Página 11</a:t>
+              <a:t>Página 10</a:t>
             </a:r>
           </a:p>
         </p:txBody>
@@ -4731,7 +4139,7 @@
 </p:sld>
 </file>
 
-<file path=ppt/slides/slide12.xml><?xml version="1.0" encoding="utf-8"?>
+<file path=ppt/slides/slide11.xml><?xml version="1.0" encoding="utf-8"?>
 <p:sld xmlns:p="http://schemas.openxmlformats.org/presentationml/2006/main" xmlns:a="http://schemas.openxmlformats.org/drawingml/2006/main" xmlns:r="http://schemas.openxmlformats.org/officeDocument/2006/relationships">
   <p:cSld>
     <p:bg>
@@ -6301,7 +5709,7 @@
                 <a:cs typeface="Open Sans"/>
                 <a:sym typeface="Open Sans"/>
               </a:rPr>
-              <a:t>Página 12</a:t>
+              <a:t>Página 11</a:t>
             </a:r>
           </a:p>
         </p:txBody>
@@ -6314,1454 +5722,7 @@
 </p:sld>
 </file>
 
-<file path=ppt/slides/slide13.xml><?xml version="1.0" encoding="utf-8"?>
-<p:sld xmlns:p="http://schemas.openxmlformats.org/presentationml/2006/main" xmlns:a="http://schemas.openxmlformats.org/drawingml/2006/main" xmlns:r="http://schemas.openxmlformats.org/officeDocument/2006/relationships">
-  <p:cSld>
-    <p:bg>
-      <p:bgPr>
-        <a:solidFill>
-          <a:srgbClr val="344F51"/>
-        </a:solidFill>
-      </p:bgPr>
-    </p:bg>
-    <p:spTree>
-      <p:nvGrpSpPr>
-        <p:cNvPr id="1" name=""/>
-        <p:cNvGrpSpPr/>
-        <p:nvPr/>
-      </p:nvGrpSpPr>
-      <p:grpSpPr>
-        <a:xfrm>
-          <a:off x="0" y="0"/>
-          <a:ext cx="0" cy="0"/>
-          <a:chOff x="0" y="0"/>
-          <a:chExt cx="0" cy="0"/>
-        </a:xfrm>
-      </p:grpSpPr>
-      <p:grpSp>
-        <p:nvGrpSpPr>
-          <p:cNvPr name="Group 2" id="2"/>
-          <p:cNvGrpSpPr/>
-          <p:nvPr/>
-        </p:nvGrpSpPr>
-        <p:grpSpPr>
-          <a:xfrm rot="0">
-            <a:off x="642505" y="2544721"/>
-            <a:ext cx="4668130" cy="5341511"/>
-            <a:chOff x="0" y="0"/>
-            <a:chExt cx="1428497" cy="1634559"/>
-          </a:xfrm>
-        </p:grpSpPr>
-        <p:sp>
-          <p:nvSpPr>
-            <p:cNvPr name="Freeform 3" id="3"/>
-            <p:cNvSpPr/>
-            <p:nvPr/>
-          </p:nvSpPr>
-          <p:spPr>
-            <a:xfrm flipH="false" flipV="false" rot="0">
-              <a:off x="0" y="0"/>
-              <a:ext cx="1428497" cy="1634559"/>
-            </a:xfrm>
-            <a:custGeom>
-              <a:avLst/>
-              <a:gdLst/>
-              <a:ahLst/>
-              <a:cxnLst/>
-              <a:rect r="r" b="b" t="t" l="l"/>
-              <a:pathLst>
-                <a:path h="1634559" w="1428497">
-                  <a:moveTo>
-                    <a:pt x="33169" y="0"/>
-                  </a:moveTo>
-                  <a:lnTo>
-                    <a:pt x="1395328" y="0"/>
-                  </a:lnTo>
-                  <a:cubicBezTo>
-                    <a:pt x="1413647" y="0"/>
-                    <a:pt x="1428497" y="14850"/>
-                    <a:pt x="1428497" y="33169"/>
-                  </a:cubicBezTo>
-                  <a:lnTo>
-                    <a:pt x="1428497" y="1601390"/>
-                  </a:lnTo>
-                  <a:cubicBezTo>
-                    <a:pt x="1428497" y="1610187"/>
-                    <a:pt x="1425003" y="1618624"/>
-                    <a:pt x="1418782" y="1624844"/>
-                  </a:cubicBezTo>
-                  <a:cubicBezTo>
-                    <a:pt x="1412562" y="1631065"/>
-                    <a:pt x="1404125" y="1634559"/>
-                    <a:pt x="1395328" y="1634559"/>
-                  </a:cubicBezTo>
-                  <a:lnTo>
-                    <a:pt x="33169" y="1634559"/>
-                  </a:lnTo>
-                  <a:cubicBezTo>
-                    <a:pt x="14850" y="1634559"/>
-                    <a:pt x="0" y="1619709"/>
-                    <a:pt x="0" y="1601390"/>
-                  </a:cubicBezTo>
-                  <a:lnTo>
-                    <a:pt x="0" y="33169"/>
-                  </a:lnTo>
-                  <a:cubicBezTo>
-                    <a:pt x="0" y="14850"/>
-                    <a:pt x="14850" y="0"/>
-                    <a:pt x="33169" y="0"/>
-                  </a:cubicBezTo>
-                  <a:close/>
-                </a:path>
-              </a:pathLst>
-            </a:custGeom>
-            <a:solidFill>
-              <a:srgbClr val="FFFFFF"/>
-            </a:solidFill>
-            <a:ln w="38100" cap="sq">
-              <a:solidFill>
-                <a:srgbClr val="363636"/>
-              </a:solidFill>
-              <a:prstDash val="solid"/>
-              <a:miter/>
-            </a:ln>
-          </p:spPr>
-        </p:sp>
-        <p:sp>
-          <p:nvSpPr>
-            <p:cNvPr name="TextBox 4" id="4"/>
-            <p:cNvSpPr txBox="true"/>
-            <p:nvPr/>
-          </p:nvSpPr>
-          <p:spPr>
-            <a:xfrm>
-              <a:off x="0" y="-19050"/>
-              <a:ext cx="1428497" cy="1653609"/>
-            </a:xfrm>
-            <a:prstGeom prst="rect">
-              <a:avLst/>
-            </a:prstGeom>
-          </p:spPr>
-          <p:txBody>
-            <a:bodyPr anchor="ctr" rtlCol="false" tIns="50800" lIns="50800" bIns="50800" rIns="50800"/>
-            <a:lstStyle/>
-            <a:p>
-              <a:pPr algn="ctr">
-                <a:lnSpc>
-                  <a:spcPts val="2859"/>
-                </a:lnSpc>
-              </a:pPr>
-            </a:p>
-          </p:txBody>
-        </p:sp>
-      </p:grpSp>
-      <p:grpSp>
-        <p:nvGrpSpPr>
-          <p:cNvPr name="Group 5" id="5"/>
-          <p:cNvGrpSpPr/>
-          <p:nvPr/>
-        </p:nvGrpSpPr>
-        <p:grpSpPr>
-          <a:xfrm rot="0">
-            <a:off x="5625431" y="2544721"/>
-            <a:ext cx="4668130" cy="5341511"/>
-            <a:chOff x="0" y="0"/>
-            <a:chExt cx="1428497" cy="1634559"/>
-          </a:xfrm>
-        </p:grpSpPr>
-        <p:sp>
-          <p:nvSpPr>
-            <p:cNvPr name="Freeform 6" id="6"/>
-            <p:cNvSpPr/>
-            <p:nvPr/>
-          </p:nvSpPr>
-          <p:spPr>
-            <a:xfrm flipH="false" flipV="false" rot="0">
-              <a:off x="0" y="0"/>
-              <a:ext cx="1428497" cy="1634559"/>
-            </a:xfrm>
-            <a:custGeom>
-              <a:avLst/>
-              <a:gdLst/>
-              <a:ahLst/>
-              <a:cxnLst/>
-              <a:rect r="r" b="b" t="t" l="l"/>
-              <a:pathLst>
-                <a:path h="1634559" w="1428497">
-                  <a:moveTo>
-                    <a:pt x="33169" y="0"/>
-                  </a:moveTo>
-                  <a:lnTo>
-                    <a:pt x="1395328" y="0"/>
-                  </a:lnTo>
-                  <a:cubicBezTo>
-                    <a:pt x="1413647" y="0"/>
-                    <a:pt x="1428497" y="14850"/>
-                    <a:pt x="1428497" y="33169"/>
-                  </a:cubicBezTo>
-                  <a:lnTo>
-                    <a:pt x="1428497" y="1601390"/>
-                  </a:lnTo>
-                  <a:cubicBezTo>
-                    <a:pt x="1428497" y="1610187"/>
-                    <a:pt x="1425003" y="1618624"/>
-                    <a:pt x="1418782" y="1624844"/>
-                  </a:cubicBezTo>
-                  <a:cubicBezTo>
-                    <a:pt x="1412562" y="1631065"/>
-                    <a:pt x="1404125" y="1634559"/>
-                    <a:pt x="1395328" y="1634559"/>
-                  </a:cubicBezTo>
-                  <a:lnTo>
-                    <a:pt x="33169" y="1634559"/>
-                  </a:lnTo>
-                  <a:cubicBezTo>
-                    <a:pt x="14850" y="1634559"/>
-                    <a:pt x="0" y="1619709"/>
-                    <a:pt x="0" y="1601390"/>
-                  </a:cubicBezTo>
-                  <a:lnTo>
-                    <a:pt x="0" y="33169"/>
-                  </a:lnTo>
-                  <a:cubicBezTo>
-                    <a:pt x="0" y="14850"/>
-                    <a:pt x="14850" y="0"/>
-                    <a:pt x="33169" y="0"/>
-                  </a:cubicBezTo>
-                  <a:close/>
-                </a:path>
-              </a:pathLst>
-            </a:custGeom>
-            <a:solidFill>
-              <a:srgbClr val="FFFFFF"/>
-            </a:solidFill>
-            <a:ln w="38100" cap="sq">
-              <a:solidFill>
-                <a:srgbClr val="363636"/>
-              </a:solidFill>
-              <a:prstDash val="solid"/>
-              <a:miter/>
-            </a:ln>
-          </p:spPr>
-        </p:sp>
-        <p:sp>
-          <p:nvSpPr>
-            <p:cNvPr name="TextBox 7" id="7"/>
-            <p:cNvSpPr txBox="true"/>
-            <p:nvPr/>
-          </p:nvSpPr>
-          <p:spPr>
-            <a:xfrm>
-              <a:off x="0" y="-19050"/>
-              <a:ext cx="1428497" cy="1653609"/>
-            </a:xfrm>
-            <a:prstGeom prst="rect">
-              <a:avLst/>
-            </a:prstGeom>
-          </p:spPr>
-          <p:txBody>
-            <a:bodyPr anchor="ctr" rtlCol="false" tIns="50800" lIns="50800" bIns="50800" rIns="50800"/>
-            <a:lstStyle/>
-            <a:p>
-              <a:pPr algn="ctr">
-                <a:lnSpc>
-                  <a:spcPts val="2859"/>
-                </a:lnSpc>
-              </a:pPr>
-            </a:p>
-          </p:txBody>
-        </p:sp>
-      </p:grpSp>
-      <p:grpSp>
-        <p:nvGrpSpPr>
-          <p:cNvPr name="Group 8" id="8"/>
-          <p:cNvGrpSpPr/>
-          <p:nvPr/>
-        </p:nvGrpSpPr>
-        <p:grpSpPr>
-          <a:xfrm rot="0">
-            <a:off x="10751945" y="2544721"/>
-            <a:ext cx="4668130" cy="5341511"/>
-            <a:chOff x="0" y="0"/>
-            <a:chExt cx="1428497" cy="1634559"/>
-          </a:xfrm>
-        </p:grpSpPr>
-        <p:sp>
-          <p:nvSpPr>
-            <p:cNvPr name="Freeform 9" id="9"/>
-            <p:cNvSpPr/>
-            <p:nvPr/>
-          </p:nvSpPr>
-          <p:spPr>
-            <a:xfrm flipH="false" flipV="false" rot="0">
-              <a:off x="0" y="0"/>
-              <a:ext cx="1428497" cy="1634559"/>
-            </a:xfrm>
-            <a:custGeom>
-              <a:avLst/>
-              <a:gdLst/>
-              <a:ahLst/>
-              <a:cxnLst/>
-              <a:rect r="r" b="b" t="t" l="l"/>
-              <a:pathLst>
-                <a:path h="1634559" w="1428497">
-                  <a:moveTo>
-                    <a:pt x="33169" y="0"/>
-                  </a:moveTo>
-                  <a:lnTo>
-                    <a:pt x="1395328" y="0"/>
-                  </a:lnTo>
-                  <a:cubicBezTo>
-                    <a:pt x="1413647" y="0"/>
-                    <a:pt x="1428497" y="14850"/>
-                    <a:pt x="1428497" y="33169"/>
-                  </a:cubicBezTo>
-                  <a:lnTo>
-                    <a:pt x="1428497" y="1601390"/>
-                  </a:lnTo>
-                  <a:cubicBezTo>
-                    <a:pt x="1428497" y="1610187"/>
-                    <a:pt x="1425003" y="1618624"/>
-                    <a:pt x="1418782" y="1624844"/>
-                  </a:cubicBezTo>
-                  <a:cubicBezTo>
-                    <a:pt x="1412562" y="1631065"/>
-                    <a:pt x="1404125" y="1634559"/>
-                    <a:pt x="1395328" y="1634559"/>
-                  </a:cubicBezTo>
-                  <a:lnTo>
-                    <a:pt x="33169" y="1634559"/>
-                  </a:lnTo>
-                  <a:cubicBezTo>
-                    <a:pt x="14850" y="1634559"/>
-                    <a:pt x="0" y="1619709"/>
-                    <a:pt x="0" y="1601390"/>
-                  </a:cubicBezTo>
-                  <a:lnTo>
-                    <a:pt x="0" y="33169"/>
-                  </a:lnTo>
-                  <a:cubicBezTo>
-                    <a:pt x="0" y="14850"/>
-                    <a:pt x="14850" y="0"/>
-                    <a:pt x="33169" y="0"/>
-                  </a:cubicBezTo>
-                  <a:close/>
-                </a:path>
-              </a:pathLst>
-            </a:custGeom>
-            <a:solidFill>
-              <a:srgbClr val="FFFFFF"/>
-            </a:solidFill>
-            <a:ln w="38100" cap="sq">
-              <a:solidFill>
-                <a:srgbClr val="363636"/>
-              </a:solidFill>
-              <a:prstDash val="solid"/>
-              <a:miter/>
-            </a:ln>
-          </p:spPr>
-        </p:sp>
-        <p:sp>
-          <p:nvSpPr>
-            <p:cNvPr name="TextBox 10" id="10"/>
-            <p:cNvSpPr txBox="true"/>
-            <p:nvPr/>
-          </p:nvSpPr>
-          <p:spPr>
-            <a:xfrm>
-              <a:off x="0" y="-19050"/>
-              <a:ext cx="1428497" cy="1653609"/>
-            </a:xfrm>
-            <a:prstGeom prst="rect">
-              <a:avLst/>
-            </a:prstGeom>
-          </p:spPr>
-          <p:txBody>
-            <a:bodyPr anchor="ctr" rtlCol="false" tIns="50800" lIns="50800" bIns="50800" rIns="50800"/>
-            <a:lstStyle/>
-            <a:p>
-              <a:pPr algn="ctr">
-                <a:lnSpc>
-                  <a:spcPts val="2859"/>
-                </a:lnSpc>
-              </a:pPr>
-            </a:p>
-          </p:txBody>
-        </p:sp>
-      </p:grpSp>
-      <p:sp>
-        <p:nvSpPr>
-          <p:cNvPr name="Freeform 11" id="11"/>
-          <p:cNvSpPr/>
-          <p:nvPr/>
-        </p:nvSpPr>
-        <p:spPr>
-          <a:xfrm flipH="false" flipV="false" rot="0">
-            <a:off x="2610870" y="2795568"/>
-            <a:ext cx="1078897" cy="1596328"/>
-          </a:xfrm>
-          <a:custGeom>
-            <a:avLst/>
-            <a:gdLst/>
-            <a:ahLst/>
-            <a:cxnLst/>
-            <a:rect r="r" b="b" t="t" l="l"/>
-            <a:pathLst>
-              <a:path h="1596328" w="1078897">
-                <a:moveTo>
-                  <a:pt x="0" y="0"/>
-                </a:moveTo>
-                <a:lnTo>
-                  <a:pt x="1078897" y="0"/>
-                </a:lnTo>
-                <a:lnTo>
-                  <a:pt x="1078897" y="1596328"/>
-                </a:lnTo>
-                <a:lnTo>
-                  <a:pt x="0" y="1596328"/>
-                </a:lnTo>
-                <a:lnTo>
-                  <a:pt x="0" y="0"/>
-                </a:lnTo>
-                <a:close/>
-              </a:path>
-            </a:pathLst>
-          </a:custGeom>
-          <a:blipFill>
-            <a:blip r:embed="rId2">
-              <a:extLst>
-                <a:ext uri="{96DAC541-7B7A-43D3-8B79-37D633B846F1}">
-                  <asvg:svgBlip xmlns:asvg="http://schemas.microsoft.com/office/drawing/2016/SVG/main" r:embed="rId3"/>
-                </a:ext>
-              </a:extLst>
-            </a:blip>
-            <a:stretch>
-              <a:fillRect l="0" t="0" r="0" b="0"/>
-            </a:stretch>
-          </a:blipFill>
-        </p:spPr>
-      </p:sp>
-      <p:sp>
-        <p:nvSpPr>
-          <p:cNvPr name="Freeform 12" id="12"/>
-          <p:cNvSpPr/>
-          <p:nvPr/>
-        </p:nvSpPr>
-        <p:spPr>
-          <a:xfrm flipH="false" flipV="false" rot="0">
-            <a:off x="1218173" y="4781415"/>
-            <a:ext cx="1336683" cy="1336683"/>
-          </a:xfrm>
-          <a:custGeom>
-            <a:avLst/>
-            <a:gdLst/>
-            <a:ahLst/>
-            <a:cxnLst/>
-            <a:rect r="r" b="b" t="t" l="l"/>
-            <a:pathLst>
-              <a:path h="1336683" w="1336683">
-                <a:moveTo>
-                  <a:pt x="0" y="0"/>
-                </a:moveTo>
-                <a:lnTo>
-                  <a:pt x="1336682" y="0"/>
-                </a:lnTo>
-                <a:lnTo>
-                  <a:pt x="1336682" y="1336682"/>
-                </a:lnTo>
-                <a:lnTo>
-                  <a:pt x="0" y="1336682"/>
-                </a:lnTo>
-                <a:lnTo>
-                  <a:pt x="0" y="0"/>
-                </a:lnTo>
-                <a:close/>
-              </a:path>
-            </a:pathLst>
-          </a:custGeom>
-          <a:blipFill>
-            <a:blip r:embed="rId4">
-              <a:extLst>
-                <a:ext uri="{96DAC541-7B7A-43D3-8B79-37D633B846F1}">
-                  <asvg:svgBlip xmlns:asvg="http://schemas.microsoft.com/office/drawing/2016/SVG/main" r:embed="rId5"/>
-                </a:ext>
-              </a:extLst>
-            </a:blip>
-            <a:stretch>
-              <a:fillRect l="0" t="0" r="0" b="0"/>
-            </a:stretch>
-          </a:blipFill>
-        </p:spPr>
-      </p:sp>
-      <p:sp>
-        <p:nvSpPr>
-          <p:cNvPr name="Freeform 13" id="13"/>
-          <p:cNvSpPr/>
-          <p:nvPr/>
-        </p:nvSpPr>
-        <p:spPr>
-          <a:xfrm flipH="false" flipV="false" rot="0">
-            <a:off x="1162158" y="6269029"/>
-            <a:ext cx="1448711" cy="1298572"/>
-          </a:xfrm>
-          <a:custGeom>
-            <a:avLst/>
-            <a:gdLst/>
-            <a:ahLst/>
-            <a:cxnLst/>
-            <a:rect r="r" b="b" t="t" l="l"/>
-            <a:pathLst>
-              <a:path h="1298572" w="1448711">
-                <a:moveTo>
-                  <a:pt x="0" y="0"/>
-                </a:moveTo>
-                <a:lnTo>
-                  <a:pt x="1448712" y="0"/>
-                </a:lnTo>
-                <a:lnTo>
-                  <a:pt x="1448712" y="1298572"/>
-                </a:lnTo>
-                <a:lnTo>
-                  <a:pt x="0" y="1298572"/>
-                </a:lnTo>
-                <a:lnTo>
-                  <a:pt x="0" y="0"/>
-                </a:lnTo>
-                <a:close/>
-              </a:path>
-            </a:pathLst>
-          </a:custGeom>
-          <a:blipFill>
-            <a:blip r:embed="rId6"/>
-            <a:stretch>
-              <a:fillRect l="0" t="0" r="0" b="0"/>
-            </a:stretch>
-          </a:blipFill>
-        </p:spPr>
-      </p:sp>
-      <p:sp>
-        <p:nvSpPr>
-          <p:cNvPr name="Freeform 14" id="14"/>
-          <p:cNvSpPr/>
-          <p:nvPr/>
-        </p:nvSpPr>
-        <p:spPr>
-          <a:xfrm flipH="false" flipV="false" rot="0">
-            <a:off x="3831802" y="5449756"/>
-            <a:ext cx="1075134" cy="940254"/>
-          </a:xfrm>
-          <a:custGeom>
-            <a:avLst/>
-            <a:gdLst/>
-            <a:ahLst/>
-            <a:cxnLst/>
-            <a:rect r="r" b="b" t="t" l="l"/>
-            <a:pathLst>
-              <a:path h="940254" w="1075134">
-                <a:moveTo>
-                  <a:pt x="0" y="0"/>
-                </a:moveTo>
-                <a:lnTo>
-                  <a:pt x="1075134" y="0"/>
-                </a:lnTo>
-                <a:lnTo>
-                  <a:pt x="1075134" y="940254"/>
-                </a:lnTo>
-                <a:lnTo>
-                  <a:pt x="0" y="940254"/>
-                </a:lnTo>
-                <a:lnTo>
-                  <a:pt x="0" y="0"/>
-                </a:lnTo>
-                <a:close/>
-              </a:path>
-            </a:pathLst>
-          </a:custGeom>
-          <a:blipFill>
-            <a:blip r:embed="rId7">
-              <a:extLst>
-                <a:ext uri="{96DAC541-7B7A-43D3-8B79-37D633B846F1}">
-                  <asvg:svgBlip xmlns:asvg="http://schemas.microsoft.com/office/drawing/2016/SVG/main" r:embed="rId8"/>
-                </a:ext>
-              </a:extLst>
-            </a:blip>
-            <a:stretch>
-              <a:fillRect l="0" t="0" r="0" b="0"/>
-            </a:stretch>
-          </a:blipFill>
-        </p:spPr>
-      </p:sp>
-      <p:sp>
-        <p:nvSpPr>
-          <p:cNvPr name="Freeform 15" id="15"/>
-          <p:cNvSpPr/>
-          <p:nvPr/>
-        </p:nvSpPr>
-        <p:spPr>
-          <a:xfrm flipH="false" flipV="false" rot="1827227">
-            <a:off x="2937183" y="5252586"/>
-            <a:ext cx="936949" cy="674603"/>
-          </a:xfrm>
-          <a:custGeom>
-            <a:avLst/>
-            <a:gdLst/>
-            <a:ahLst/>
-            <a:cxnLst/>
-            <a:rect r="r" b="b" t="t" l="l"/>
-            <a:pathLst>
-              <a:path h="674603" w="936949">
-                <a:moveTo>
-                  <a:pt x="0" y="0"/>
-                </a:moveTo>
-                <a:lnTo>
-                  <a:pt x="936949" y="0"/>
-                </a:lnTo>
-                <a:lnTo>
-                  <a:pt x="936949" y="674603"/>
-                </a:lnTo>
-                <a:lnTo>
-                  <a:pt x="0" y="674603"/>
-                </a:lnTo>
-                <a:lnTo>
-                  <a:pt x="0" y="0"/>
-                </a:lnTo>
-                <a:close/>
-              </a:path>
-            </a:pathLst>
-          </a:custGeom>
-          <a:blipFill>
-            <a:blip r:embed="rId9">
-              <a:extLst>
-                <a:ext uri="{96DAC541-7B7A-43D3-8B79-37D633B846F1}">
-                  <asvg:svgBlip xmlns:asvg="http://schemas.microsoft.com/office/drawing/2016/SVG/main" r:embed="rId10"/>
-                </a:ext>
-              </a:extLst>
-            </a:blip>
-            <a:stretch>
-              <a:fillRect l="0" t="0" r="0" b="0"/>
-            </a:stretch>
-          </a:blipFill>
-        </p:spPr>
-      </p:sp>
-      <p:sp>
-        <p:nvSpPr>
-          <p:cNvPr name="Freeform 16" id="16"/>
-          <p:cNvSpPr/>
-          <p:nvPr/>
-        </p:nvSpPr>
-        <p:spPr>
-          <a:xfrm flipH="false" flipV="false" rot="-2061641">
-            <a:off x="2934886" y="6474577"/>
-            <a:ext cx="936949" cy="674603"/>
-          </a:xfrm>
-          <a:custGeom>
-            <a:avLst/>
-            <a:gdLst/>
-            <a:ahLst/>
-            <a:cxnLst/>
-            <a:rect r="r" b="b" t="t" l="l"/>
-            <a:pathLst>
-              <a:path h="674603" w="936949">
-                <a:moveTo>
-                  <a:pt x="0" y="0"/>
-                </a:moveTo>
-                <a:lnTo>
-                  <a:pt x="936949" y="0"/>
-                </a:lnTo>
-                <a:lnTo>
-                  <a:pt x="936949" y="674604"/>
-                </a:lnTo>
-                <a:lnTo>
-                  <a:pt x="0" y="674604"/>
-                </a:lnTo>
-                <a:lnTo>
-                  <a:pt x="0" y="0"/>
-                </a:lnTo>
-                <a:close/>
-              </a:path>
-            </a:pathLst>
-          </a:custGeom>
-          <a:blipFill>
-            <a:blip r:embed="rId9">
-              <a:extLst>
-                <a:ext uri="{96DAC541-7B7A-43D3-8B79-37D633B846F1}">
-                  <asvg:svgBlip xmlns:asvg="http://schemas.microsoft.com/office/drawing/2016/SVG/main" r:embed="rId10"/>
-                </a:ext>
-              </a:extLst>
-            </a:blip>
-            <a:stretch>
-              <a:fillRect l="0" t="0" r="0" b="0"/>
-            </a:stretch>
-          </a:blipFill>
-        </p:spPr>
-      </p:sp>
-      <p:sp>
-        <p:nvSpPr>
-          <p:cNvPr name="Freeform 17" id="17"/>
-          <p:cNvSpPr/>
-          <p:nvPr/>
-        </p:nvSpPr>
-        <p:spPr>
-          <a:xfrm flipH="false" flipV="false" rot="0">
-            <a:off x="12686868" y="2795568"/>
-            <a:ext cx="1078897" cy="1596328"/>
-          </a:xfrm>
-          <a:custGeom>
-            <a:avLst/>
-            <a:gdLst/>
-            <a:ahLst/>
-            <a:cxnLst/>
-            <a:rect r="r" b="b" t="t" l="l"/>
-            <a:pathLst>
-              <a:path h="1596328" w="1078897">
-                <a:moveTo>
-                  <a:pt x="0" y="0"/>
-                </a:moveTo>
-                <a:lnTo>
-                  <a:pt x="1078897" y="0"/>
-                </a:lnTo>
-                <a:lnTo>
-                  <a:pt x="1078897" y="1596328"/>
-                </a:lnTo>
-                <a:lnTo>
-                  <a:pt x="0" y="1596328"/>
-                </a:lnTo>
-                <a:lnTo>
-                  <a:pt x="0" y="0"/>
-                </a:lnTo>
-                <a:close/>
-              </a:path>
-            </a:pathLst>
-          </a:custGeom>
-          <a:blipFill>
-            <a:blip r:embed="rId2">
-              <a:extLst>
-                <a:ext uri="{96DAC541-7B7A-43D3-8B79-37D633B846F1}">
-                  <asvg:svgBlip xmlns:asvg="http://schemas.microsoft.com/office/drawing/2016/SVG/main" r:embed="rId3"/>
-                </a:ext>
-              </a:extLst>
-            </a:blip>
-            <a:stretch>
-              <a:fillRect l="0" t="0" r="0" b="0"/>
-            </a:stretch>
-          </a:blipFill>
-        </p:spPr>
-      </p:sp>
-      <p:sp>
-        <p:nvSpPr>
-          <p:cNvPr name="Freeform 18" id="18"/>
-          <p:cNvSpPr/>
-          <p:nvPr/>
-        </p:nvSpPr>
-        <p:spPr>
-          <a:xfrm flipH="false" flipV="false" rot="0">
-            <a:off x="11572432" y="4817480"/>
-            <a:ext cx="1287478" cy="1102403"/>
-          </a:xfrm>
-          <a:custGeom>
-            <a:avLst/>
-            <a:gdLst/>
-            <a:ahLst/>
-            <a:cxnLst/>
-            <a:rect r="r" b="b" t="t" l="l"/>
-            <a:pathLst>
-              <a:path h="1102403" w="1287478">
-                <a:moveTo>
-                  <a:pt x="0" y="0"/>
-                </a:moveTo>
-                <a:lnTo>
-                  <a:pt x="1287479" y="0"/>
-                </a:lnTo>
-                <a:lnTo>
-                  <a:pt x="1287479" y="1102403"/>
-                </a:lnTo>
-                <a:lnTo>
-                  <a:pt x="0" y="1102403"/>
-                </a:lnTo>
-                <a:lnTo>
-                  <a:pt x="0" y="0"/>
-                </a:lnTo>
-                <a:close/>
-              </a:path>
-            </a:pathLst>
-          </a:custGeom>
-          <a:blipFill>
-            <a:blip r:embed="rId11">
-              <a:extLst>
-                <a:ext uri="{96DAC541-7B7A-43D3-8B79-37D633B846F1}">
-                  <asvg:svgBlip xmlns:asvg="http://schemas.microsoft.com/office/drawing/2016/SVG/main" r:embed="rId12"/>
-                </a:ext>
-              </a:extLst>
-            </a:blip>
-            <a:stretch>
-              <a:fillRect l="0" t="0" r="0" b="0"/>
-            </a:stretch>
-          </a:blipFill>
-        </p:spPr>
-      </p:sp>
-      <p:sp>
-        <p:nvSpPr>
-          <p:cNvPr name="Freeform 19" id="19"/>
-          <p:cNvSpPr/>
-          <p:nvPr/>
-        </p:nvSpPr>
-        <p:spPr>
-          <a:xfrm flipH="false" flipV="false" rot="0">
-            <a:off x="13435256" y="4736405"/>
-            <a:ext cx="1183478" cy="1183478"/>
-          </a:xfrm>
-          <a:custGeom>
-            <a:avLst/>
-            <a:gdLst/>
-            <a:ahLst/>
-            <a:cxnLst/>
-            <a:rect r="r" b="b" t="t" l="l"/>
-            <a:pathLst>
-              <a:path h="1183478" w="1183478">
-                <a:moveTo>
-                  <a:pt x="0" y="0"/>
-                </a:moveTo>
-                <a:lnTo>
-                  <a:pt x="1183478" y="0"/>
-                </a:lnTo>
-                <a:lnTo>
-                  <a:pt x="1183478" y="1183478"/>
-                </a:lnTo>
-                <a:lnTo>
-                  <a:pt x="0" y="1183478"/>
-                </a:lnTo>
-                <a:lnTo>
-                  <a:pt x="0" y="0"/>
-                </a:lnTo>
-                <a:close/>
-              </a:path>
-            </a:pathLst>
-          </a:custGeom>
-          <a:blipFill>
-            <a:blip r:embed="rId13">
-              <a:extLst>
-                <a:ext uri="{96DAC541-7B7A-43D3-8B79-37D633B846F1}">
-                  <asvg:svgBlip xmlns:asvg="http://schemas.microsoft.com/office/drawing/2016/SVG/main" r:embed="rId14"/>
-                </a:ext>
-              </a:extLst>
-            </a:blip>
-            <a:stretch>
-              <a:fillRect l="0" t="0" r="0" b="0"/>
-            </a:stretch>
-          </a:blipFill>
-        </p:spPr>
-      </p:sp>
-      <p:sp>
-        <p:nvSpPr>
-          <p:cNvPr name="Freeform 20" id="20"/>
-          <p:cNvSpPr/>
-          <p:nvPr/>
-        </p:nvSpPr>
-        <p:spPr>
-          <a:xfrm flipH="false" flipV="false" rot="0">
-            <a:off x="7390154" y="2795568"/>
-            <a:ext cx="1596328" cy="1596328"/>
-          </a:xfrm>
-          <a:custGeom>
-            <a:avLst/>
-            <a:gdLst/>
-            <a:ahLst/>
-            <a:cxnLst/>
-            <a:rect r="r" b="b" t="t" l="l"/>
-            <a:pathLst>
-              <a:path h="1596328" w="1596328">
-                <a:moveTo>
-                  <a:pt x="0" y="0"/>
-                </a:moveTo>
-                <a:lnTo>
-                  <a:pt x="1596327" y="0"/>
-                </a:lnTo>
-                <a:lnTo>
-                  <a:pt x="1596327" y="1596328"/>
-                </a:lnTo>
-                <a:lnTo>
-                  <a:pt x="0" y="1596328"/>
-                </a:lnTo>
-                <a:lnTo>
-                  <a:pt x="0" y="0"/>
-                </a:lnTo>
-                <a:close/>
-              </a:path>
-            </a:pathLst>
-          </a:custGeom>
-          <a:blipFill>
-            <a:blip r:embed="rId13">
-              <a:extLst>
-                <a:ext uri="{96DAC541-7B7A-43D3-8B79-37D633B846F1}">
-                  <asvg:svgBlip xmlns:asvg="http://schemas.microsoft.com/office/drawing/2016/SVG/main" r:embed="rId14"/>
-                </a:ext>
-              </a:extLst>
-            </a:blip>
-            <a:stretch>
-              <a:fillRect l="0" t="0" r="0" b="0"/>
-            </a:stretch>
-          </a:blipFill>
-        </p:spPr>
-      </p:sp>
-      <p:sp>
-        <p:nvSpPr>
-          <p:cNvPr name="Freeform 21" id="21"/>
-          <p:cNvSpPr/>
-          <p:nvPr/>
-        </p:nvSpPr>
-        <p:spPr>
-          <a:xfrm flipH="false" flipV="false" rot="0">
-            <a:off x="11429268" y="6194608"/>
-            <a:ext cx="1430643" cy="1160121"/>
-          </a:xfrm>
-          <a:custGeom>
-            <a:avLst/>
-            <a:gdLst/>
-            <a:ahLst/>
-            <a:cxnLst/>
-            <a:rect r="r" b="b" t="t" l="l"/>
-            <a:pathLst>
-              <a:path h="1160121" w="1430643">
-                <a:moveTo>
-                  <a:pt x="0" y="0"/>
-                </a:moveTo>
-                <a:lnTo>
-                  <a:pt x="1430643" y="0"/>
-                </a:lnTo>
-                <a:lnTo>
-                  <a:pt x="1430643" y="1160121"/>
-                </a:lnTo>
-                <a:lnTo>
-                  <a:pt x="0" y="1160121"/>
-                </a:lnTo>
-                <a:lnTo>
-                  <a:pt x="0" y="0"/>
-                </a:lnTo>
-                <a:close/>
-              </a:path>
-            </a:pathLst>
-          </a:custGeom>
-          <a:blipFill>
-            <a:blip r:embed="rId15">
-              <a:extLst>
-                <a:ext uri="{96DAC541-7B7A-43D3-8B79-37D633B846F1}">
-                  <asvg:svgBlip xmlns:asvg="http://schemas.microsoft.com/office/drawing/2016/SVG/main" r:embed="rId16"/>
-                </a:ext>
-              </a:extLst>
-            </a:blip>
-            <a:stretch>
-              <a:fillRect l="0" t="0" r="0" b="0"/>
-            </a:stretch>
-          </a:blipFill>
-        </p:spPr>
-      </p:sp>
-      <p:sp>
-        <p:nvSpPr>
-          <p:cNvPr name="Freeform 22" id="22"/>
-          <p:cNvSpPr/>
-          <p:nvPr/>
-        </p:nvSpPr>
-        <p:spPr>
-          <a:xfrm flipH="false" flipV="false" rot="0">
-            <a:off x="13574286" y="6342137"/>
-            <a:ext cx="954598" cy="865063"/>
-          </a:xfrm>
-          <a:custGeom>
-            <a:avLst/>
-            <a:gdLst/>
-            <a:ahLst/>
-            <a:cxnLst/>
-            <a:rect r="r" b="b" t="t" l="l"/>
-            <a:pathLst>
-              <a:path h="865063" w="954598">
-                <a:moveTo>
-                  <a:pt x="0" y="0"/>
-                </a:moveTo>
-                <a:lnTo>
-                  <a:pt x="954597" y="0"/>
-                </a:lnTo>
-                <a:lnTo>
-                  <a:pt x="954597" y="865063"/>
-                </a:lnTo>
-                <a:lnTo>
-                  <a:pt x="0" y="865063"/>
-                </a:lnTo>
-                <a:lnTo>
-                  <a:pt x="0" y="0"/>
-                </a:lnTo>
-                <a:close/>
-              </a:path>
-            </a:pathLst>
-          </a:custGeom>
-          <a:blipFill>
-            <a:blip r:embed="rId17">
-              <a:extLst>
-                <a:ext uri="{96DAC541-7B7A-43D3-8B79-37D633B846F1}">
-                  <asvg:svgBlip xmlns:asvg="http://schemas.microsoft.com/office/drawing/2016/SVG/main" r:embed="rId18"/>
-                </a:ext>
-              </a:extLst>
-            </a:blip>
-            <a:stretch>
-              <a:fillRect l="0" t="0" r="0" b="0"/>
-            </a:stretch>
-          </a:blipFill>
-        </p:spPr>
-      </p:sp>
-      <p:sp>
-        <p:nvSpPr>
-          <p:cNvPr name="Freeform 23" id="23"/>
-          <p:cNvSpPr/>
-          <p:nvPr/>
-        </p:nvSpPr>
-        <p:spPr>
-          <a:xfrm flipH="false" flipV="false" rot="0">
-            <a:off x="6111699" y="6774669"/>
-            <a:ext cx="640097" cy="580061"/>
-          </a:xfrm>
-          <a:custGeom>
-            <a:avLst/>
-            <a:gdLst/>
-            <a:ahLst/>
-            <a:cxnLst/>
-            <a:rect r="r" b="b" t="t" l="l"/>
-            <a:pathLst>
-              <a:path h="580061" w="640097">
-                <a:moveTo>
-                  <a:pt x="0" y="0"/>
-                </a:moveTo>
-                <a:lnTo>
-                  <a:pt x="640097" y="0"/>
-                </a:lnTo>
-                <a:lnTo>
-                  <a:pt x="640097" y="580060"/>
-                </a:lnTo>
-                <a:lnTo>
-                  <a:pt x="0" y="580060"/>
-                </a:lnTo>
-                <a:lnTo>
-                  <a:pt x="0" y="0"/>
-                </a:lnTo>
-                <a:close/>
-              </a:path>
-            </a:pathLst>
-          </a:custGeom>
-          <a:blipFill>
-            <a:blip r:embed="rId17">
-              <a:extLst>
-                <a:ext uri="{96DAC541-7B7A-43D3-8B79-37D633B846F1}">
-                  <asvg:svgBlip xmlns:asvg="http://schemas.microsoft.com/office/drawing/2016/SVG/main" r:embed="rId18"/>
-                </a:ext>
-              </a:extLst>
-            </a:blip>
-            <a:stretch>
-              <a:fillRect l="0" t="0" r="0" b="0"/>
-            </a:stretch>
-          </a:blipFill>
-        </p:spPr>
-      </p:sp>
-      <p:sp>
-        <p:nvSpPr>
-          <p:cNvPr name="Freeform 24" id="24"/>
-          <p:cNvSpPr/>
-          <p:nvPr/>
-        </p:nvSpPr>
-        <p:spPr>
-          <a:xfrm flipH="false" flipV="false" rot="0">
-            <a:off x="16264765" y="2795568"/>
-            <a:ext cx="994535" cy="1093989"/>
-          </a:xfrm>
-          <a:custGeom>
-            <a:avLst/>
-            <a:gdLst/>
-            <a:ahLst/>
-            <a:cxnLst/>
-            <a:rect r="r" b="b" t="t" l="l"/>
-            <a:pathLst>
-              <a:path h="1093989" w="994535">
-                <a:moveTo>
-                  <a:pt x="0" y="0"/>
-                </a:moveTo>
-                <a:lnTo>
-                  <a:pt x="994535" y="0"/>
-                </a:lnTo>
-                <a:lnTo>
-                  <a:pt x="994535" y="1093989"/>
-                </a:lnTo>
-                <a:lnTo>
-                  <a:pt x="0" y="1093989"/>
-                </a:lnTo>
-                <a:lnTo>
-                  <a:pt x="0" y="0"/>
-                </a:lnTo>
-                <a:close/>
-              </a:path>
-            </a:pathLst>
-          </a:custGeom>
-          <a:blipFill>
-            <a:blip r:embed="rId19">
-              <a:extLst>
-                <a:ext uri="{96DAC541-7B7A-43D3-8B79-37D633B846F1}">
-                  <asvg:svgBlip xmlns:asvg="http://schemas.microsoft.com/office/drawing/2016/SVG/main" r:embed="rId20"/>
-                </a:ext>
-              </a:extLst>
-            </a:blip>
-            <a:stretch>
-              <a:fillRect l="0" t="0" r="0" b="0"/>
-            </a:stretch>
-          </a:blipFill>
-        </p:spPr>
-      </p:sp>
-      <p:sp>
-        <p:nvSpPr>
-          <p:cNvPr name="Freeform 25" id="25"/>
-          <p:cNvSpPr/>
-          <p:nvPr/>
-        </p:nvSpPr>
-        <p:spPr>
-          <a:xfrm flipH="false" flipV="false" rot="0">
-            <a:off x="16105487" y="4333610"/>
-            <a:ext cx="1401526" cy="1256277"/>
-          </a:xfrm>
-          <a:custGeom>
-            <a:avLst/>
-            <a:gdLst/>
-            <a:ahLst/>
-            <a:cxnLst/>
-            <a:rect r="r" b="b" t="t" l="l"/>
-            <a:pathLst>
-              <a:path h="1256277" w="1401526">
-                <a:moveTo>
-                  <a:pt x="0" y="0"/>
-                </a:moveTo>
-                <a:lnTo>
-                  <a:pt x="1401526" y="0"/>
-                </a:lnTo>
-                <a:lnTo>
-                  <a:pt x="1401526" y="1256277"/>
-                </a:lnTo>
-                <a:lnTo>
-                  <a:pt x="0" y="1256277"/>
-                </a:lnTo>
-                <a:lnTo>
-                  <a:pt x="0" y="0"/>
-                </a:lnTo>
-                <a:close/>
-              </a:path>
-            </a:pathLst>
-          </a:custGeom>
-          <a:blipFill>
-            <a:blip r:embed="rId21">
-              <a:extLst>
-                <a:ext uri="{96DAC541-7B7A-43D3-8B79-37D633B846F1}">
-                  <asvg:svgBlip xmlns:asvg="http://schemas.microsoft.com/office/drawing/2016/SVG/main" r:embed="rId22"/>
-                </a:ext>
-              </a:extLst>
-            </a:blip>
-            <a:stretch>
-              <a:fillRect l="0" t="0" r="0" b="0"/>
-            </a:stretch>
-          </a:blipFill>
-        </p:spPr>
-      </p:sp>
-      <p:sp>
-        <p:nvSpPr>
-          <p:cNvPr name="Freeform 26" id="26"/>
-          <p:cNvSpPr/>
-          <p:nvPr/>
-        </p:nvSpPr>
-        <p:spPr>
-          <a:xfrm flipH="false" flipV="false" rot="0">
-            <a:off x="16105487" y="5919883"/>
-            <a:ext cx="1401526" cy="1557251"/>
-          </a:xfrm>
-          <a:custGeom>
-            <a:avLst/>
-            <a:gdLst/>
-            <a:ahLst/>
-            <a:cxnLst/>
-            <a:rect r="r" b="b" t="t" l="l"/>
-            <a:pathLst>
-              <a:path h="1557251" w="1401526">
-                <a:moveTo>
-                  <a:pt x="0" y="0"/>
-                </a:moveTo>
-                <a:lnTo>
-                  <a:pt x="1401526" y="0"/>
-                </a:lnTo>
-                <a:lnTo>
-                  <a:pt x="1401526" y="1557251"/>
-                </a:lnTo>
-                <a:lnTo>
-                  <a:pt x="0" y="1557251"/>
-                </a:lnTo>
-                <a:lnTo>
-                  <a:pt x="0" y="0"/>
-                </a:lnTo>
-                <a:close/>
-              </a:path>
-            </a:pathLst>
-          </a:custGeom>
-          <a:blipFill>
-            <a:blip r:embed="rId23">
-              <a:extLst>
-                <a:ext uri="{96DAC541-7B7A-43D3-8B79-37D633B846F1}">
-                  <asvg:svgBlip xmlns:asvg="http://schemas.microsoft.com/office/drawing/2016/SVG/main" r:embed="rId24"/>
-                </a:ext>
-              </a:extLst>
-            </a:blip>
-            <a:stretch>
-              <a:fillRect l="0" t="0" r="0" b="0"/>
-            </a:stretch>
-          </a:blipFill>
-        </p:spPr>
-      </p:sp>
-      <p:sp>
-        <p:nvSpPr>
-          <p:cNvPr name="Freeform 27" id="27"/>
-          <p:cNvSpPr/>
-          <p:nvPr/>
-        </p:nvSpPr>
-        <p:spPr>
-          <a:xfrm flipH="false" flipV="false" rot="0">
-            <a:off x="7056373" y="4614983"/>
-            <a:ext cx="1949835" cy="1669546"/>
-          </a:xfrm>
-          <a:custGeom>
-            <a:avLst/>
-            <a:gdLst/>
-            <a:ahLst/>
-            <a:cxnLst/>
-            <a:rect r="r" b="b" t="t" l="l"/>
-            <a:pathLst>
-              <a:path h="1669546" w="1949835">
-                <a:moveTo>
-                  <a:pt x="0" y="0"/>
-                </a:moveTo>
-                <a:lnTo>
-                  <a:pt x="1949835" y="0"/>
-                </a:lnTo>
-                <a:lnTo>
-                  <a:pt x="1949835" y="1669546"/>
-                </a:lnTo>
-                <a:lnTo>
-                  <a:pt x="0" y="1669546"/>
-                </a:lnTo>
-                <a:lnTo>
-                  <a:pt x="0" y="0"/>
-                </a:lnTo>
-                <a:close/>
-              </a:path>
-            </a:pathLst>
-          </a:custGeom>
-          <a:blipFill>
-            <a:blip r:embed="rId11">
-              <a:extLst>
-                <a:ext uri="{96DAC541-7B7A-43D3-8B79-37D633B846F1}">
-                  <asvg:svgBlip xmlns:asvg="http://schemas.microsoft.com/office/drawing/2016/SVG/main" r:embed="rId12"/>
-                </a:ext>
-              </a:extLst>
-            </a:blip>
-            <a:stretch>
-              <a:fillRect l="0" t="0" r="0" b="0"/>
-            </a:stretch>
-          </a:blipFill>
-        </p:spPr>
-      </p:sp>
-      <p:sp>
-        <p:nvSpPr>
-          <p:cNvPr name="Freeform 28" id="28"/>
-          <p:cNvSpPr/>
-          <p:nvPr/>
-        </p:nvSpPr>
-        <p:spPr>
-          <a:xfrm flipH="false" flipV="false" rot="0">
-            <a:off x="7235140" y="6390010"/>
-            <a:ext cx="1448711" cy="1298572"/>
-          </a:xfrm>
-          <a:custGeom>
-            <a:avLst/>
-            <a:gdLst/>
-            <a:ahLst/>
-            <a:cxnLst/>
-            <a:rect r="r" b="b" t="t" l="l"/>
-            <a:pathLst>
-              <a:path h="1298572" w="1448711">
-                <a:moveTo>
-                  <a:pt x="0" y="0"/>
-                </a:moveTo>
-                <a:lnTo>
-                  <a:pt x="1448711" y="0"/>
-                </a:lnTo>
-                <a:lnTo>
-                  <a:pt x="1448711" y="1298572"/>
-                </a:lnTo>
-                <a:lnTo>
-                  <a:pt x="0" y="1298572"/>
-                </a:lnTo>
-                <a:lnTo>
-                  <a:pt x="0" y="0"/>
-                </a:lnTo>
-                <a:close/>
-              </a:path>
-            </a:pathLst>
-          </a:custGeom>
-          <a:blipFill>
-            <a:blip r:embed="rId6"/>
-            <a:stretch>
-              <a:fillRect l="0" t="0" r="0" b="0"/>
-            </a:stretch>
-          </a:blipFill>
-        </p:spPr>
-      </p:sp>
-      <p:sp>
-        <p:nvSpPr>
-          <p:cNvPr name="Freeform 29" id="29"/>
-          <p:cNvSpPr/>
-          <p:nvPr/>
-        </p:nvSpPr>
-        <p:spPr>
-          <a:xfrm flipH="false" flipV="false" rot="0">
-            <a:off x="9144000" y="6698509"/>
-            <a:ext cx="828115" cy="861498"/>
-          </a:xfrm>
-          <a:custGeom>
-            <a:avLst/>
-            <a:gdLst/>
-            <a:ahLst/>
-            <a:cxnLst/>
-            <a:rect r="r" b="b" t="t" l="l"/>
-            <a:pathLst>
-              <a:path h="861498" w="828115">
-                <a:moveTo>
-                  <a:pt x="0" y="0"/>
-                </a:moveTo>
-                <a:lnTo>
-                  <a:pt x="828115" y="0"/>
-                </a:lnTo>
-                <a:lnTo>
-                  <a:pt x="828115" y="861498"/>
-                </a:lnTo>
-                <a:lnTo>
-                  <a:pt x="0" y="861498"/>
-                </a:lnTo>
-                <a:lnTo>
-                  <a:pt x="0" y="0"/>
-                </a:lnTo>
-                <a:close/>
-              </a:path>
-            </a:pathLst>
-          </a:custGeom>
-          <a:blipFill>
-            <a:blip r:embed="rId25">
-              <a:extLst>
-                <a:ext uri="{96DAC541-7B7A-43D3-8B79-37D633B846F1}">
-                  <asvg:svgBlip xmlns:asvg="http://schemas.microsoft.com/office/drawing/2016/SVG/main" r:embed="rId26"/>
-                </a:ext>
-              </a:extLst>
-            </a:blip>
-            <a:stretch>
-              <a:fillRect l="0" t="0" r="0" b="0"/>
-            </a:stretch>
-          </a:blipFill>
-        </p:spPr>
-      </p:sp>
-      <p:sp>
-        <p:nvSpPr>
-          <p:cNvPr name="TextBox 30" id="30"/>
-          <p:cNvSpPr txBox="true"/>
-          <p:nvPr/>
-        </p:nvSpPr>
-        <p:spPr>
-          <a:xfrm rot="0">
-            <a:off x="4110616" y="789079"/>
-            <a:ext cx="9655149" cy="898392"/>
-          </a:xfrm>
-          <a:prstGeom prst="rect">
-            <a:avLst/>
-          </a:prstGeom>
-        </p:spPr>
-        <p:txBody>
-          <a:bodyPr anchor="t" rtlCol="false" tIns="0" lIns="0" bIns="0" rIns="0">
-            <a:spAutoFit/>
-          </a:bodyPr>
-          <a:lstStyle/>
-          <a:p>
-            <a:pPr algn="ctr" marL="0" indent="0" lvl="0">
-              <a:lnSpc>
-                <a:spcPts val="7291"/>
-              </a:lnSpc>
-              <a:spcBef>
-                <a:spcPct val="0"/>
-              </a:spcBef>
-            </a:pPr>
-            <a:r>
-              <a:rPr lang="en-US" sz="5283" spc="184">
-                <a:solidFill>
-                  <a:srgbClr val="FFFFFF"/>
-                </a:solidFill>
-                <a:latin typeface="Archivo Black"/>
-                <a:ea typeface="Archivo Black"/>
-                <a:cs typeface="Archivo Black"/>
-                <a:sym typeface="Archivo Black"/>
-              </a:rPr>
-              <a:t>RESUMEN APLICATIVO</a:t>
-            </a:r>
-          </a:p>
-        </p:txBody>
-      </p:sp>
-      <p:sp>
-        <p:nvSpPr>
-          <p:cNvPr name="TextBox 31" id="31"/>
-          <p:cNvSpPr txBox="true"/>
-          <p:nvPr/>
-        </p:nvSpPr>
-        <p:spPr>
-          <a:xfrm rot="0">
-            <a:off x="16931495" y="9677125"/>
-            <a:ext cx="152400" cy="200025"/>
-          </a:xfrm>
-          <a:prstGeom prst="rect">
-            <a:avLst/>
-          </a:prstGeom>
-        </p:spPr>
-        <p:txBody>
-          <a:bodyPr anchor="t" rtlCol="false" tIns="0" lIns="0" bIns="0" rIns="0" wrap="none">
-            <a:spAutoFit/>
-          </a:bodyPr>
-          <a:lstStyle/>
-          <a:p>
-            <a:pPr algn="ctr">
-              <a:lnSpc>
-                <a:spcPts val="2800"/>
-              </a:lnSpc>
-              <a:spcBef>
-                <a:spcPct val="0"/>
-              </a:spcBef>
-            </a:pPr>
-            <a:r>
-              <a:rPr lang="en-US" sz="2000">
-                <a:solidFill>
-                  <a:srgbClr val="FFFFFF"/>
-                </a:solidFill>
-                <a:latin typeface="Open Sans"/>
-                <a:ea typeface="Open Sans"/>
-                <a:cs typeface="Open Sans"/>
-                <a:sym typeface="Open Sans"/>
-              </a:rPr>
-              <a:t>Página 13</a:t>
-            </a:r>
-          </a:p>
-        </p:txBody>
-      </p:sp>
-    </p:spTree>
-  </p:cSld>
-  <p:clrMapOvr>
-    <a:masterClrMapping/>
-  </p:clrMapOvr>
-</p:sld>
-</file>
-
-<file path=ppt/slides/slide14.xml><?xml version="1.0" encoding="utf-8"?>
+<file path=ppt/slides/slide12.xml><?xml version="1.0" encoding="utf-8"?>
 <p:sld xmlns:p="http://schemas.openxmlformats.org/presentationml/2006/main" xmlns:a="http://schemas.openxmlformats.org/drawingml/2006/main" xmlns:r="http://schemas.openxmlformats.org/officeDocument/2006/relationships">
   <p:cSld>
     <p:bg>
@@ -8005,55 +5966,9 @@
           </a:blipFill>
         </p:spPr>
       </p:sp>
-      <p:sp>
-        <p:nvSpPr>
-          <p:cNvPr name="Freeform 8" id="8"/>
-          <p:cNvSpPr/>
-          <p:nvPr/>
-        </p:nvSpPr>
-        <p:spPr>
-          <a:xfrm flipH="false" flipV="false" rot="0">
-            <a:off x="12833394" y="6585475"/>
-            <a:ext cx="2011615" cy="2011615"/>
-          </a:xfrm>
-          <a:custGeom>
-            <a:avLst/>
-            <a:gdLst/>
-            <a:ahLst/>
-            <a:cxnLst/>
-            <a:rect r="r" b="b" t="t" l="l"/>
-            <a:pathLst>
-              <a:path h="2011615" w="2011615">
-                <a:moveTo>
-                  <a:pt x="0" y="0"/>
-                </a:moveTo>
-                <a:lnTo>
-                  <a:pt x="2011614" y="0"/>
-                </a:lnTo>
-                <a:lnTo>
-                  <a:pt x="2011614" y="2011615"/>
-                </a:lnTo>
-                <a:lnTo>
-                  <a:pt x="0" y="2011615"/>
-                </a:lnTo>
-                <a:lnTo>
-                  <a:pt x="0" y="0"/>
-                </a:lnTo>
-                <a:close/>
-              </a:path>
-            </a:pathLst>
-          </a:custGeom>
-          <a:blipFill>
-            <a:blip r:embed="rId5"/>
-            <a:stretch>
-              <a:fillRect l="0" t="0" r="0" b="0"/>
-            </a:stretch>
-          </a:blipFill>
-        </p:spPr>
-      </p:sp>
       <p:grpSp>
         <p:nvGrpSpPr>
-          <p:cNvPr name="Group 9" id="9"/>
+          <p:cNvPr name="Group 8" id="8"/>
           <p:cNvGrpSpPr/>
           <p:nvPr/>
         </p:nvGrpSpPr>
@@ -8067,7 +5982,7 @@
         </p:grpSpPr>
         <p:sp>
           <p:nvSpPr>
-            <p:cNvPr name="Freeform 10" id="10"/>
+            <p:cNvPr name="Freeform 9" id="9"/>
             <p:cNvSpPr/>
             <p:nvPr/>
           </p:nvSpPr>
@@ -8119,7 +6034,7 @@
         </p:sp>
         <p:sp>
           <p:nvSpPr>
-            <p:cNvPr name="TextBox 11" id="11"/>
+            <p:cNvPr name="TextBox 10" id="10"/>
             <p:cNvSpPr txBox="true"/>
             <p:nvPr/>
           </p:nvSpPr>
@@ -8145,6 +6060,52 @@
           </p:txBody>
         </p:sp>
       </p:grpSp>
+      <p:sp>
+        <p:nvSpPr>
+          <p:cNvPr name="Freeform 11" id="11"/>
+          <p:cNvSpPr/>
+          <p:nvPr/>
+        </p:nvSpPr>
+        <p:spPr>
+          <a:xfrm flipH="false" flipV="false" rot="0">
+            <a:off x="13118589" y="6896711"/>
+            <a:ext cx="1699666" cy="1699666"/>
+          </a:xfrm>
+          <a:custGeom>
+            <a:avLst/>
+            <a:gdLst/>
+            <a:ahLst/>
+            <a:cxnLst/>
+            <a:rect r="r" b="b" t="t" l="l"/>
+            <a:pathLst>
+              <a:path h="1699666" w="1699666">
+                <a:moveTo>
+                  <a:pt x="0" y="0"/>
+                </a:moveTo>
+                <a:lnTo>
+                  <a:pt x="1699666" y="0"/>
+                </a:lnTo>
+                <a:lnTo>
+                  <a:pt x="1699666" y="1699666"/>
+                </a:lnTo>
+                <a:lnTo>
+                  <a:pt x="0" y="1699666"/>
+                </a:lnTo>
+                <a:lnTo>
+                  <a:pt x="0" y="0"/>
+                </a:lnTo>
+                <a:close/>
+              </a:path>
+            </a:pathLst>
+          </a:custGeom>
+          <a:blipFill>
+            <a:blip r:embed="rId5"/>
+            <a:stretch>
+              <a:fillRect l="0" t="0" r="0" b="0"/>
+            </a:stretch>
+          </a:blipFill>
+        </p:spPr>
+      </p:sp>
       <p:sp>
         <p:nvSpPr>
           <p:cNvPr name="TextBox 12" id="12"/>
@@ -13961,7 +11922,7 @@
         </p:nvGrpSpPr>
         <p:grpSpPr>
           <a:xfrm rot="0">
-            <a:off x="6836071" y="313458"/>
+            <a:off x="6597208" y="317296"/>
             <a:ext cx="3910547" cy="923910"/>
             <a:chOff x="0" y="0"/>
             <a:chExt cx="909243" cy="214819"/>
@@ -14193,8 +12154,8 @@
         </p:nvSpPr>
         <p:spPr>
           <a:xfrm flipH="false" flipV="false" rot="0">
-            <a:off x="10475907" y="3029854"/>
-            <a:ext cx="5826726" cy="2134038"/>
+            <a:off x="10503735" y="1928634"/>
+            <a:ext cx="5388887" cy="1973680"/>
           </a:xfrm>
           <a:custGeom>
             <a:avLst/>
@@ -14203,18 +12164,18 @@
             <a:cxnLst/>
             <a:rect r="r" b="b" t="t" l="l"/>
             <a:pathLst>
-              <a:path h="2134038" w="5826726">
+              <a:path h="1973680" w="5388887">
                 <a:moveTo>
                   <a:pt x="0" y="0"/>
                 </a:moveTo>
                 <a:lnTo>
-                  <a:pt x="5826725" y="0"/>
-                </a:lnTo>
-                <a:lnTo>
-                  <a:pt x="5826725" y="2134038"/>
-                </a:lnTo>
-                <a:lnTo>
-                  <a:pt x="0" y="2134038"/>
+                  <a:pt x="5388887" y="0"/>
+                </a:lnTo>
+                <a:lnTo>
+                  <a:pt x="5388887" y="1973680"/>
+                </a:lnTo>
+                <a:lnTo>
+                  <a:pt x="0" y="1973680"/>
                 </a:lnTo>
                 <a:lnTo>
                   <a:pt x="0" y="0"/>
@@ -14285,7 +12246,7 @@
         </p:nvSpPr>
         <p:spPr>
           <a:xfrm flipH="false" flipV="false" rot="0">
-            <a:off x="9962497" y="6983200"/>
+            <a:off x="9771406" y="4799819"/>
             <a:ext cx="6853546" cy="1816190"/>
           </a:xfrm>
           <a:custGeom>
@@ -14413,7 +12374,7 @@
         </p:nvSpPr>
         <p:spPr>
           <a:xfrm rot="0">
-            <a:off x="11399630" y="2163374"/>
+            <a:off x="11288160" y="1202580"/>
             <a:ext cx="4296694" cy="531495"/>
           </a:xfrm>
           <a:prstGeom prst="rect">
@@ -14539,7 +12500,7 @@
         </p:nvSpPr>
         <p:spPr>
           <a:xfrm rot="0">
-            <a:off x="11399630" y="5938588"/>
+            <a:off x="11049831" y="4020673"/>
             <a:ext cx="4296694" cy="531495"/>
           </a:xfrm>
           <a:prstGeom prst="rect">
@@ -14571,6 +12532,231 @@
             </a:r>
           </a:p>
         </p:txBody>
+      </p:sp>
+      <p:sp>
+        <p:nvSpPr>
+          <p:cNvPr name="TextBox 19" id="19"/>
+          <p:cNvSpPr txBox="true"/>
+          <p:nvPr/>
+        </p:nvSpPr>
+        <p:spPr>
+          <a:xfrm rot="0">
+            <a:off x="9442042" y="6916525"/>
+            <a:ext cx="10136117" cy="438150"/>
+          </a:xfrm>
+          <a:prstGeom prst="rect">
+            <a:avLst/>
+          </a:prstGeom>
+        </p:spPr>
+        <p:txBody>
+          <a:bodyPr anchor="t" rtlCol="false" tIns="0" lIns="0" bIns="0" rIns="0">
+            <a:spAutoFit/>
+          </a:bodyPr>
+          <a:lstStyle/>
+          <a:p>
+            <a:pPr algn="l">
+              <a:lnSpc>
+                <a:spcPts val="3449"/>
+              </a:lnSpc>
+            </a:pPr>
+            <a:r>
+              <a:rPr lang="en-US" sz="2499" spc="244">
+                <a:solidFill>
+                  <a:srgbClr val="FFFFFF"/>
+                </a:solidFill>
+                <a:latin typeface="Poppins"/>
+                <a:ea typeface="Poppins"/>
+                <a:cs typeface="Poppins"/>
+                <a:sym typeface="Poppins"/>
+              </a:rPr>
+              <a:t>Consultar dashboard (métricas del aplicativo)</a:t>
+            </a:r>
+          </a:p>
+        </p:txBody>
+      </p:sp>
+      <p:sp>
+        <p:nvSpPr>
+          <p:cNvPr name="Freeform 20" id="20"/>
+          <p:cNvSpPr/>
+          <p:nvPr/>
+        </p:nvSpPr>
+        <p:spPr>
+          <a:xfrm flipH="false" flipV="false" rot="0">
+            <a:off x="9726904" y="7649950"/>
+            <a:ext cx="3471275" cy="2006894"/>
+          </a:xfrm>
+          <a:custGeom>
+            <a:avLst/>
+            <a:gdLst/>
+            <a:ahLst/>
+            <a:cxnLst/>
+            <a:rect r="r" b="b" t="t" l="l"/>
+            <a:pathLst>
+              <a:path h="2006894" w="3471275">
+                <a:moveTo>
+                  <a:pt x="0" y="0"/>
+                </a:moveTo>
+                <a:lnTo>
+                  <a:pt x="3471275" y="0"/>
+                </a:lnTo>
+                <a:lnTo>
+                  <a:pt x="3471275" y="2006894"/>
+                </a:lnTo>
+                <a:lnTo>
+                  <a:pt x="0" y="2006894"/>
+                </a:lnTo>
+                <a:lnTo>
+                  <a:pt x="0" y="0"/>
+                </a:lnTo>
+                <a:close/>
+              </a:path>
+            </a:pathLst>
+          </a:custGeom>
+          <a:blipFill>
+            <a:blip r:embed="rId7"/>
+            <a:stretch>
+              <a:fillRect l="-1390" t="0" r="-1390" b="0"/>
+            </a:stretch>
+          </a:blipFill>
+        </p:spPr>
+      </p:sp>
+      <p:sp>
+        <p:nvSpPr>
+          <p:cNvPr name="Freeform 21" id="21"/>
+          <p:cNvSpPr/>
+          <p:nvPr/>
+        </p:nvSpPr>
+        <p:spPr>
+          <a:xfrm flipH="false" flipV="false" rot="0">
+            <a:off x="13327498" y="7846406"/>
+            <a:ext cx="2257356" cy="1015810"/>
+          </a:xfrm>
+          <a:custGeom>
+            <a:avLst/>
+            <a:gdLst/>
+            <a:ahLst/>
+            <a:cxnLst/>
+            <a:rect r="r" b="b" t="t" l="l"/>
+            <a:pathLst>
+              <a:path h="1015810" w="2257356">
+                <a:moveTo>
+                  <a:pt x="0" y="0"/>
+                </a:moveTo>
+                <a:lnTo>
+                  <a:pt x="2257356" y="0"/>
+                </a:lnTo>
+                <a:lnTo>
+                  <a:pt x="2257356" y="1015810"/>
+                </a:lnTo>
+                <a:lnTo>
+                  <a:pt x="0" y="1015810"/>
+                </a:lnTo>
+                <a:lnTo>
+                  <a:pt x="0" y="0"/>
+                </a:lnTo>
+                <a:close/>
+              </a:path>
+            </a:pathLst>
+          </a:custGeom>
+          <a:blipFill>
+            <a:blip r:embed="rId8"/>
+            <a:stretch>
+              <a:fillRect l="0" t="0" r="0" b="0"/>
+            </a:stretch>
+          </a:blipFill>
+        </p:spPr>
+      </p:sp>
+      <p:sp>
+        <p:nvSpPr>
+          <p:cNvPr name="Freeform 22" id="22"/>
+          <p:cNvSpPr/>
+          <p:nvPr/>
+        </p:nvSpPr>
+        <p:spPr>
+          <a:xfrm flipH="false" flipV="false" rot="0">
+            <a:off x="15718204" y="7846406"/>
+            <a:ext cx="2371558" cy="1523726"/>
+          </a:xfrm>
+          <a:custGeom>
+            <a:avLst/>
+            <a:gdLst/>
+            <a:ahLst/>
+            <a:cxnLst/>
+            <a:rect r="r" b="b" t="t" l="l"/>
+            <a:pathLst>
+              <a:path h="1523726" w="2371558">
+                <a:moveTo>
+                  <a:pt x="0" y="0"/>
+                </a:moveTo>
+                <a:lnTo>
+                  <a:pt x="2371558" y="0"/>
+                </a:lnTo>
+                <a:lnTo>
+                  <a:pt x="2371558" y="1523726"/>
+                </a:lnTo>
+                <a:lnTo>
+                  <a:pt x="0" y="1523726"/>
+                </a:lnTo>
+                <a:lnTo>
+                  <a:pt x="0" y="0"/>
+                </a:lnTo>
+                <a:close/>
+              </a:path>
+            </a:pathLst>
+          </a:custGeom>
+          <a:blipFill>
+            <a:blip r:embed="rId9"/>
+            <a:stretch>
+              <a:fillRect l="0" t="0" r="0" b="0"/>
+            </a:stretch>
+          </a:blipFill>
+        </p:spPr>
+      </p:sp>
+      <p:sp>
+        <p:nvSpPr>
+          <p:cNvPr name="Freeform 23" id="23"/>
+          <p:cNvSpPr/>
+          <p:nvPr/>
+        </p:nvSpPr>
+        <p:spPr>
+          <a:xfrm flipH="false" flipV="false" rot="0">
+            <a:off x="13327498" y="8940556"/>
+            <a:ext cx="2257356" cy="331603"/>
+          </a:xfrm>
+          <a:custGeom>
+            <a:avLst/>
+            <a:gdLst/>
+            <a:ahLst/>
+            <a:cxnLst/>
+            <a:rect r="r" b="b" t="t" l="l"/>
+            <a:pathLst>
+              <a:path h="331603" w="2257356">
+                <a:moveTo>
+                  <a:pt x="0" y="0"/>
+                </a:moveTo>
+                <a:lnTo>
+                  <a:pt x="2257356" y="0"/>
+                </a:lnTo>
+                <a:lnTo>
+                  <a:pt x="2257356" y="331603"/>
+                </a:lnTo>
+                <a:lnTo>
+                  <a:pt x="0" y="331603"/>
+                </a:lnTo>
+                <a:lnTo>
+                  <a:pt x="0" y="0"/>
+                </a:lnTo>
+                <a:close/>
+              </a:path>
+            </a:pathLst>
+          </a:custGeom>
+          <a:blipFill>
+            <a:blip r:embed="rId10"/>
+            <a:stretch>
+              <a:fillRect l="0" t="0" r="0" b="-14874"/>
+            </a:stretch>
+          </a:blipFill>
+        </p:spPr>
       </p:sp>
     </p:spTree>
   </p:cSld>

</xml_diff>

<commit_message>
docuemntos cambiados, adaptanod el contenido a las exigencias de la asignatura
</commit_message>
<xml_diff>
--- a/documentacion_extra/presentacion/cuidaDos.pptx
+++ b/documentacion_extra/presentacion/cuidaDos.pptx
@@ -8191,7 +8191,7 @@
         </p:nvSpPr>
         <p:spPr>
           <a:xfrm rot="0">
-            <a:off x="5591677" y="6376255"/>
+            <a:off x="5459664" y="6376255"/>
             <a:ext cx="899357" cy="272198"/>
           </a:xfrm>
           <a:prstGeom prst="rect">
@@ -8773,8 +8773,8 @@
         </p:nvSpPr>
         <p:spPr>
           <a:xfrm rot="0">
-            <a:off x="3390239" y="3264861"/>
-            <a:ext cx="12762620" cy="4944241"/>
+            <a:off x="2976208" y="3153392"/>
+            <a:ext cx="13558833" cy="6001516"/>
           </a:xfrm>
           <a:prstGeom prst="rect">
             <a:avLst/>
@@ -8831,7 +8831,7 @@
                 <a:cs typeface="Poppins Bold"/>
                 <a:sym typeface="Poppins Bold"/>
               </a:rPr>
-              <a:t>Sistema de Valoraciones y Reputación.</a:t>
+              <a:t>Sistema de Valoraciones.</a:t>
             </a:r>
           </a:p>
           <a:p>
@@ -8889,6 +8889,48 @@
               </a:rPr>
               <a:t>Expansión del Módulo de Inteligencia Artificial. Matchmaking Inteligente: el cliente describe el problema en lenguaje natural y la IA filtra la base de datos y le propone los 3 perfiles profesionales más adecuados.</a:t>
             </a:r>
+          </a:p>
+          <a:p>
+            <a:pPr algn="l">
+              <a:lnSpc>
+                <a:spcPts val="2828"/>
+              </a:lnSpc>
+            </a:pPr>
+          </a:p>
+          <a:p>
+            <a:pPr algn="l" marL="442554" indent="-221277" lvl="1">
+              <a:lnSpc>
+                <a:spcPts val="2828"/>
+              </a:lnSpc>
+              <a:buFont typeface="Arial"/>
+              <a:buChar char="•"/>
+            </a:pPr>
+            <a:r>
+              <a:rPr lang="en-US" b="true" sz="2049" spc="200">
+                <a:solidFill>
+                  <a:srgbClr val="344F51"/>
+                </a:solidFill>
+                <a:latin typeface="Poppins Bold"/>
+                <a:ea typeface="Poppins Bold"/>
+                <a:cs typeface="Poppins Bold"/>
+                <a:sym typeface="Poppins Bold"/>
+              </a:rPr>
+              <a:t>Dar de alta a los usuarios de nuevo por los adnimistradores</a:t>
+            </a:r>
+          </a:p>
+          <a:p>
+            <a:pPr algn="l">
+              <a:lnSpc>
+                <a:spcPts val="2828"/>
+              </a:lnSpc>
+            </a:pPr>
+          </a:p>
+          <a:p>
+            <a:pPr algn="l">
+              <a:lnSpc>
+                <a:spcPts val="2828"/>
+              </a:lnSpc>
+            </a:pPr>
           </a:p>
           <a:p>
             <a:pPr algn="l">

</xml_diff>

<commit_message>
actualizacion de las presentación e imágenes de la base de datos
</commit_message>
<xml_diff>
--- a/documentacion_extra/presentacion/cuidaDos.pptx
+++ b/documentacion_extra/presentacion/cuidaDos.pptx
@@ -6371,10 +6371,10 @@
         </p:nvGrpSpPr>
         <p:grpSpPr>
           <a:xfrm rot="0">
-            <a:off x="-2591018" y="2082056"/>
-            <a:ext cx="11567554" cy="1713680"/>
+            <a:off x="-2785357" y="538989"/>
+            <a:ext cx="7162260" cy="1961344"/>
             <a:chOff x="0" y="0"/>
-            <a:chExt cx="1121219" cy="166103"/>
+            <a:chExt cx="1012764" cy="277340"/>
           </a:xfrm>
         </p:grpSpPr>
         <p:sp>
@@ -6386,7 +6386,7 @@
           <p:spPr>
             <a:xfrm flipH="false" flipV="false" rot="0">
               <a:off x="0" y="0"/>
-              <a:ext cx="1121219" cy="166103"/>
+              <a:ext cx="1012764" cy="277340"/>
             </a:xfrm>
             <a:custGeom>
               <a:avLst/>
@@ -6395,21 +6395,21 @@
               <a:cxnLst/>
               <a:rect r="r" b="b" t="t" l="l"/>
               <a:pathLst>
-                <a:path h="166103" w="1121219">
+                <a:path h="277340" w="1012764">
                   <a:moveTo>
-                    <a:pt x="918019" y="0"/>
+                    <a:pt x="809564" y="0"/>
                   </a:moveTo>
                   <a:lnTo>
                     <a:pt x="0" y="0"/>
                   </a:lnTo>
                   <a:lnTo>
-                    <a:pt x="203200" y="166103"/>
-                  </a:lnTo>
-                  <a:lnTo>
-                    <a:pt x="1121219" y="166103"/>
-                  </a:lnTo>
-                  <a:lnTo>
-                    <a:pt x="918019" y="0"/>
+                    <a:pt x="203200" y="277340"/>
+                  </a:lnTo>
+                  <a:lnTo>
+                    <a:pt x="1012764" y="277340"/>
+                  </a:lnTo>
+                  <a:lnTo>
+                    <a:pt x="809564" y="0"/>
                   </a:lnTo>
                   <a:close/>
                 </a:path>
@@ -6434,7 +6434,7 @@
           <p:spPr>
             <a:xfrm>
               <a:off x="101600" y="-19050"/>
-              <a:ext cx="918019" cy="185153"/>
+              <a:ext cx="809564" cy="296390"/>
             </a:xfrm>
             <a:prstGeom prst="rect">
               <a:avLst/>
@@ -6464,8 +6464,8 @@
         </p:nvSpPr>
         <p:spPr>
           <a:xfrm flipH="false" flipV="false" rot="0">
-            <a:off x="2453908" y="4640836"/>
-            <a:ext cx="3873132" cy="4289649"/>
+            <a:off x="878202" y="4555916"/>
+            <a:ext cx="2340497" cy="2592195"/>
           </a:xfrm>
           <a:custGeom>
             <a:avLst/>
@@ -6474,18 +6474,18 @@
             <a:cxnLst/>
             <a:rect r="r" b="b" t="t" l="l"/>
             <a:pathLst>
-              <a:path h="4289649" w="3873132">
+              <a:path h="2592195" w="2340497">
                 <a:moveTo>
                   <a:pt x="0" y="0"/>
                 </a:moveTo>
                 <a:lnTo>
-                  <a:pt x="3873132" y="0"/>
-                </a:lnTo>
-                <a:lnTo>
-                  <a:pt x="3873132" y="4289649"/>
-                </a:lnTo>
-                <a:lnTo>
-                  <a:pt x="0" y="4289649"/>
+                  <a:pt x="2340498" y="0"/>
+                </a:lnTo>
+                <a:lnTo>
+                  <a:pt x="2340498" y="2592195"/>
+                </a:lnTo>
+                <a:lnTo>
+                  <a:pt x="0" y="2592195"/>
                 </a:lnTo>
                 <a:lnTo>
                   <a:pt x="0" y="0"/>
@@ -6516,7 +6516,7 @@
         </p:nvSpPr>
         <p:spPr>
           <a:xfrm flipH="false" flipV="false" rot="0">
-            <a:off x="5143896" y="7700469"/>
+            <a:off x="2048451" y="6513095"/>
             <a:ext cx="1510002" cy="1557831"/>
           </a:xfrm>
           <a:custGeom>
@@ -6562,8 +6562,8 @@
         </p:nvSpPr>
         <p:spPr>
           <a:xfrm flipH="false" flipV="false" rot="0">
-            <a:off x="10604811" y="143786"/>
-            <a:ext cx="5874664" cy="9999428"/>
+            <a:off x="5105746" y="639089"/>
+            <a:ext cx="12153554" cy="9008822"/>
           </a:xfrm>
           <a:custGeom>
             <a:avLst/>
@@ -6572,18 +6572,18 @@
             <a:cxnLst/>
             <a:rect r="r" b="b" t="t" l="l"/>
             <a:pathLst>
-              <a:path h="9999428" w="5874664">
+              <a:path h="9008822" w="12153554">
                 <a:moveTo>
                   <a:pt x="0" y="0"/>
                 </a:moveTo>
                 <a:lnTo>
-                  <a:pt x="5874664" y="0"/>
-                </a:lnTo>
-                <a:lnTo>
-                  <a:pt x="5874664" y="9999428"/>
-                </a:lnTo>
-                <a:lnTo>
-                  <a:pt x="0" y="9999428"/>
+                  <a:pt x="12153554" y="0"/>
+                </a:lnTo>
+                <a:lnTo>
+                  <a:pt x="12153554" y="9008822"/>
+                </a:lnTo>
+                <a:lnTo>
+                  <a:pt x="0" y="9008822"/>
                 </a:lnTo>
                 <a:lnTo>
                   <a:pt x="0" y="0"/>
@@ -6608,50 +6608,6 @@
         </p:nvSpPr>
         <p:spPr>
           <a:xfrm rot="0">
-            <a:off x="885582" y="2502601"/>
-            <a:ext cx="5252286" cy="796391"/>
-          </a:xfrm>
-          <a:prstGeom prst="rect">
-            <a:avLst/>
-          </a:prstGeom>
-        </p:spPr>
-        <p:txBody>
-          <a:bodyPr anchor="t" rtlCol="false" tIns="0" lIns="0" bIns="0" rIns="0">
-            <a:spAutoFit/>
-          </a:bodyPr>
-          <a:lstStyle/>
-          <a:p>
-            <a:pPr algn="ctr" marL="0" indent="0" lvl="0">
-              <a:lnSpc>
-                <a:spcPts val="6548"/>
-              </a:lnSpc>
-              <a:spcBef>
-                <a:spcPct val="0"/>
-              </a:spcBef>
-            </a:pPr>
-            <a:r>
-              <a:rPr lang="en-US" sz="4745" spc="37">
-                <a:solidFill>
-                  <a:srgbClr val="51786E"/>
-                </a:solidFill>
-                <a:latin typeface="Fraunces"/>
-                <a:ea typeface="Fraunces"/>
-                <a:cs typeface="Fraunces"/>
-                <a:sym typeface="Fraunces"/>
-              </a:rPr>
-              <a:t>BASE DE DATOS</a:t>
-            </a:r>
-          </a:p>
-        </p:txBody>
-      </p:sp>
-      <p:sp>
-        <p:nvSpPr>
-          <p:cNvPr name="TextBox 9" id="9"/>
-          <p:cNvSpPr txBox="true"/>
-          <p:nvPr/>
-        </p:nvSpPr>
-        <p:spPr>
-          <a:xfrm rot="0">
             <a:off x="17535126" y="9399905"/>
             <a:ext cx="752874" cy="887095"/>
           </a:xfrm>
@@ -6681,6 +6637,50 @@
                 <a:sym typeface="Open Sans Bold"/>
               </a:rPr>
               <a:t>4.</a:t>
+            </a:r>
+          </a:p>
+        </p:txBody>
+      </p:sp>
+      <p:sp>
+        <p:nvSpPr>
+          <p:cNvPr name="TextBox 9" id="9"/>
+          <p:cNvSpPr txBox="true"/>
+          <p:nvPr/>
+        </p:nvSpPr>
+        <p:spPr>
+          <a:xfrm rot="0">
+            <a:off x="112517" y="918729"/>
+            <a:ext cx="2690935" cy="1144714"/>
+          </a:xfrm>
+          <a:prstGeom prst="rect">
+            <a:avLst/>
+          </a:prstGeom>
+        </p:spPr>
+        <p:txBody>
+          <a:bodyPr anchor="t" rtlCol="false" tIns="0" lIns="0" bIns="0" rIns="0">
+            <a:spAutoFit/>
+          </a:bodyPr>
+          <a:lstStyle/>
+          <a:p>
+            <a:pPr algn="ctr" marL="0" indent="0" lvl="0">
+              <a:lnSpc>
+                <a:spcPts val="4598"/>
+              </a:lnSpc>
+              <a:spcBef>
+                <a:spcPct val="0"/>
+              </a:spcBef>
+            </a:pPr>
+            <a:r>
+              <a:rPr lang="en-US" sz="3332" spc="26">
+                <a:solidFill>
+                  <a:srgbClr val="51786E"/>
+                </a:solidFill>
+                <a:latin typeface="Fraunces"/>
+                <a:ea typeface="Fraunces"/>
+                <a:cs typeface="Fraunces"/>
+                <a:sym typeface="Fraunces"/>
+              </a:rPr>
+              <a:t>BASE DE DATOS</a:t>
             </a:r>
           </a:p>
         </p:txBody>

</xml_diff>

<commit_message>
arreglo de la presentación y resubida
</commit_message>
<xml_diff>
--- a/documentacion_extra/presentacion/cuidaDos.pptx
+++ b/documentacion_extra/presentacion/cuidaDos.pptx
@@ -5728,7 +5728,7 @@
                   <a:cs typeface="Poppins Bold"/>
                   <a:sym typeface="Poppins Bold"/>
                 </a:rPr>
-                <a:t>Clientes</a:t>
+                <a:t>CLIENTE</a:t>
               </a:r>
             </a:p>
           </p:txBody>
@@ -8274,308 +8274,6 @@
 </file>
 
 <file path=ppt/slides/slide8.xml><?xml version="1.0" encoding="utf-8"?>
-<p:sld xmlns:p="http://schemas.openxmlformats.org/presentationml/2006/main" xmlns:a="http://schemas.openxmlformats.org/drawingml/2006/main" xmlns:r="http://schemas.openxmlformats.org/officeDocument/2006/relationships">
-  <p:cSld>
-    <p:bg>
-      <p:bgPr>
-        <a:solidFill>
-          <a:srgbClr val="344F51"/>
-        </a:solidFill>
-      </p:bgPr>
-    </p:bg>
-    <p:spTree>
-      <p:nvGrpSpPr>
-        <p:cNvPr id="1" name=""/>
-        <p:cNvGrpSpPr/>
-        <p:nvPr/>
-      </p:nvGrpSpPr>
-      <p:grpSpPr>
-        <a:xfrm>
-          <a:off x="0" y="0"/>
-          <a:ext cx="0" cy="0"/>
-          <a:chOff x="0" y="0"/>
-          <a:chExt cx="0" cy="0"/>
-        </a:xfrm>
-      </p:grpSpPr>
-      <p:grpSp>
-        <p:nvGrpSpPr>
-          <p:cNvPr name="Group 2" id="2"/>
-          <p:cNvGrpSpPr/>
-          <p:nvPr/>
-        </p:nvGrpSpPr>
-        <p:grpSpPr>
-          <a:xfrm rot="0">
-            <a:off x="3826496" y="2463569"/>
-            <a:ext cx="11196945" cy="6310665"/>
-            <a:chOff x="0" y="0"/>
-            <a:chExt cx="2948990" cy="1662068"/>
-          </a:xfrm>
-        </p:grpSpPr>
-        <p:sp>
-          <p:nvSpPr>
-            <p:cNvPr name="Freeform 3" id="3"/>
-            <p:cNvSpPr/>
-            <p:nvPr/>
-          </p:nvSpPr>
-          <p:spPr>
-            <a:xfrm flipH="false" flipV="false" rot="0">
-              <a:off x="0" y="0"/>
-              <a:ext cx="2948990" cy="1662068"/>
-            </a:xfrm>
-            <a:custGeom>
-              <a:avLst/>
-              <a:gdLst/>
-              <a:ahLst/>
-              <a:cxnLst/>
-              <a:rect r="r" b="b" t="t" l="l"/>
-              <a:pathLst>
-                <a:path h="1662068" w="2948990">
-                  <a:moveTo>
-                    <a:pt x="0" y="0"/>
-                  </a:moveTo>
-                  <a:lnTo>
-                    <a:pt x="2948990" y="0"/>
-                  </a:lnTo>
-                  <a:lnTo>
-                    <a:pt x="2948990" y="1662068"/>
-                  </a:lnTo>
-                  <a:lnTo>
-                    <a:pt x="0" y="1662068"/>
-                  </a:lnTo>
-                  <a:close/>
-                </a:path>
-              </a:pathLst>
-            </a:custGeom>
-            <a:solidFill>
-              <a:srgbClr val="FFFFFF"/>
-            </a:solidFill>
-          </p:spPr>
-        </p:sp>
-        <p:sp>
-          <p:nvSpPr>
-            <p:cNvPr name="TextBox 4" id="4"/>
-            <p:cNvSpPr txBox="true"/>
-            <p:nvPr/>
-          </p:nvSpPr>
-          <p:spPr>
-            <a:xfrm>
-              <a:off x="0" y="-19050"/>
-              <a:ext cx="2948990" cy="1681118"/>
-            </a:xfrm>
-            <a:prstGeom prst="rect">
-              <a:avLst/>
-            </a:prstGeom>
-          </p:spPr>
-          <p:txBody>
-            <a:bodyPr anchor="ctr" rtlCol="false" tIns="50800" lIns="50800" bIns="50800" rIns="50800"/>
-            <a:lstStyle/>
-            <a:p>
-              <a:pPr algn="ctr">
-                <a:lnSpc>
-                  <a:spcPts val="2859"/>
-                </a:lnSpc>
-              </a:pPr>
-            </a:p>
-          </p:txBody>
-        </p:sp>
-      </p:grpSp>
-      <p:sp>
-        <p:nvSpPr>
-          <p:cNvPr name="Freeform 5" id="5"/>
-          <p:cNvSpPr/>
-          <p:nvPr/>
-        </p:nvSpPr>
-        <p:spPr>
-          <a:xfrm flipH="false" flipV="false" rot="0">
-            <a:off x="11869158" y="5427811"/>
-            <a:ext cx="1699666" cy="1699666"/>
-          </a:xfrm>
-          <a:custGeom>
-            <a:avLst/>
-            <a:gdLst/>
-            <a:ahLst/>
-            <a:cxnLst/>
-            <a:rect r="r" b="b" t="t" l="l"/>
-            <a:pathLst>
-              <a:path h="1699666" w="1699666">
-                <a:moveTo>
-                  <a:pt x="0" y="0"/>
-                </a:moveTo>
-                <a:lnTo>
-                  <a:pt x="1699666" y="0"/>
-                </a:lnTo>
-                <a:lnTo>
-                  <a:pt x="1699666" y="1699666"/>
-                </a:lnTo>
-                <a:lnTo>
-                  <a:pt x="0" y="1699666"/>
-                </a:lnTo>
-                <a:lnTo>
-                  <a:pt x="0" y="0"/>
-                </a:lnTo>
-                <a:close/>
-              </a:path>
-            </a:pathLst>
-          </a:custGeom>
-          <a:blipFill>
-            <a:blip r:embed="rId2"/>
-            <a:stretch>
-              <a:fillRect l="0" t="0" r="0" b="0"/>
-            </a:stretch>
-          </a:blipFill>
-        </p:spPr>
-      </p:sp>
-      <p:sp>
-        <p:nvSpPr>
-          <p:cNvPr name="Freeform 6" id="6">
-            <a:hlinkClick r:id="rId4" tooltip="https://www.conectacuidados.eu"/>
-          </p:cNvPr>
-          <p:cNvSpPr/>
-          <p:nvPr/>
-        </p:nvSpPr>
-        <p:spPr>
-          <a:xfrm flipH="false" flipV="false" rot="0">
-            <a:off x="5570665" y="4603389"/>
-            <a:ext cx="5936428" cy="3730691"/>
-          </a:xfrm>
-          <a:custGeom>
-            <a:avLst/>
-            <a:gdLst/>
-            <a:ahLst/>
-            <a:cxnLst/>
-            <a:rect r="r" b="b" t="t" l="l"/>
-            <a:pathLst>
-              <a:path h="3730691" w="5936428">
-                <a:moveTo>
-                  <a:pt x="0" y="0"/>
-                </a:moveTo>
-                <a:lnTo>
-                  <a:pt x="5936427" y="0"/>
-                </a:lnTo>
-                <a:lnTo>
-                  <a:pt x="5936427" y="3730691"/>
-                </a:lnTo>
-                <a:lnTo>
-                  <a:pt x="0" y="3730691"/>
-                </a:lnTo>
-                <a:lnTo>
-                  <a:pt x="0" y="0"/>
-                </a:lnTo>
-                <a:close/>
-              </a:path>
-            </a:pathLst>
-          </a:custGeom>
-          <a:blipFill>
-            <a:blip r:embed="rId3"/>
-            <a:stretch>
-              <a:fillRect l="0" t="0" r="0" b="0"/>
-            </a:stretch>
-          </a:blipFill>
-        </p:spPr>
-      </p:sp>
-      <p:sp>
-        <p:nvSpPr>
-          <p:cNvPr name="TextBox 7" id="7"/>
-          <p:cNvSpPr txBox="true"/>
-          <p:nvPr/>
-        </p:nvSpPr>
-        <p:spPr>
-          <a:xfrm rot="0">
-            <a:off x="6782564" y="3038086"/>
-            <a:ext cx="5936428" cy="1152525"/>
-          </a:xfrm>
-          <a:prstGeom prst="rect">
-            <a:avLst/>
-          </a:prstGeom>
-        </p:spPr>
-        <p:txBody>
-          <a:bodyPr anchor="t" rtlCol="false" tIns="0" lIns="0" bIns="0" rIns="0">
-            <a:spAutoFit/>
-          </a:bodyPr>
-          <a:lstStyle/>
-          <a:p>
-            <a:pPr algn="ctr">
-              <a:lnSpc>
-                <a:spcPts val="9119"/>
-              </a:lnSpc>
-            </a:pPr>
-            <a:r>
-              <a:rPr lang="en-US" b="true" sz="7599" spc="-151">
-                <a:solidFill>
-                  <a:srgbClr val="344F51"/>
-                </a:solidFill>
-                <a:latin typeface="Montserrat Bold"/>
-                <a:ea typeface="Montserrat Bold"/>
-                <a:cs typeface="Montserrat Bold"/>
-                <a:sym typeface="Montserrat Bold"/>
-              </a:rPr>
-              <a:t>CUIDA</a:t>
-            </a:r>
-            <a:r>
-              <a:rPr lang="en-US" b="true" sz="7599" spc="-151">
-                <a:solidFill>
-                  <a:srgbClr val="93D14B"/>
-                </a:solidFill>
-                <a:latin typeface="Montserrat Bold"/>
-                <a:ea typeface="Montserrat Bold"/>
-                <a:cs typeface="Montserrat Bold"/>
-                <a:sym typeface="Montserrat Bold"/>
-              </a:rPr>
-              <a:t>DOS</a:t>
-            </a:r>
-          </a:p>
-        </p:txBody>
-      </p:sp>
-      <p:sp>
-        <p:nvSpPr>
-          <p:cNvPr name="TextBox 8" id="8"/>
-          <p:cNvSpPr txBox="true"/>
-          <p:nvPr/>
-        </p:nvSpPr>
-        <p:spPr>
-          <a:xfrm rot="0">
-            <a:off x="17535126" y="9399905"/>
-            <a:ext cx="752874" cy="887095"/>
-          </a:xfrm>
-          <a:prstGeom prst="rect">
-            <a:avLst/>
-          </a:prstGeom>
-        </p:spPr>
-        <p:txBody>
-          <a:bodyPr anchor="t" rtlCol="false" tIns="0" lIns="0" bIns="0" rIns="0">
-            <a:spAutoFit/>
-          </a:bodyPr>
-          <a:lstStyle/>
-          <a:p>
-            <a:pPr algn="ctr">
-              <a:lnSpc>
-                <a:spcPts val="7279"/>
-              </a:lnSpc>
-            </a:pPr>
-            <a:r>
-              <a:rPr lang="en-US" b="true" sz="5199">
-                <a:solidFill>
-                  <a:srgbClr val="93D14B"/>
-                </a:solidFill>
-                <a:latin typeface="Open Sans Bold"/>
-                <a:ea typeface="Open Sans Bold"/>
-                <a:cs typeface="Open Sans Bold"/>
-                <a:sym typeface="Open Sans Bold"/>
-              </a:rPr>
-              <a:t>6.</a:t>
-            </a:r>
-          </a:p>
-        </p:txBody>
-      </p:sp>
-    </p:spTree>
-  </p:cSld>
-  <p:clrMapOvr>
-    <a:masterClrMapping/>
-  </p:clrMapOvr>
-</p:sld>
-</file>
-
-<file path=ppt/slides/slide9.xml><?xml version="1.0" encoding="utf-8"?>
 <p:sld xmlns:p="http://schemas.openxmlformats.org/presentationml/2006/main" xmlns:a="http://schemas.openxmlformats.org/drawingml/2006/main">
   <p:cSld>
     <p:bg>
@@ -8978,6 +8676,18 @@
               </a:lnSpc>
             </a:pPr>
             <a:r>
+              <a:rPr lang="en-US" sz="5199" b="true">
+                <a:solidFill>
+                  <a:srgbClr val="93D14B"/>
+                </a:solidFill>
+                <a:latin typeface="Open Sans Bold"/>
+                <a:ea typeface="Open Sans Bold"/>
+                <a:cs typeface="Open Sans Bold"/>
+                <a:sym typeface="Open Sans Bold"/>
+              </a:rPr>
+              <a:t>6</a:t>
+            </a:r>
+            <a:r>
               <a:rPr lang="en-US" b="true" sz="5199">
                 <a:solidFill>
                   <a:srgbClr val="93D14B"/>
@@ -8987,7 +8697,321 @@
                 <a:cs typeface="Open Sans Bold"/>
                 <a:sym typeface="Open Sans Bold"/>
               </a:rPr>
-              <a:t>7.</a:t>
+              <a:t>.</a:t>
+            </a:r>
+          </a:p>
+        </p:txBody>
+      </p:sp>
+    </p:spTree>
+  </p:cSld>
+  <p:clrMapOvr>
+    <a:masterClrMapping/>
+  </p:clrMapOvr>
+</p:sld>
+</file>
+
+<file path=ppt/slides/slide9.xml><?xml version="1.0" encoding="utf-8"?>
+<p:sld xmlns:p="http://schemas.openxmlformats.org/presentationml/2006/main" xmlns:a="http://schemas.openxmlformats.org/drawingml/2006/main" xmlns:r="http://schemas.openxmlformats.org/officeDocument/2006/relationships">
+  <p:cSld>
+    <p:bg>
+      <p:bgPr>
+        <a:solidFill>
+          <a:srgbClr val="344F51"/>
+        </a:solidFill>
+      </p:bgPr>
+    </p:bg>
+    <p:spTree>
+      <p:nvGrpSpPr>
+        <p:cNvPr id="1" name=""/>
+        <p:cNvGrpSpPr/>
+        <p:nvPr/>
+      </p:nvGrpSpPr>
+      <p:grpSpPr>
+        <a:xfrm>
+          <a:off x="0" y="0"/>
+          <a:ext cx="0" cy="0"/>
+          <a:chOff x="0" y="0"/>
+          <a:chExt cx="0" cy="0"/>
+        </a:xfrm>
+      </p:grpSpPr>
+      <p:grpSp>
+        <p:nvGrpSpPr>
+          <p:cNvPr name="Group 2" id="2"/>
+          <p:cNvGrpSpPr/>
+          <p:nvPr/>
+        </p:nvGrpSpPr>
+        <p:grpSpPr>
+          <a:xfrm rot="0">
+            <a:off x="3826496" y="2463569"/>
+            <a:ext cx="11196945" cy="6310665"/>
+            <a:chOff x="0" y="0"/>
+            <a:chExt cx="2948990" cy="1662068"/>
+          </a:xfrm>
+        </p:grpSpPr>
+        <p:sp>
+          <p:nvSpPr>
+            <p:cNvPr name="Freeform 3" id="3"/>
+            <p:cNvSpPr/>
+            <p:nvPr/>
+          </p:nvSpPr>
+          <p:spPr>
+            <a:xfrm flipH="false" flipV="false" rot="0">
+              <a:off x="0" y="0"/>
+              <a:ext cx="2948990" cy="1662068"/>
+            </a:xfrm>
+            <a:custGeom>
+              <a:avLst/>
+              <a:gdLst/>
+              <a:ahLst/>
+              <a:cxnLst/>
+              <a:rect r="r" b="b" t="t" l="l"/>
+              <a:pathLst>
+                <a:path h="1662068" w="2948990">
+                  <a:moveTo>
+                    <a:pt x="0" y="0"/>
+                  </a:moveTo>
+                  <a:lnTo>
+                    <a:pt x="2948990" y="0"/>
+                  </a:lnTo>
+                  <a:lnTo>
+                    <a:pt x="2948990" y="1662068"/>
+                  </a:lnTo>
+                  <a:lnTo>
+                    <a:pt x="0" y="1662068"/>
+                  </a:lnTo>
+                  <a:close/>
+                </a:path>
+              </a:pathLst>
+            </a:custGeom>
+            <a:solidFill>
+              <a:srgbClr val="FFFFFF"/>
+            </a:solidFill>
+          </p:spPr>
+        </p:sp>
+        <p:sp>
+          <p:nvSpPr>
+            <p:cNvPr name="TextBox 4" id="4"/>
+            <p:cNvSpPr txBox="true"/>
+            <p:nvPr/>
+          </p:nvSpPr>
+          <p:spPr>
+            <a:xfrm>
+              <a:off x="0" y="-19050"/>
+              <a:ext cx="2948990" cy="1681118"/>
+            </a:xfrm>
+            <a:prstGeom prst="rect">
+              <a:avLst/>
+            </a:prstGeom>
+          </p:spPr>
+          <p:txBody>
+            <a:bodyPr anchor="ctr" rtlCol="false" tIns="50800" lIns="50800" bIns="50800" rIns="50800"/>
+            <a:lstStyle/>
+            <a:p>
+              <a:pPr algn="ctr">
+                <a:lnSpc>
+                  <a:spcPts val="2859"/>
+                </a:lnSpc>
+              </a:pPr>
+            </a:p>
+          </p:txBody>
+        </p:sp>
+      </p:grpSp>
+      <p:sp>
+        <p:nvSpPr>
+          <p:cNvPr name="Freeform 5" id="5"/>
+          <p:cNvSpPr/>
+          <p:nvPr/>
+        </p:nvSpPr>
+        <p:spPr>
+          <a:xfrm flipH="false" flipV="false" rot="0">
+            <a:off x="11869158" y="5427811"/>
+            <a:ext cx="1699666" cy="1699666"/>
+          </a:xfrm>
+          <a:custGeom>
+            <a:avLst/>
+            <a:gdLst/>
+            <a:ahLst/>
+            <a:cxnLst/>
+            <a:rect r="r" b="b" t="t" l="l"/>
+            <a:pathLst>
+              <a:path h="1699666" w="1699666">
+                <a:moveTo>
+                  <a:pt x="0" y="0"/>
+                </a:moveTo>
+                <a:lnTo>
+                  <a:pt x="1699666" y="0"/>
+                </a:lnTo>
+                <a:lnTo>
+                  <a:pt x="1699666" y="1699666"/>
+                </a:lnTo>
+                <a:lnTo>
+                  <a:pt x="0" y="1699666"/>
+                </a:lnTo>
+                <a:lnTo>
+                  <a:pt x="0" y="0"/>
+                </a:lnTo>
+                <a:close/>
+              </a:path>
+            </a:pathLst>
+          </a:custGeom>
+          <a:blipFill>
+            <a:blip r:embed="rId2"/>
+            <a:stretch>
+              <a:fillRect l="0" t="0" r="0" b="0"/>
+            </a:stretch>
+          </a:blipFill>
+        </p:spPr>
+      </p:sp>
+      <p:sp>
+        <p:nvSpPr>
+          <p:cNvPr name="Freeform 6" id="6">
+            <a:hlinkClick r:id="rId4" tooltip="https://www.conectacuidados.eu"/>
+          </p:cNvPr>
+          <p:cNvSpPr/>
+          <p:nvPr/>
+        </p:nvSpPr>
+        <p:spPr>
+          <a:xfrm flipH="false" flipV="false" rot="0">
+            <a:off x="5570665" y="4603389"/>
+            <a:ext cx="5936428" cy="3730691"/>
+          </a:xfrm>
+          <a:custGeom>
+            <a:avLst/>
+            <a:gdLst/>
+            <a:ahLst/>
+            <a:cxnLst/>
+            <a:rect r="r" b="b" t="t" l="l"/>
+            <a:pathLst>
+              <a:path h="3730691" w="5936428">
+                <a:moveTo>
+                  <a:pt x="0" y="0"/>
+                </a:moveTo>
+                <a:lnTo>
+                  <a:pt x="5936427" y="0"/>
+                </a:lnTo>
+                <a:lnTo>
+                  <a:pt x="5936427" y="3730691"/>
+                </a:lnTo>
+                <a:lnTo>
+                  <a:pt x="0" y="3730691"/>
+                </a:lnTo>
+                <a:lnTo>
+                  <a:pt x="0" y="0"/>
+                </a:lnTo>
+                <a:close/>
+              </a:path>
+            </a:pathLst>
+          </a:custGeom>
+          <a:blipFill>
+            <a:blip r:embed="rId3"/>
+            <a:stretch>
+              <a:fillRect l="0" t="0" r="0" b="0"/>
+            </a:stretch>
+          </a:blipFill>
+        </p:spPr>
+      </p:sp>
+      <p:sp>
+        <p:nvSpPr>
+          <p:cNvPr name="TextBox 7" id="7"/>
+          <p:cNvSpPr txBox="true"/>
+          <p:nvPr/>
+        </p:nvSpPr>
+        <p:spPr>
+          <a:xfrm rot="0">
+            <a:off x="6782564" y="3038086"/>
+            <a:ext cx="5936428" cy="1152525"/>
+          </a:xfrm>
+          <a:prstGeom prst="rect">
+            <a:avLst/>
+          </a:prstGeom>
+        </p:spPr>
+        <p:txBody>
+          <a:bodyPr anchor="t" rtlCol="false" tIns="0" lIns="0" bIns="0" rIns="0">
+            <a:spAutoFit/>
+          </a:bodyPr>
+          <a:lstStyle/>
+          <a:p>
+            <a:pPr algn="ctr">
+              <a:lnSpc>
+                <a:spcPts val="9119"/>
+              </a:lnSpc>
+            </a:pPr>
+            <a:r>
+              <a:rPr lang="en-US" b="true" sz="7599" spc="-151">
+                <a:solidFill>
+                  <a:srgbClr val="344F51"/>
+                </a:solidFill>
+                <a:latin typeface="Montserrat Bold"/>
+                <a:ea typeface="Montserrat Bold"/>
+                <a:cs typeface="Montserrat Bold"/>
+                <a:sym typeface="Montserrat Bold"/>
+              </a:rPr>
+              <a:t>CUIDA</a:t>
+            </a:r>
+            <a:r>
+              <a:rPr lang="en-US" b="true" sz="7599" spc="-151">
+                <a:solidFill>
+                  <a:srgbClr val="93D14B"/>
+                </a:solidFill>
+                <a:latin typeface="Montserrat Bold"/>
+                <a:ea typeface="Montserrat Bold"/>
+                <a:cs typeface="Montserrat Bold"/>
+                <a:sym typeface="Montserrat Bold"/>
+              </a:rPr>
+              <a:t>DOS</a:t>
+            </a:r>
+          </a:p>
+        </p:txBody>
+      </p:sp>
+      <p:sp>
+        <p:nvSpPr>
+          <p:cNvPr name="TextBox 8" id="8"/>
+          <p:cNvSpPr txBox="true"/>
+          <p:nvPr/>
+        </p:nvSpPr>
+        <p:spPr>
+          <a:xfrm rot="0">
+            <a:off x="17535126" y="9399905"/>
+            <a:ext cx="752874" cy="887095"/>
+          </a:xfrm>
+          <a:prstGeom prst="rect">
+            <a:avLst/>
+          </a:prstGeom>
+        </p:spPr>
+        <p:txBody>
+          <a:bodyPr anchor="t" rtlCol="false" tIns="0" lIns="0" bIns="0" rIns="0">
+            <a:spAutoFit/>
+          </a:bodyPr>
+          <a:lstStyle/>
+          <a:p>
+            <a:pPr algn="ctr">
+              <a:lnSpc>
+                <a:spcPts val="7279"/>
+              </a:lnSpc>
+            </a:pPr>
+            <a:r>
+              <a:rPr lang="en-US" sz="5199" b="true">
+                <a:solidFill>
+                  <a:srgbClr val="93D14B"/>
+                </a:solidFill>
+                <a:latin typeface="Open Sans Bold"/>
+                <a:ea typeface="Open Sans Bold"/>
+                <a:cs typeface="Open Sans Bold"/>
+                <a:sym typeface="Open Sans Bold"/>
+              </a:rPr>
+              <a:t>7</a:t>
+            </a:r>
+            <a:r>
+              <a:rPr lang="en-US" b="true" sz="5199">
+                <a:solidFill>
+                  <a:srgbClr val="93D14B"/>
+                </a:solidFill>
+                <a:latin typeface="Open Sans Bold"/>
+                <a:ea typeface="Open Sans Bold"/>
+                <a:cs typeface="Open Sans Bold"/>
+                <a:sym typeface="Open Sans Bold"/>
+              </a:rPr>
+              <a:t>.</a:t>
             </a:r>
           </a:p>
         </p:txBody>

</xml_diff>

<commit_message>
actualziaci´on de la presentación pdf y ppt
</commit_message>
<xml_diff>
--- a/documentacion_extra/presentacion/cuidaDos.pptx
+++ b/documentacion_extra/presentacion/cuidaDos.pptx
@@ -3333,10 +3333,10 @@
         </p:nvGrpSpPr>
         <p:grpSpPr>
           <a:xfrm rot="0">
-            <a:off x="11912991" y="7131081"/>
-            <a:ext cx="920403" cy="920403"/>
+            <a:off x="12024461" y="7288212"/>
+            <a:ext cx="952251" cy="920403"/>
             <a:chOff x="0" y="0"/>
-            <a:chExt cx="812800" cy="812800"/>
+            <a:chExt cx="840925" cy="812800"/>
           </a:xfrm>
         </p:grpSpPr>
         <p:sp>
@@ -3348,7 +3348,7 @@
           <p:spPr>
             <a:xfrm flipH="false" flipV="false" rot="0">
               <a:off x="0" y="0"/>
-              <a:ext cx="812800" cy="812800"/>
+              <a:ext cx="840925" cy="812800"/>
             </a:xfrm>
             <a:custGeom>
               <a:avLst/>
@@ -3357,15 +3357,15 @@
               <a:cxnLst/>
               <a:rect r="r" b="b" t="t" l="l"/>
               <a:pathLst>
-                <a:path h="812800" w="812800">
+                <a:path h="812800" w="840925">
                   <a:moveTo>
-                    <a:pt x="812800" y="406400"/>
+                    <a:pt x="840925" y="406400"/>
                   </a:moveTo>
                   <a:lnTo>
-                    <a:pt x="406400" y="0"/>
-                  </a:lnTo>
-                  <a:lnTo>
-                    <a:pt x="406400" y="203200"/>
+                    <a:pt x="434525" y="0"/>
+                  </a:lnTo>
+                  <a:lnTo>
+                    <a:pt x="434525" y="203200"/>
                   </a:lnTo>
                   <a:lnTo>
                     <a:pt x="0" y="203200"/>
@@ -3374,13 +3374,13 @@
                     <a:pt x="0" y="609600"/>
                   </a:lnTo>
                   <a:lnTo>
-                    <a:pt x="406400" y="609600"/>
-                  </a:lnTo>
-                  <a:lnTo>
-                    <a:pt x="406400" y="812800"/>
-                  </a:lnTo>
-                  <a:lnTo>
-                    <a:pt x="812800" y="406400"/>
+                    <a:pt x="434525" y="609600"/>
+                  </a:lnTo>
+                  <a:lnTo>
+                    <a:pt x="434525" y="812800"/>
+                  </a:lnTo>
+                  <a:lnTo>
+                    <a:pt x="840925" y="406400"/>
                   </a:lnTo>
                   <a:close/>
                 </a:path>
@@ -3400,7 +3400,7 @@
           <p:spPr>
             <a:xfrm>
               <a:off x="0" y="184150"/>
-              <a:ext cx="711200" cy="425450"/>
+              <a:ext cx="739325" cy="425450"/>
             </a:xfrm>
             <a:prstGeom prst="rect">
               <a:avLst/>
@@ -3526,7 +3526,7 @@
         </p:nvSpPr>
         <p:spPr>
           <a:xfrm rot="0">
-            <a:off x="8090223" y="5662612"/>
+            <a:off x="7946905" y="5662612"/>
             <a:ext cx="5241880" cy="514350"/>
           </a:xfrm>
           <a:prstGeom prst="rect">
@@ -3555,6 +3555,85 @@
                 <a:sym typeface="Montserrat Bold"/>
               </a:rPr>
               <a:t>Evelia Gil Paredes</a:t>
+            </a:r>
+          </a:p>
+        </p:txBody>
+      </p:sp>
+      <p:sp>
+        <p:nvSpPr>
+          <p:cNvPr name="TextBox 14" id="14"/>
+          <p:cNvSpPr txBox="true"/>
+          <p:nvPr/>
+        </p:nvSpPr>
+        <p:spPr>
+          <a:xfrm rot="0">
+            <a:off x="8806814" y="6243638"/>
+            <a:ext cx="4381971" cy="1397000"/>
+          </a:xfrm>
+          <a:prstGeom prst="rect">
+            <a:avLst/>
+          </a:prstGeom>
+        </p:spPr>
+        <p:txBody>
+          <a:bodyPr anchor="t" rtlCol="false" tIns="0" lIns="0" bIns="0" rIns="0">
+            <a:spAutoFit/>
+          </a:bodyPr>
+          <a:lstStyle/>
+          <a:p>
+            <a:pPr algn="l">
+              <a:lnSpc>
+                <a:spcPts val="2800"/>
+              </a:lnSpc>
+            </a:pPr>
+            <a:r>
+              <a:rPr lang="en-US" sz="2000" b="true">
+                <a:solidFill>
+                  <a:srgbClr val="51786E"/>
+                </a:solidFill>
+                <a:latin typeface="Montserrat Bold"/>
+                <a:ea typeface="Montserrat Bold"/>
+                <a:cs typeface="Montserrat Bold"/>
+                <a:sym typeface="Montserrat Bold"/>
+              </a:rPr>
+              <a:t>IES Albarregas</a:t>
+            </a:r>
+          </a:p>
+          <a:p>
+            <a:pPr algn="l">
+              <a:lnSpc>
+                <a:spcPts val="2800"/>
+              </a:lnSpc>
+            </a:pPr>
+            <a:r>
+              <a:rPr lang="en-US" sz="2000" b="true">
+                <a:solidFill>
+                  <a:srgbClr val="51786E"/>
+                </a:solidFill>
+                <a:latin typeface="Montserrat Bold"/>
+                <a:ea typeface="Montserrat Bold"/>
+                <a:cs typeface="Montserrat Bold"/>
+                <a:sym typeface="Montserrat Bold"/>
+              </a:rPr>
+              <a:t>Técnico Superior en Desarrollo de Aplicaciones Web</a:t>
+            </a:r>
+          </a:p>
+          <a:p>
+            <a:pPr algn="l">
+              <a:lnSpc>
+                <a:spcPts val="2800"/>
+              </a:lnSpc>
+            </a:pPr>
+            <a:r>
+              <a:rPr lang="en-US" sz="2000" b="true">
+                <a:solidFill>
+                  <a:srgbClr val="51786E"/>
+                </a:solidFill>
+                <a:latin typeface="Montserrat Bold"/>
+                <a:ea typeface="Montserrat Bold"/>
+                <a:cs typeface="Montserrat Bold"/>
+                <a:sym typeface="Montserrat Bold"/>
+              </a:rPr>
+              <a:t>Curso: 25/26</a:t>
             </a:r>
           </a:p>
         </p:txBody>
@@ -3727,7 +3806,7 @@
         </p:nvSpPr>
         <p:spPr>
           <a:xfrm flipH="false" flipV="false" rot="0">
-            <a:off x="3980832" y="2807187"/>
+            <a:off x="3826496" y="3282589"/>
             <a:ext cx="3618799" cy="4672626"/>
           </a:xfrm>
           <a:custGeom>
@@ -3742,13 +3821,13 @@
                   <a:pt x="0" y="0"/>
                 </a:moveTo>
                 <a:lnTo>
-                  <a:pt x="3618799" y="0"/>
-                </a:lnTo>
-                <a:lnTo>
-                  <a:pt x="3618799" y="4672626"/>
-                </a:lnTo>
-                <a:lnTo>
-                  <a:pt x="0" y="4672626"/>
+                  <a:pt x="3618800" y="0"/>
+                </a:lnTo>
+                <a:lnTo>
+                  <a:pt x="3618800" y="4672625"/>
+                </a:lnTo>
+                <a:lnTo>
+                  <a:pt x="0" y="4672625"/>
                 </a:lnTo>
                 <a:lnTo>
                   <a:pt x="0" y="0"/>
@@ -3811,109 +3890,15 @@
           </a:blipFill>
         </p:spPr>
       </p:sp>
-      <p:grpSp>
-        <p:nvGrpSpPr>
-          <p:cNvPr name="Group 8" id="8"/>
-          <p:cNvGrpSpPr/>
-          <p:nvPr/>
-        </p:nvGrpSpPr>
-        <p:grpSpPr>
-          <a:xfrm rot="0">
-            <a:off x="11912991" y="7131081"/>
-            <a:ext cx="920403" cy="920403"/>
-            <a:chOff x="0" y="0"/>
-            <a:chExt cx="812800" cy="812800"/>
-          </a:xfrm>
-        </p:grpSpPr>
-        <p:sp>
-          <p:nvSpPr>
-            <p:cNvPr name="Freeform 9" id="9"/>
-            <p:cNvSpPr/>
-            <p:nvPr/>
-          </p:nvSpPr>
-          <p:spPr>
-            <a:xfrm flipH="false" flipV="false" rot="0">
-              <a:off x="0" y="0"/>
-              <a:ext cx="812800" cy="812800"/>
-            </a:xfrm>
-            <a:custGeom>
-              <a:avLst/>
-              <a:gdLst/>
-              <a:ahLst/>
-              <a:cxnLst/>
-              <a:rect r="r" b="b" t="t" l="l"/>
-              <a:pathLst>
-                <a:path h="812800" w="812800">
-                  <a:moveTo>
-                    <a:pt x="812800" y="406400"/>
-                  </a:moveTo>
-                  <a:lnTo>
-                    <a:pt x="406400" y="0"/>
-                  </a:lnTo>
-                  <a:lnTo>
-                    <a:pt x="406400" y="203200"/>
-                  </a:lnTo>
-                  <a:lnTo>
-                    <a:pt x="0" y="203200"/>
-                  </a:lnTo>
-                  <a:lnTo>
-                    <a:pt x="0" y="609600"/>
-                  </a:lnTo>
-                  <a:lnTo>
-                    <a:pt x="406400" y="609600"/>
-                  </a:lnTo>
-                  <a:lnTo>
-                    <a:pt x="406400" y="812800"/>
-                  </a:lnTo>
-                  <a:lnTo>
-                    <a:pt x="812800" y="406400"/>
-                  </a:lnTo>
-                  <a:close/>
-                </a:path>
-              </a:pathLst>
-            </a:custGeom>
-            <a:solidFill>
-              <a:srgbClr val="51786E"/>
-            </a:solidFill>
-          </p:spPr>
-        </p:sp>
-        <p:sp>
-          <p:nvSpPr>
-            <p:cNvPr name="TextBox 10" id="10"/>
-            <p:cNvSpPr txBox="true"/>
-            <p:nvPr/>
-          </p:nvSpPr>
-          <p:spPr>
-            <a:xfrm>
-              <a:off x="0" y="184150"/>
-              <a:ext cx="711200" cy="425450"/>
-            </a:xfrm>
-            <a:prstGeom prst="rect">
-              <a:avLst/>
-            </a:prstGeom>
-          </p:spPr>
-          <p:txBody>
-            <a:bodyPr anchor="ctr" rtlCol="false" tIns="50800" lIns="50800" bIns="50800" rIns="50800"/>
-            <a:lstStyle/>
-            <a:p>
-              <a:pPr algn="ctr">
-                <a:lnSpc>
-                  <a:spcPts val="2859"/>
-                </a:lnSpc>
-              </a:pPr>
-            </a:p>
-          </p:txBody>
-        </p:sp>
-      </p:grpSp>
-      <p:sp>
-        <p:nvSpPr>
-          <p:cNvPr name="Freeform 11" id="11"/>
+      <p:sp>
+        <p:nvSpPr>
+          <p:cNvPr name="Freeform 8" id="8"/>
           <p:cNvSpPr/>
           <p:nvPr/>
         </p:nvSpPr>
         <p:spPr>
           <a:xfrm flipH="false" flipV="false" rot="0">
-            <a:off x="13118589" y="6896711"/>
+            <a:off x="13323775" y="7074568"/>
             <a:ext cx="1699666" cy="1699666"/>
           </a:xfrm>
           <a:custGeom>
@@ -3953,97 +3938,55 @@
       </p:sp>
       <p:sp>
         <p:nvSpPr>
-          <p:cNvPr name="TextBox 12" id="12"/>
-          <p:cNvSpPr txBox="true"/>
+          <p:cNvPr name="Freeform 9" id="9"/>
+          <p:cNvSpPr/>
           <p:nvPr/>
         </p:nvSpPr>
         <p:spPr>
-          <a:xfrm rot="0">
-            <a:off x="7599631" y="4466377"/>
-            <a:ext cx="5936428" cy="1152525"/>
-          </a:xfrm>
-          <a:prstGeom prst="rect">
+          <a:xfrm flipH="false" flipV="false" rot="0">
+            <a:off x="7330495" y="4405482"/>
+            <a:ext cx="6508706" cy="2828329"/>
+          </a:xfrm>
+          <a:custGeom>
             <a:avLst/>
-          </a:prstGeom>
+            <a:gdLst/>
+            <a:ahLst/>
+            <a:cxnLst/>
+            <a:rect r="r" b="b" t="t" l="l"/>
+            <a:pathLst>
+              <a:path h="2828329" w="6508706">
+                <a:moveTo>
+                  <a:pt x="0" y="0"/>
+                </a:moveTo>
+                <a:lnTo>
+                  <a:pt x="6508706" y="0"/>
+                </a:lnTo>
+                <a:lnTo>
+                  <a:pt x="6508706" y="2828328"/>
+                </a:lnTo>
+                <a:lnTo>
+                  <a:pt x="0" y="2828328"/>
+                </a:lnTo>
+                <a:lnTo>
+                  <a:pt x="0" y="0"/>
+                </a:lnTo>
+                <a:close/>
+              </a:path>
+            </a:pathLst>
+          </a:custGeom>
+          <a:blipFill>
+            <a:blip r:embed="rId6">
+              <a:extLst>
+                <a:ext uri="{96DAC541-7B7A-43D3-8B79-37D633B846F1}">
+                  <asvg:svgBlip xmlns:asvg="http://schemas.microsoft.com/office/drawing/2016/SVG/main" r:embed="rId7"/>
+                </a:ext>
+              </a:extLst>
+            </a:blip>
+            <a:stretch>
+              <a:fillRect l="0" t="0" r="0" b="0"/>
+            </a:stretch>
+          </a:blipFill>
         </p:spPr>
-        <p:txBody>
-          <a:bodyPr anchor="t" rtlCol="false" tIns="0" lIns="0" bIns="0" rIns="0">
-            <a:spAutoFit/>
-          </a:bodyPr>
-          <a:lstStyle/>
-          <a:p>
-            <a:pPr algn="ctr">
-              <a:lnSpc>
-                <a:spcPts val="9119"/>
-              </a:lnSpc>
-            </a:pPr>
-            <a:r>
-              <a:rPr lang="en-US" b="true" sz="7599" spc="-151">
-                <a:solidFill>
-                  <a:srgbClr val="344F51"/>
-                </a:solidFill>
-                <a:latin typeface="Montserrat Bold"/>
-                <a:ea typeface="Montserrat Bold"/>
-                <a:cs typeface="Montserrat Bold"/>
-                <a:sym typeface="Montserrat Bold"/>
-              </a:rPr>
-              <a:t>CUIDA</a:t>
-            </a:r>
-            <a:r>
-              <a:rPr lang="en-US" b="true" sz="7599" spc="-151">
-                <a:solidFill>
-                  <a:srgbClr val="93D14B"/>
-                </a:solidFill>
-                <a:latin typeface="Montserrat Bold"/>
-                <a:ea typeface="Montserrat Bold"/>
-                <a:cs typeface="Montserrat Bold"/>
-                <a:sym typeface="Montserrat Bold"/>
-              </a:rPr>
-              <a:t>DOS</a:t>
-            </a:r>
-          </a:p>
-        </p:txBody>
-      </p:sp>
-      <p:sp>
-        <p:nvSpPr>
-          <p:cNvPr name="TextBox 13" id="13"/>
-          <p:cNvSpPr txBox="true"/>
-          <p:nvPr/>
-        </p:nvSpPr>
-        <p:spPr>
-          <a:xfrm rot="0">
-            <a:off x="8090223" y="5662612"/>
-            <a:ext cx="5241880" cy="514350"/>
-          </a:xfrm>
-          <a:prstGeom prst="rect">
-            <a:avLst/>
-          </a:prstGeom>
-        </p:spPr>
-        <p:txBody>
-          <a:bodyPr anchor="t" rtlCol="false" tIns="0" lIns="0" bIns="0" rIns="0">
-            <a:spAutoFit/>
-          </a:bodyPr>
-          <a:lstStyle/>
-          <a:p>
-            <a:pPr algn="ctr">
-              <a:lnSpc>
-                <a:spcPts val="4200"/>
-              </a:lnSpc>
-            </a:pPr>
-            <a:r>
-              <a:rPr lang="en-US" b="true" sz="3000">
-                <a:solidFill>
-                  <a:srgbClr val="344F51"/>
-                </a:solidFill>
-                <a:latin typeface="Montserrat Bold"/>
-                <a:ea typeface="Montserrat Bold"/>
-                <a:cs typeface="Montserrat Bold"/>
-                <a:sym typeface="Montserrat Bold"/>
-              </a:rPr>
-              <a:t>Evelia Gil Paredes</a:t>
-            </a:r>
-          </a:p>
-        </p:txBody>
       </p:sp>
     </p:spTree>
   </p:cSld>
@@ -4556,7 +4499,7 @@
         </p:nvGrpSpPr>
         <p:grpSpPr>
           <a:xfrm rot="0">
-            <a:off x="2264337" y="3655008"/>
+            <a:off x="2226237" y="3655008"/>
             <a:ext cx="4475594" cy="5100938"/>
             <a:chOff x="0" y="0"/>
             <a:chExt cx="1178757" cy="1343457"/>
@@ -4680,7 +4623,7 @@
         </p:nvGrpSpPr>
         <p:grpSpPr>
           <a:xfrm rot="0">
-            <a:off x="2959084" y="2802626"/>
+            <a:off x="3016234" y="2802626"/>
             <a:ext cx="3086100" cy="516103"/>
             <a:chOff x="0" y="0"/>
             <a:chExt cx="812800" cy="135928"/>
@@ -4774,7 +4717,7 @@
         </p:nvGrpSpPr>
         <p:grpSpPr>
           <a:xfrm rot="0">
-            <a:off x="7600950" y="2803064"/>
+            <a:off x="7943029" y="2802626"/>
             <a:ext cx="3086100" cy="516103"/>
             <a:chOff x="0" y="0"/>
             <a:chExt cx="812800" cy="135928"/>
@@ -4868,7 +4811,7 @@
         </p:nvGrpSpPr>
         <p:grpSpPr>
           <a:xfrm rot="0">
-            <a:off x="12579096" y="2828329"/>
+            <a:off x="12925937" y="2802626"/>
             <a:ext cx="3086100" cy="516103"/>
             <a:chOff x="0" y="0"/>
             <a:chExt cx="812800" cy="135928"/>
@@ -5057,7 +5000,7 @@
         </p:nvSpPr>
         <p:spPr>
           <a:xfrm rot="0">
-            <a:off x="7747710" y="4059812"/>
+            <a:off x="7912044" y="4059812"/>
             <a:ext cx="3281419" cy="3936326"/>
           </a:xfrm>
           <a:prstGeom prst="rect">
@@ -5120,10 +5063,10 @@
         </p:nvGrpSpPr>
         <p:grpSpPr>
           <a:xfrm rot="0">
-            <a:off x="7150622" y="3655008"/>
-            <a:ext cx="4475594" cy="5151030"/>
+            <a:off x="12178667" y="3623212"/>
+            <a:ext cx="4475594" cy="5164530"/>
             <a:chOff x="0" y="0"/>
-            <a:chExt cx="1178757" cy="1356650"/>
+            <a:chExt cx="1178757" cy="1360205"/>
           </a:xfrm>
         </p:grpSpPr>
         <p:sp>
@@ -5135,7 +5078,7 @@
           <p:spPr>
             <a:xfrm flipH="false" flipV="false" rot="0">
               <a:off x="0" y="0"/>
-              <a:ext cx="1178757" cy="1356650"/>
+              <a:ext cx="1178757" cy="1360205"/>
             </a:xfrm>
             <a:custGeom>
               <a:avLst/>
@@ -5144,7 +5087,7 @@
               <a:cxnLst/>
               <a:rect r="r" b="b" t="t" l="l"/>
               <a:pathLst>
-                <a:path h="1356650" w="1178757">
+                <a:path h="1360205" w="1178757">
                   <a:moveTo>
                     <a:pt x="34596" y="0"/>
                   </a:moveTo>
@@ -5162,25 +5105,25 @@
                     <a:pt x="1178757" y="34596"/>
                   </a:cubicBezTo>
                   <a:lnTo>
-                    <a:pt x="1178757" y="1322054"/>
+                    <a:pt x="1178757" y="1325609"/>
                   </a:lnTo>
                   <a:cubicBezTo>
-                    <a:pt x="1178757" y="1341161"/>
-                    <a:pt x="1163268" y="1356650"/>
-                    <a:pt x="1144161" y="1356650"/>
+                    <a:pt x="1178757" y="1344716"/>
+                    <a:pt x="1163268" y="1360205"/>
+                    <a:pt x="1144161" y="1360205"/>
                   </a:cubicBezTo>
                   <a:lnTo>
-                    <a:pt x="34596" y="1356650"/>
+                    <a:pt x="34596" y="1360205"/>
                   </a:lnTo>
                   <a:cubicBezTo>
-                    <a:pt x="25421" y="1356650"/>
-                    <a:pt x="16621" y="1353005"/>
-                    <a:pt x="10133" y="1346517"/>
+                    <a:pt x="25421" y="1360205"/>
+                    <a:pt x="16621" y="1356561"/>
+                    <a:pt x="10133" y="1350072"/>
                   </a:cubicBezTo>
                   <a:cubicBezTo>
-                    <a:pt x="3645" y="1340029"/>
-                    <a:pt x="0" y="1331229"/>
-                    <a:pt x="0" y="1322054"/>
+                    <a:pt x="3645" y="1343584"/>
+                    <a:pt x="0" y="1334785"/>
+                    <a:pt x="0" y="1325609"/>
                   </a:cubicBezTo>
                   <a:lnTo>
                     <a:pt x="0" y="34596"/>
@@ -5216,8 +5159,8 @@
           </p:nvSpPr>
           <p:spPr>
             <a:xfrm>
-              <a:off x="0" y="-47625"/>
-              <a:ext cx="1178757" cy="1404275"/>
+              <a:off x="0" y="-19050"/>
+              <a:ext cx="1178757" cy="1379255"/>
             </a:xfrm>
             <a:prstGeom prst="rect">
               <a:avLst/>
@@ -5229,37 +5172,166 @@
             <a:p>
               <a:pPr algn="ctr">
                 <a:lnSpc>
-                  <a:spcPts val="2600"/>
+                  <a:spcPts val="2859"/>
                 </a:lnSpc>
               </a:pPr>
             </a:p>
           </p:txBody>
         </p:sp>
       </p:grpSp>
+      <p:sp>
+        <p:nvSpPr>
+          <p:cNvPr name="TextBox 22" id="22"/>
+          <p:cNvSpPr txBox="true"/>
+          <p:nvPr/>
+        </p:nvSpPr>
+        <p:spPr>
+          <a:xfrm rot="0">
+            <a:off x="3690980" y="1329960"/>
+            <a:ext cx="10906040" cy="796391"/>
+          </a:xfrm>
+          <a:prstGeom prst="rect">
+            <a:avLst/>
+          </a:prstGeom>
+        </p:spPr>
+        <p:txBody>
+          <a:bodyPr anchor="t" rtlCol="false" tIns="0" lIns="0" bIns="0" rIns="0">
+            <a:spAutoFit/>
+          </a:bodyPr>
+          <a:lstStyle/>
+          <a:p>
+            <a:pPr algn="ctr" marL="0" indent="0" lvl="0">
+              <a:lnSpc>
+                <a:spcPts val="6548"/>
+              </a:lnSpc>
+              <a:spcBef>
+                <a:spcPct val="0"/>
+              </a:spcBef>
+            </a:pPr>
+            <a:r>
+              <a:rPr lang="en-US" b="true" sz="4745" spc="37">
+                <a:solidFill>
+                  <a:srgbClr val="344F51"/>
+                </a:solidFill>
+                <a:latin typeface="Fraunces Bold"/>
+                <a:ea typeface="Fraunces Bold"/>
+                <a:cs typeface="Fraunces Bold"/>
+                <a:sym typeface="Fraunces Bold"/>
+              </a:rPr>
+              <a:t>JUSTIFICACIÓN</a:t>
+            </a:r>
+          </a:p>
+        </p:txBody>
+      </p:sp>
+      <p:sp>
+        <p:nvSpPr>
+          <p:cNvPr name="TextBox 23" id="23"/>
+          <p:cNvSpPr txBox="true"/>
+          <p:nvPr/>
+        </p:nvSpPr>
+        <p:spPr>
+          <a:xfrm rot="0">
+            <a:off x="2508537" y="4059812"/>
+            <a:ext cx="3987194" cy="3683734"/>
+          </a:xfrm>
+          <a:prstGeom prst="rect">
+            <a:avLst/>
+          </a:prstGeom>
+        </p:spPr>
+        <p:txBody>
+          <a:bodyPr anchor="t" rtlCol="false" tIns="0" lIns="0" bIns="0" rIns="0">
+            <a:spAutoFit/>
+          </a:bodyPr>
+          <a:lstStyle/>
+          <a:p>
+            <a:pPr algn="l" marL="0" indent="0" lvl="0">
+              <a:lnSpc>
+                <a:spcPts val="2958"/>
+              </a:lnSpc>
+              <a:spcBef>
+                <a:spcPct val="0"/>
+              </a:spcBef>
+            </a:pPr>
+            <a:r>
+              <a:rPr lang="en-US" sz="2143" spc="210">
+                <a:solidFill>
+                  <a:srgbClr val="231F20"/>
+                </a:solidFill>
+                <a:latin typeface="Poppins"/>
+                <a:ea typeface="Poppins"/>
+                <a:cs typeface="Poppins"/>
+                <a:sym typeface="Poppins"/>
+              </a:rPr>
+              <a:t>Sitio web en el que se pueda realizar la contratación, por parte de los usuarios, de servicios ofrecidos por distintas empresas destinados al cuidado de personas mayores y/o personas que necesitan ayuda.</a:t>
+            </a:r>
+          </a:p>
+        </p:txBody>
+      </p:sp>
+      <p:sp>
+        <p:nvSpPr>
+          <p:cNvPr name="TextBox 24" id="24"/>
+          <p:cNvSpPr txBox="true"/>
+          <p:nvPr/>
+        </p:nvSpPr>
+        <p:spPr>
+          <a:xfrm rot="0">
+            <a:off x="17535126" y="9399905"/>
+            <a:ext cx="752874" cy="887095"/>
+          </a:xfrm>
+          <a:prstGeom prst="rect">
+            <a:avLst/>
+          </a:prstGeom>
+        </p:spPr>
+        <p:txBody>
+          <a:bodyPr anchor="t" rtlCol="false" tIns="0" lIns="0" bIns="0" rIns="0">
+            <a:spAutoFit/>
+          </a:bodyPr>
+          <a:lstStyle/>
+          <a:p>
+            <a:pPr algn="ctr">
+              <a:lnSpc>
+                <a:spcPts val="7279"/>
+              </a:lnSpc>
+            </a:pPr>
+            <a:r>
+              <a:rPr lang="en-US" b="true" sz="5199">
+                <a:solidFill>
+                  <a:srgbClr val="93D14B"/>
+                </a:solidFill>
+                <a:latin typeface="Open Sans Bold"/>
+                <a:ea typeface="Open Sans Bold"/>
+                <a:cs typeface="Open Sans Bold"/>
+                <a:sym typeface="Open Sans Bold"/>
+              </a:rPr>
+              <a:t>1.</a:t>
+            </a:r>
+          </a:p>
+        </p:txBody>
+      </p:sp>
       <p:grpSp>
         <p:nvGrpSpPr>
-          <p:cNvPr name="Group 22" id="22"/>
+          <p:cNvPr name="Group 25" id="25"/>
           <p:cNvGrpSpPr/>
           <p:nvPr/>
         </p:nvGrpSpPr>
         <p:grpSpPr>
           <a:xfrm rot="0">
-            <a:off x="12178667" y="3623212"/>
-            <a:ext cx="4475594" cy="5164530"/>
+            <a:off x="7328002" y="3655008"/>
+            <a:ext cx="4475594" cy="5151030"/>
             <a:chOff x="0" y="0"/>
-            <a:chExt cx="1178757" cy="1360205"/>
+            <a:chExt cx="1178757" cy="1356650"/>
           </a:xfrm>
         </p:grpSpPr>
         <p:sp>
           <p:nvSpPr>
-            <p:cNvPr name="Freeform 23" id="23"/>
+            <p:cNvPr name="Freeform 26" id="26"/>
             <p:cNvSpPr/>
             <p:nvPr/>
           </p:nvSpPr>
           <p:spPr>
             <a:xfrm flipH="false" flipV="false" rot="0">
               <a:off x="0" y="0"/>
-              <a:ext cx="1178757" cy="1360205"/>
+              <a:ext cx="1178757" cy="1356650"/>
             </a:xfrm>
             <a:custGeom>
               <a:avLst/>
@@ -5268,7 +5340,7 @@
               <a:cxnLst/>
               <a:rect r="r" b="b" t="t" l="l"/>
               <a:pathLst>
-                <a:path h="1360205" w="1178757">
+                <a:path h="1356650" w="1178757">
                   <a:moveTo>
                     <a:pt x="34596" y="0"/>
                   </a:moveTo>
@@ -5286,25 +5358,25 @@
                     <a:pt x="1178757" y="34596"/>
                   </a:cubicBezTo>
                   <a:lnTo>
-                    <a:pt x="1178757" y="1325609"/>
+                    <a:pt x="1178757" y="1322054"/>
                   </a:lnTo>
                   <a:cubicBezTo>
-                    <a:pt x="1178757" y="1344716"/>
-                    <a:pt x="1163268" y="1360205"/>
-                    <a:pt x="1144161" y="1360205"/>
+                    <a:pt x="1178757" y="1341161"/>
+                    <a:pt x="1163268" y="1356650"/>
+                    <a:pt x="1144161" y="1356650"/>
                   </a:cubicBezTo>
                   <a:lnTo>
-                    <a:pt x="34596" y="1360205"/>
+                    <a:pt x="34596" y="1356650"/>
                   </a:lnTo>
                   <a:cubicBezTo>
-                    <a:pt x="25421" y="1360205"/>
-                    <a:pt x="16621" y="1356561"/>
-                    <a:pt x="10133" y="1350072"/>
+                    <a:pt x="25421" y="1356650"/>
+                    <a:pt x="16621" y="1353005"/>
+                    <a:pt x="10133" y="1346517"/>
                   </a:cubicBezTo>
                   <a:cubicBezTo>
-                    <a:pt x="3645" y="1343584"/>
-                    <a:pt x="0" y="1334785"/>
-                    <a:pt x="0" y="1325609"/>
+                    <a:pt x="3645" y="1340029"/>
+                    <a:pt x="0" y="1331229"/>
+                    <a:pt x="0" y="1322054"/>
                   </a:cubicBezTo>
                   <a:lnTo>
                     <a:pt x="0" y="34596"/>
@@ -5334,14 +5406,14 @@
         </p:sp>
         <p:sp>
           <p:nvSpPr>
-            <p:cNvPr name="TextBox 24" id="24"/>
+            <p:cNvPr name="TextBox 27" id="27"/>
             <p:cNvSpPr txBox="true"/>
             <p:nvPr/>
           </p:nvSpPr>
           <p:spPr>
             <a:xfrm>
-              <a:off x="0" y="-19050"/>
-              <a:ext cx="1178757" cy="1379255"/>
+              <a:off x="0" y="-47625"/>
+              <a:ext cx="1178757" cy="1404275"/>
             </a:xfrm>
             <a:prstGeom prst="rect">
               <a:avLst/>
@@ -5353,142 +5425,13 @@
             <a:p>
               <a:pPr algn="ctr">
                 <a:lnSpc>
-                  <a:spcPts val="2859"/>
+                  <a:spcPts val="2600"/>
                 </a:lnSpc>
               </a:pPr>
             </a:p>
           </p:txBody>
         </p:sp>
       </p:grpSp>
-      <p:sp>
-        <p:nvSpPr>
-          <p:cNvPr name="TextBox 25" id="25"/>
-          <p:cNvSpPr txBox="true"/>
-          <p:nvPr/>
-        </p:nvSpPr>
-        <p:spPr>
-          <a:xfrm rot="0">
-            <a:off x="3690980" y="1329960"/>
-            <a:ext cx="10906040" cy="796391"/>
-          </a:xfrm>
-          <a:prstGeom prst="rect">
-            <a:avLst/>
-          </a:prstGeom>
-        </p:spPr>
-        <p:txBody>
-          <a:bodyPr anchor="t" rtlCol="false" tIns="0" lIns="0" bIns="0" rIns="0">
-            <a:spAutoFit/>
-          </a:bodyPr>
-          <a:lstStyle/>
-          <a:p>
-            <a:pPr algn="ctr" marL="0" indent="0" lvl="0">
-              <a:lnSpc>
-                <a:spcPts val="6548"/>
-              </a:lnSpc>
-              <a:spcBef>
-                <a:spcPct val="0"/>
-              </a:spcBef>
-            </a:pPr>
-            <a:r>
-              <a:rPr lang="en-US" b="true" sz="4745" spc="37">
-                <a:solidFill>
-                  <a:srgbClr val="344F51"/>
-                </a:solidFill>
-                <a:latin typeface="Fraunces Bold"/>
-                <a:ea typeface="Fraunces Bold"/>
-                <a:cs typeface="Fraunces Bold"/>
-                <a:sym typeface="Fraunces Bold"/>
-              </a:rPr>
-              <a:t>JUSTIFICACIÓN</a:t>
-            </a:r>
-          </a:p>
-        </p:txBody>
-      </p:sp>
-      <p:sp>
-        <p:nvSpPr>
-          <p:cNvPr name="TextBox 26" id="26"/>
-          <p:cNvSpPr txBox="true"/>
-          <p:nvPr/>
-        </p:nvSpPr>
-        <p:spPr>
-          <a:xfrm rot="0">
-            <a:off x="2405030" y="4186108"/>
-            <a:ext cx="4194209" cy="3683734"/>
-          </a:xfrm>
-          <a:prstGeom prst="rect">
-            <a:avLst/>
-          </a:prstGeom>
-        </p:spPr>
-        <p:txBody>
-          <a:bodyPr anchor="t" rtlCol="false" tIns="0" lIns="0" bIns="0" rIns="0">
-            <a:spAutoFit/>
-          </a:bodyPr>
-          <a:lstStyle/>
-          <a:p>
-            <a:pPr algn="l" marL="0" indent="0" lvl="0">
-              <a:lnSpc>
-                <a:spcPts val="2958"/>
-              </a:lnSpc>
-              <a:spcBef>
-                <a:spcPct val="0"/>
-              </a:spcBef>
-            </a:pPr>
-            <a:r>
-              <a:rPr lang="en-US" sz="2143" spc="210">
-                <a:solidFill>
-                  <a:srgbClr val="231F20"/>
-                </a:solidFill>
-                <a:latin typeface="Poppins"/>
-                <a:ea typeface="Poppins"/>
-                <a:cs typeface="Poppins"/>
-                <a:sym typeface="Poppins"/>
-              </a:rPr>
-              <a:t>Sitio web en el que se pueda realizar la contratación, por parte de los usuarios, de servicios ofrecidos por distintas empresas destinados al cuidado de personas mayores y/o personas que necesitan ayuda.</a:t>
-            </a:r>
-          </a:p>
-        </p:txBody>
-      </p:sp>
-      <p:sp>
-        <p:nvSpPr>
-          <p:cNvPr name="TextBox 27" id="27"/>
-          <p:cNvSpPr txBox="true"/>
-          <p:nvPr/>
-        </p:nvSpPr>
-        <p:spPr>
-          <a:xfrm rot="0">
-            <a:off x="17535126" y="9399905"/>
-            <a:ext cx="752874" cy="887095"/>
-          </a:xfrm>
-          <a:prstGeom prst="rect">
-            <a:avLst/>
-          </a:prstGeom>
-        </p:spPr>
-        <p:txBody>
-          <a:bodyPr anchor="t" rtlCol="false" tIns="0" lIns="0" bIns="0" rIns="0">
-            <a:spAutoFit/>
-          </a:bodyPr>
-          <a:lstStyle/>
-          <a:p>
-            <a:pPr algn="ctr">
-              <a:lnSpc>
-                <a:spcPts val="7279"/>
-              </a:lnSpc>
-            </a:pPr>
-            <a:r>
-              <a:rPr lang="en-US" b="true" sz="5199">
-                <a:solidFill>
-                  <a:srgbClr val="93D14B"/>
-                </a:solidFill>
-                <a:latin typeface="Open Sans Bold"/>
-                <a:ea typeface="Open Sans Bold"/>
-                <a:cs typeface="Open Sans Bold"/>
-                <a:sym typeface="Open Sans Bold"/>
-              </a:rPr>
-              <a:t>1.</a:t>
-            </a:r>
-          </a:p>
-        </p:txBody>
-      </p:sp>
     </p:spTree>
   </p:cSld>
   <p:clrMapOvr>
@@ -6562,8 +6505,8 @@
         </p:nvSpPr>
         <p:spPr>
           <a:xfrm flipH="false" flipV="false" rot="0">
-            <a:off x="5105746" y="639089"/>
-            <a:ext cx="12153554" cy="9008822"/>
+            <a:off x="4556940" y="256829"/>
+            <a:ext cx="12978186" cy="9620080"/>
           </a:xfrm>
           <a:custGeom>
             <a:avLst/>
@@ -6572,18 +6515,18 @@
             <a:cxnLst/>
             <a:rect r="r" b="b" t="t" l="l"/>
             <a:pathLst>
-              <a:path h="9008822" w="12153554">
+              <a:path h="9620080" w="12978186">
                 <a:moveTo>
                   <a:pt x="0" y="0"/>
                 </a:moveTo>
                 <a:lnTo>
-                  <a:pt x="12153554" y="0"/>
-                </a:lnTo>
-                <a:lnTo>
-                  <a:pt x="12153554" y="9008822"/>
-                </a:lnTo>
-                <a:lnTo>
-                  <a:pt x="0" y="9008822"/>
+                  <a:pt x="12978186" y="0"/>
+                </a:lnTo>
+                <a:lnTo>
+                  <a:pt x="12978186" y="9620080"/>
+                </a:lnTo>
+                <a:lnTo>
+                  <a:pt x="0" y="9620080"/>
                 </a:lnTo>
                 <a:lnTo>
                   <a:pt x="0" y="0"/>
@@ -6818,7 +6761,7 @@
         </p:nvGrpSpPr>
         <p:grpSpPr>
           <a:xfrm rot="0">
-            <a:off x="290765" y="3591042"/>
+            <a:off x="335116" y="3466122"/>
             <a:ext cx="5008014" cy="859690"/>
             <a:chOff x="0" y="0"/>
             <a:chExt cx="1164415" cy="199887"/>
@@ -6943,7 +6886,7 @@
         </p:nvGrpSpPr>
         <p:grpSpPr>
           <a:xfrm rot="0">
-            <a:off x="6241754" y="3466122"/>
+            <a:off x="6240627" y="3466122"/>
             <a:ext cx="5964636" cy="859690"/>
             <a:chOff x="0" y="0"/>
             <a:chExt cx="1386840" cy="199887"/>
@@ -8274,7 +8217,7 @@
 </file>
 
 <file path=ppt/slides/slide8.xml><?xml version="1.0" encoding="utf-8"?>
-<p:sld xmlns:p="http://schemas.openxmlformats.org/presentationml/2006/main" xmlns:a="http://schemas.openxmlformats.org/drawingml/2006/main">
+<p:sld xmlns:p="http://schemas.openxmlformats.org/presentationml/2006/main" xmlns:a="http://schemas.openxmlformats.org/drawingml/2006/main" xmlns:r="http://schemas.openxmlformats.org/officeDocument/2006/relationships">
   <p:cSld>
     <p:bg>
       <p:bgPr>
@@ -8421,7 +8364,280 @@
       </p:grpSp>
       <p:sp>
         <p:nvSpPr>
-          <p:cNvPr name="TextBox 5" id="5"/>
+          <p:cNvPr name="Freeform 5" id="5"/>
+          <p:cNvSpPr/>
+          <p:nvPr/>
+        </p:nvSpPr>
+        <p:spPr>
+          <a:xfrm flipH="false" flipV="false" rot="0">
+            <a:off x="2314384" y="3331871"/>
+            <a:ext cx="1516533" cy="1254586"/>
+          </a:xfrm>
+          <a:custGeom>
+            <a:avLst/>
+            <a:gdLst/>
+            <a:ahLst/>
+            <a:cxnLst/>
+            <a:rect r="r" b="b" t="t" l="l"/>
+            <a:pathLst>
+              <a:path h="1254586" w="1516533">
+                <a:moveTo>
+                  <a:pt x="0" y="0"/>
+                </a:moveTo>
+                <a:lnTo>
+                  <a:pt x="1516533" y="0"/>
+                </a:lnTo>
+                <a:lnTo>
+                  <a:pt x="1516533" y="1254586"/>
+                </a:lnTo>
+                <a:lnTo>
+                  <a:pt x="0" y="1254586"/>
+                </a:lnTo>
+                <a:lnTo>
+                  <a:pt x="0" y="0"/>
+                </a:lnTo>
+                <a:close/>
+              </a:path>
+            </a:pathLst>
+          </a:custGeom>
+          <a:blipFill>
+            <a:blip r:embed="rId2">
+              <a:extLst>
+                <a:ext uri="{96DAC541-7B7A-43D3-8B79-37D633B846F1}">
+                  <asvg:svgBlip xmlns:asvg="http://schemas.microsoft.com/office/drawing/2016/SVG/main" r:embed="rId3"/>
+                </a:ext>
+              </a:extLst>
+            </a:blip>
+            <a:stretch>
+              <a:fillRect l="0" t="0" r="0" b="0"/>
+            </a:stretch>
+          </a:blipFill>
+        </p:spPr>
+      </p:sp>
+      <p:sp>
+        <p:nvSpPr>
+          <p:cNvPr name="Freeform 6" id="6"/>
+          <p:cNvSpPr/>
+          <p:nvPr/>
+        </p:nvSpPr>
+        <p:spPr>
+          <a:xfrm flipH="false" flipV="false" rot="0">
+            <a:off x="6177532" y="3179204"/>
+            <a:ext cx="1150967" cy="1559919"/>
+          </a:xfrm>
+          <a:custGeom>
+            <a:avLst/>
+            <a:gdLst/>
+            <a:ahLst/>
+            <a:cxnLst/>
+            <a:rect r="r" b="b" t="t" l="l"/>
+            <a:pathLst>
+              <a:path h="1559919" w="1150967">
+                <a:moveTo>
+                  <a:pt x="0" y="0"/>
+                </a:moveTo>
+                <a:lnTo>
+                  <a:pt x="1150967" y="0"/>
+                </a:lnTo>
+                <a:lnTo>
+                  <a:pt x="1150967" y="1559919"/>
+                </a:lnTo>
+                <a:lnTo>
+                  <a:pt x="0" y="1559919"/>
+                </a:lnTo>
+                <a:lnTo>
+                  <a:pt x="0" y="0"/>
+                </a:lnTo>
+                <a:close/>
+              </a:path>
+            </a:pathLst>
+          </a:custGeom>
+          <a:blipFill>
+            <a:blip r:embed="rId4">
+              <a:extLst>
+                <a:ext uri="{96DAC541-7B7A-43D3-8B79-37D633B846F1}">
+                  <asvg:svgBlip xmlns:asvg="http://schemas.microsoft.com/office/drawing/2016/SVG/main" r:embed="rId5"/>
+                </a:ext>
+              </a:extLst>
+            </a:blip>
+            <a:stretch>
+              <a:fillRect l="0" t="0" r="0" b="0"/>
+            </a:stretch>
+          </a:blipFill>
+        </p:spPr>
+      </p:sp>
+      <p:sp>
+        <p:nvSpPr>
+          <p:cNvPr name="Freeform 7" id="7"/>
+          <p:cNvSpPr/>
+          <p:nvPr/>
+        </p:nvSpPr>
+        <p:spPr>
+          <a:xfrm flipH="false" flipV="false" rot="0">
+            <a:off x="9283937" y="3498338"/>
+            <a:ext cx="1635151" cy="1088119"/>
+          </a:xfrm>
+          <a:custGeom>
+            <a:avLst/>
+            <a:gdLst/>
+            <a:ahLst/>
+            <a:cxnLst/>
+            <a:rect r="r" b="b" t="t" l="l"/>
+            <a:pathLst>
+              <a:path h="1088119" w="1635151">
+                <a:moveTo>
+                  <a:pt x="0" y="0"/>
+                </a:moveTo>
+                <a:lnTo>
+                  <a:pt x="1635151" y="0"/>
+                </a:lnTo>
+                <a:lnTo>
+                  <a:pt x="1635151" y="1088119"/>
+                </a:lnTo>
+                <a:lnTo>
+                  <a:pt x="0" y="1088119"/>
+                </a:lnTo>
+                <a:lnTo>
+                  <a:pt x="0" y="0"/>
+                </a:lnTo>
+                <a:close/>
+              </a:path>
+            </a:pathLst>
+          </a:custGeom>
+          <a:blipFill>
+            <a:blip r:embed="rId6">
+              <a:extLst>
+                <a:ext uri="{96DAC541-7B7A-43D3-8B79-37D633B846F1}">
+                  <asvg:svgBlip xmlns:asvg="http://schemas.microsoft.com/office/drawing/2016/SVG/main" r:embed="rId7"/>
+                </a:ext>
+              </a:extLst>
+            </a:blip>
+            <a:stretch>
+              <a:fillRect l="0" t="0" r="0" b="0"/>
+            </a:stretch>
+          </a:blipFill>
+        </p:spPr>
+      </p:sp>
+      <p:sp>
+        <p:nvSpPr>
+          <p:cNvPr name="Freeform 8" id="8"/>
+          <p:cNvSpPr/>
+          <p:nvPr/>
+        </p:nvSpPr>
+        <p:spPr>
+          <a:xfrm flipH="false" flipV="false" rot="0">
+            <a:off x="13781727" y="3498338"/>
+            <a:ext cx="1433886" cy="1420851"/>
+          </a:xfrm>
+          <a:custGeom>
+            <a:avLst/>
+            <a:gdLst/>
+            <a:ahLst/>
+            <a:cxnLst/>
+            <a:rect r="r" b="b" t="t" l="l"/>
+            <a:pathLst>
+              <a:path h="1420851" w="1433886">
+                <a:moveTo>
+                  <a:pt x="0" y="0"/>
+                </a:moveTo>
+                <a:lnTo>
+                  <a:pt x="1433886" y="0"/>
+                </a:lnTo>
+                <a:lnTo>
+                  <a:pt x="1433886" y="1420851"/>
+                </a:lnTo>
+                <a:lnTo>
+                  <a:pt x="0" y="1420851"/>
+                </a:lnTo>
+                <a:lnTo>
+                  <a:pt x="0" y="0"/>
+                </a:lnTo>
+                <a:close/>
+              </a:path>
+            </a:pathLst>
+          </a:custGeom>
+          <a:blipFill>
+            <a:blip r:embed="rId8">
+              <a:extLst>
+                <a:ext uri="{96DAC541-7B7A-43D3-8B79-37D633B846F1}">
+                  <asvg:svgBlip xmlns:asvg="http://schemas.microsoft.com/office/drawing/2016/SVG/main" r:embed="rId9"/>
+                </a:ext>
+              </a:extLst>
+            </a:blip>
+            <a:stretch>
+              <a:fillRect l="0" t="0" r="0" b="0"/>
+            </a:stretch>
+          </a:blipFill>
+        </p:spPr>
+      </p:sp>
+      <p:sp>
+        <p:nvSpPr>
+          <p:cNvPr name="TextBox 9" id="9"/>
+          <p:cNvSpPr txBox="true"/>
+          <p:nvPr/>
+        </p:nvSpPr>
+        <p:spPr>
+          <a:xfrm rot="0">
+            <a:off x="12801467" y="5320148"/>
+            <a:ext cx="3924664" cy="3049524"/>
+          </a:xfrm>
+          <a:prstGeom prst="rect">
+            <a:avLst/>
+          </a:prstGeom>
+        </p:spPr>
+        <p:txBody>
+          <a:bodyPr anchor="t" rtlCol="false" tIns="0" lIns="0" bIns="0" rIns="0">
+            <a:spAutoFit/>
+          </a:bodyPr>
+          <a:lstStyle/>
+          <a:p>
+            <a:pPr algn="l">
+              <a:lnSpc>
+                <a:spcPts val="2207"/>
+              </a:lnSpc>
+            </a:pPr>
+            <a:r>
+              <a:rPr lang="en-US" sz="1599" spc="156" b="true">
+                <a:solidFill>
+                  <a:srgbClr val="344F51"/>
+                </a:solidFill>
+                <a:latin typeface="Poppins Bold"/>
+                <a:ea typeface="Poppins Bold"/>
+                <a:cs typeface="Poppins Bold"/>
+                <a:sym typeface="Poppins Bold"/>
+              </a:rPr>
+              <a:t>Expansión del Módulo de Inteligencia Artificial. Matchmaking Inteligente: el cliente describe el problema en lenguaje natural y la IA filtra la base de datos y le propone los 3 perfiles profesionales más adecuados.</a:t>
+            </a:r>
+          </a:p>
+          <a:p>
+            <a:pPr algn="l">
+              <a:lnSpc>
+                <a:spcPts val="2207"/>
+              </a:lnSpc>
+            </a:pPr>
+          </a:p>
+          <a:p>
+            <a:pPr algn="l">
+              <a:lnSpc>
+                <a:spcPts val="2207"/>
+              </a:lnSpc>
+            </a:pPr>
+          </a:p>
+          <a:p>
+            <a:pPr algn="l" marL="0" indent="0" lvl="0">
+              <a:lnSpc>
+                <a:spcPts val="2207"/>
+              </a:lnSpc>
+              <a:spcBef>
+                <a:spcPct val="0"/>
+              </a:spcBef>
+            </a:pPr>
+          </a:p>
+        </p:txBody>
+      </p:sp>
+      <p:sp>
+        <p:nvSpPr>
+          <p:cNvPr name="TextBox 10" id="10"/>
           <p:cNvSpPr txBox="true"/>
           <p:nvPr/>
         </p:nvSpPr>
@@ -8465,193 +8681,7 @@
       </p:sp>
       <p:sp>
         <p:nvSpPr>
-          <p:cNvPr name="TextBox 6" id="6"/>
-          <p:cNvSpPr txBox="true"/>
-          <p:nvPr/>
-        </p:nvSpPr>
-        <p:spPr>
-          <a:xfrm rot="0">
-            <a:off x="2976208" y="3153392"/>
-            <a:ext cx="13558833" cy="6001516"/>
-          </a:xfrm>
-          <a:prstGeom prst="rect">
-            <a:avLst/>
-          </a:prstGeom>
-        </p:spPr>
-        <p:txBody>
-          <a:bodyPr anchor="t" rtlCol="false" tIns="0" lIns="0" bIns="0" rIns="0">
-            <a:spAutoFit/>
-          </a:bodyPr>
-          <a:lstStyle/>
-          <a:p>
-            <a:pPr algn="l" marL="442554" indent="-221277" lvl="1">
-              <a:lnSpc>
-                <a:spcPts val="2828"/>
-              </a:lnSpc>
-              <a:buFont typeface="Arial"/>
-              <a:buChar char="•"/>
-            </a:pPr>
-            <a:r>
-              <a:rPr lang="en-US" b="true" sz="2049" spc="200">
-                <a:solidFill>
-                  <a:srgbClr val="344F51"/>
-                </a:solidFill>
-                <a:latin typeface="Poppins Bold"/>
-                <a:ea typeface="Poppins Bold"/>
-                <a:cs typeface="Poppins Bold"/>
-                <a:sym typeface="Poppins Bold"/>
-              </a:rPr>
-              <a:t>Integración de Pasarela de Pago y Modelo de Negocio. Como evolución natural, se propone la integración de una pasarela de pagos segura (como Stripe o PayPal).</a:t>
-            </a:r>
-          </a:p>
-          <a:p>
-            <a:pPr algn="l">
-              <a:lnSpc>
-                <a:spcPts val="2828"/>
-              </a:lnSpc>
-            </a:pPr>
-          </a:p>
-          <a:p>
-            <a:pPr algn="l" marL="442554" indent="-221277" lvl="1">
-              <a:lnSpc>
-                <a:spcPts val="2828"/>
-              </a:lnSpc>
-              <a:buFont typeface="Arial"/>
-              <a:buChar char="•"/>
-            </a:pPr>
-            <a:r>
-              <a:rPr lang="en-US" b="true" sz="2049" spc="200">
-                <a:solidFill>
-                  <a:srgbClr val="344F51"/>
-                </a:solidFill>
-                <a:latin typeface="Poppins Bold"/>
-                <a:ea typeface="Poppins Bold"/>
-                <a:cs typeface="Poppins Bold"/>
-                <a:sym typeface="Poppins Bold"/>
-              </a:rPr>
-              <a:t>Sistema de Valoraciones.</a:t>
-            </a:r>
-          </a:p>
-          <a:p>
-            <a:pPr algn="l">
-              <a:lnSpc>
-                <a:spcPts val="2828"/>
-              </a:lnSpc>
-            </a:pPr>
-          </a:p>
-          <a:p>
-            <a:pPr algn="l" marL="442554" indent="-221277" lvl="1">
-              <a:lnSpc>
-                <a:spcPts val="2828"/>
-              </a:lnSpc>
-              <a:buFont typeface="Arial"/>
-              <a:buChar char="•"/>
-            </a:pPr>
-            <a:r>
-              <a:rPr lang="en-US" b="true" sz="2049" spc="200">
-                <a:solidFill>
-                  <a:srgbClr val="344F51"/>
-                </a:solidFill>
-                <a:latin typeface="Poppins Bold"/>
-                <a:ea typeface="Poppins Bold"/>
-                <a:cs typeface="Poppins Bold"/>
-                <a:sym typeface="Poppins Bold"/>
-              </a:rPr>
-              <a:t>Entrevistas por Videollamada (WebRTC). Implementar un módulo de videollamadas integrado directamente en el chat de la aplicación.</a:t>
-            </a:r>
-          </a:p>
-          <a:p>
-            <a:pPr algn="l">
-              <a:lnSpc>
-                <a:spcPts val="2828"/>
-              </a:lnSpc>
-            </a:pPr>
-          </a:p>
-          <a:p>
-            <a:pPr algn="l" marL="442554" indent="-221277" lvl="1">
-              <a:lnSpc>
-                <a:spcPts val="2828"/>
-              </a:lnSpc>
-              <a:buFont typeface="Arial"/>
-              <a:buChar char="•"/>
-            </a:pPr>
-            <a:r>
-              <a:rPr lang="en-US" b="true" sz="2049" spc="200">
-                <a:solidFill>
-                  <a:srgbClr val="344F51"/>
-                </a:solidFill>
-                <a:latin typeface="Poppins Bold"/>
-                <a:ea typeface="Poppins Bold"/>
-                <a:cs typeface="Poppins Bold"/>
-                <a:sym typeface="Poppins Bold"/>
-              </a:rPr>
-              <a:t>Expansión del Módulo de Inteligencia Artificial. Matchmaking Inteligente: el cliente describe el problema en lenguaje natural y la IA filtra la base de datos y le propone los 3 perfiles profesionales más adecuados.</a:t>
-            </a:r>
-          </a:p>
-          <a:p>
-            <a:pPr algn="l">
-              <a:lnSpc>
-                <a:spcPts val="2828"/>
-              </a:lnSpc>
-            </a:pPr>
-          </a:p>
-          <a:p>
-            <a:pPr algn="l" marL="442554" indent="-221277" lvl="1">
-              <a:lnSpc>
-                <a:spcPts val="2828"/>
-              </a:lnSpc>
-              <a:buFont typeface="Arial"/>
-              <a:buChar char="•"/>
-            </a:pPr>
-            <a:r>
-              <a:rPr lang="en-US" b="true" sz="2049" spc="200">
-                <a:solidFill>
-                  <a:srgbClr val="344F51"/>
-                </a:solidFill>
-                <a:latin typeface="Poppins Bold"/>
-                <a:ea typeface="Poppins Bold"/>
-                <a:cs typeface="Poppins Bold"/>
-                <a:sym typeface="Poppins Bold"/>
-              </a:rPr>
-              <a:t>Dar de alta a los usuarios de nuevo por los adnimistradores.</a:t>
-            </a:r>
-          </a:p>
-          <a:p>
-            <a:pPr algn="l">
-              <a:lnSpc>
-                <a:spcPts val="2828"/>
-              </a:lnSpc>
-            </a:pPr>
-          </a:p>
-          <a:p>
-            <a:pPr algn="l">
-              <a:lnSpc>
-                <a:spcPts val="2828"/>
-              </a:lnSpc>
-            </a:pPr>
-          </a:p>
-          <a:p>
-            <a:pPr algn="l">
-              <a:lnSpc>
-                <a:spcPts val="2828"/>
-              </a:lnSpc>
-            </a:pPr>
-          </a:p>
-          <a:p>
-            <a:pPr algn="l" marL="0" indent="0" lvl="0">
-              <a:lnSpc>
-                <a:spcPts val="2828"/>
-              </a:lnSpc>
-              <a:spcBef>
-                <a:spcPct val="0"/>
-              </a:spcBef>
-            </a:pPr>
-          </a:p>
-        </p:txBody>
-      </p:sp>
-      <p:sp>
-        <p:nvSpPr>
-          <p:cNvPr name="TextBox 7" id="7"/>
+          <p:cNvPr name="TextBox 11" id="11"/>
           <p:cNvSpPr txBox="true"/>
           <p:nvPr/>
         </p:nvSpPr>
@@ -8699,6 +8729,236 @@
               </a:rPr>
               <a:t>.</a:t>
             </a:r>
+          </a:p>
+        </p:txBody>
+      </p:sp>
+      <p:sp>
+        <p:nvSpPr>
+          <p:cNvPr name="TextBox 12" id="12"/>
+          <p:cNvSpPr txBox="true"/>
+          <p:nvPr/>
+        </p:nvSpPr>
+        <p:spPr>
+          <a:xfrm rot="0">
+            <a:off x="1778673" y="5320148"/>
+            <a:ext cx="2970137" cy="3601974"/>
+          </a:xfrm>
+          <a:prstGeom prst="rect">
+            <a:avLst/>
+          </a:prstGeom>
+        </p:spPr>
+        <p:txBody>
+          <a:bodyPr anchor="t" rtlCol="false" tIns="0" lIns="0" bIns="0" rIns="0">
+            <a:spAutoFit/>
+          </a:bodyPr>
+          <a:lstStyle/>
+          <a:p>
+            <a:pPr algn="l">
+              <a:lnSpc>
+                <a:spcPts val="2208"/>
+              </a:lnSpc>
+            </a:pPr>
+            <a:r>
+              <a:rPr lang="en-US" sz="1600" spc="156" b="true">
+                <a:solidFill>
+                  <a:srgbClr val="344F51"/>
+                </a:solidFill>
+                <a:latin typeface="Poppins Bold"/>
+                <a:ea typeface="Poppins Bold"/>
+                <a:cs typeface="Poppins Bold"/>
+                <a:sym typeface="Poppins Bold"/>
+              </a:rPr>
+              <a:t>Integración de Pasarela de Pago y Modelo de Negocio. Como evolución natural, se propone la integración de una pasarela de pagos segura (como Stripe o PayPal).</a:t>
+            </a:r>
+          </a:p>
+          <a:p>
+            <a:pPr algn="l">
+              <a:lnSpc>
+                <a:spcPts val="2208"/>
+              </a:lnSpc>
+            </a:pPr>
+          </a:p>
+          <a:p>
+            <a:pPr algn="l">
+              <a:lnSpc>
+                <a:spcPts val="2208"/>
+              </a:lnSpc>
+            </a:pPr>
+          </a:p>
+          <a:p>
+            <a:pPr algn="l">
+              <a:lnSpc>
+                <a:spcPts val="2208"/>
+              </a:lnSpc>
+            </a:pPr>
+          </a:p>
+          <a:p>
+            <a:pPr algn="l">
+              <a:lnSpc>
+                <a:spcPts val="2208"/>
+              </a:lnSpc>
+            </a:pPr>
+          </a:p>
+          <a:p>
+            <a:pPr algn="l" marL="0" indent="0" lvl="0">
+              <a:lnSpc>
+                <a:spcPts val="2208"/>
+              </a:lnSpc>
+              <a:spcBef>
+                <a:spcPct val="0"/>
+              </a:spcBef>
+            </a:pPr>
+          </a:p>
+        </p:txBody>
+      </p:sp>
+      <p:sp>
+        <p:nvSpPr>
+          <p:cNvPr name="TextBox 13" id="13"/>
+          <p:cNvSpPr txBox="true"/>
+          <p:nvPr/>
+        </p:nvSpPr>
+        <p:spPr>
+          <a:xfrm rot="0">
+            <a:off x="5307758" y="5329673"/>
+            <a:ext cx="3209001" cy="3361374"/>
+          </a:xfrm>
+          <a:prstGeom prst="rect">
+            <a:avLst/>
+          </a:prstGeom>
+        </p:spPr>
+        <p:txBody>
+          <a:bodyPr anchor="t" rtlCol="false" tIns="0" lIns="0" bIns="0" rIns="0">
+            <a:spAutoFit/>
+          </a:bodyPr>
+          <a:lstStyle/>
+          <a:p>
+            <a:pPr algn="l">
+              <a:lnSpc>
+                <a:spcPts val="2247"/>
+              </a:lnSpc>
+            </a:pPr>
+            <a:r>
+              <a:rPr lang="en-US" sz="1628" spc="159" b="true">
+                <a:solidFill>
+                  <a:srgbClr val="344F51"/>
+                </a:solidFill>
+                <a:latin typeface="Poppins Bold"/>
+                <a:ea typeface="Poppins Bold"/>
+                <a:cs typeface="Poppins Bold"/>
+                <a:sym typeface="Poppins Bold"/>
+              </a:rPr>
+              <a:t>Sistema de Valoraciones, de forma que los usuarios podrán leer las reseñas de otros clientes, facilitando la toma de decisión de contratación.</a:t>
+            </a:r>
+          </a:p>
+          <a:p>
+            <a:pPr algn="l">
+              <a:lnSpc>
+                <a:spcPts val="2247"/>
+              </a:lnSpc>
+            </a:pPr>
+          </a:p>
+          <a:p>
+            <a:pPr algn="l">
+              <a:lnSpc>
+                <a:spcPts val="2247"/>
+              </a:lnSpc>
+            </a:pPr>
+          </a:p>
+          <a:p>
+            <a:pPr algn="l">
+              <a:lnSpc>
+                <a:spcPts val="2247"/>
+              </a:lnSpc>
+            </a:pPr>
+          </a:p>
+          <a:p>
+            <a:pPr algn="l">
+              <a:lnSpc>
+                <a:spcPts val="2247"/>
+              </a:lnSpc>
+            </a:pPr>
+          </a:p>
+          <a:p>
+            <a:pPr algn="l" marL="0" indent="0" lvl="0">
+              <a:lnSpc>
+                <a:spcPts val="2247"/>
+              </a:lnSpc>
+              <a:spcBef>
+                <a:spcPct val="0"/>
+              </a:spcBef>
+            </a:pPr>
+          </a:p>
+        </p:txBody>
+      </p:sp>
+      <p:sp>
+        <p:nvSpPr>
+          <p:cNvPr name="TextBox 14" id="14"/>
+          <p:cNvSpPr txBox="true"/>
+          <p:nvPr/>
+        </p:nvSpPr>
+        <p:spPr>
+          <a:xfrm rot="0">
+            <a:off x="8948066" y="5320148"/>
+            <a:ext cx="3654880" cy="2773299"/>
+          </a:xfrm>
+          <a:prstGeom prst="rect">
+            <a:avLst/>
+          </a:prstGeom>
+        </p:spPr>
+        <p:txBody>
+          <a:bodyPr anchor="t" rtlCol="false" tIns="0" lIns="0" bIns="0" rIns="0">
+            <a:spAutoFit/>
+          </a:bodyPr>
+          <a:lstStyle/>
+          <a:p>
+            <a:pPr algn="l">
+              <a:lnSpc>
+                <a:spcPts val="2207"/>
+              </a:lnSpc>
+            </a:pPr>
+            <a:r>
+              <a:rPr lang="en-US" sz="1599" spc="156" b="true">
+                <a:solidFill>
+                  <a:srgbClr val="344F51"/>
+                </a:solidFill>
+                <a:latin typeface="Poppins Bold"/>
+                <a:ea typeface="Poppins Bold"/>
+                <a:cs typeface="Poppins Bold"/>
+                <a:sym typeface="Poppins Bold"/>
+              </a:rPr>
+              <a:t>Entrevistas por Videollamada (WebRTC). Implementar un módulo de videollamadas integrado directamente en el chat de la aplicación.</a:t>
+            </a:r>
+          </a:p>
+          <a:p>
+            <a:pPr algn="l">
+              <a:lnSpc>
+                <a:spcPts val="2207"/>
+              </a:lnSpc>
+            </a:pPr>
+          </a:p>
+          <a:p>
+            <a:pPr algn="l">
+              <a:lnSpc>
+                <a:spcPts val="2207"/>
+              </a:lnSpc>
+            </a:pPr>
+          </a:p>
+          <a:p>
+            <a:pPr algn="l">
+              <a:lnSpc>
+                <a:spcPts val="2207"/>
+              </a:lnSpc>
+            </a:pPr>
+          </a:p>
+          <a:p>
+            <a:pPr algn="l" marL="0" indent="0" lvl="0">
+              <a:lnSpc>
+                <a:spcPts val="2207"/>
+              </a:lnSpc>
+              <a:spcBef>
+                <a:spcPct val="0"/>
+              </a:spcBef>
+            </a:pPr>
           </a:p>
         </p:txBody>
       </p:sp>

</xml_diff>

<commit_message>
cambios pequeños de algunas traducciones por algunas mejores en el json. Actualizacion de la presentacion tras la corrección del tutor
</commit_message>
<xml_diff>
--- a/documentacion_extra/presentacion/cuidaDos.pptx
+++ b/documentacion_extra/presentacion/cuidaDos.pptx
@@ -6355,7 +6355,7 @@
           <p:nvPr/>
         </p:nvGraphicFramePr>
         <p:xfrm>
-          <a:off x="1028700" y="645282"/>
+          <a:off x="612113" y="286642"/>
           <a:ext cx="11291915" cy="8229600"/>
         </p:xfrm>
         <a:graphic>
@@ -6394,8 +6394,8 @@
         </p:nvSpPr>
         <p:spPr>
           <a:xfrm rot="0">
-            <a:off x="17535126" y="9399905"/>
-            <a:ext cx="752874" cy="887095"/>
+            <a:off x="17675887" y="9399905"/>
+            <a:ext cx="612113" cy="887095"/>
           </a:xfrm>
           <a:prstGeom prst="rect">
             <a:avLst/>

</xml_diff>

<commit_message>
actualiacion de la presentacion
</commit_message>
<xml_diff>
--- a/documentacion_extra/presentacion/cuidaDos.pptx
+++ b/documentacion_extra/presentacion/cuidaDos.pptx
@@ -6468,9 +6468,9 @@
         <p:grpSpPr>
           <a:xfrm rot="0">
             <a:off x="-2785357" y="538989"/>
-            <a:ext cx="7162260" cy="1961344"/>
+            <a:ext cx="7570719" cy="1961344"/>
             <a:chOff x="0" y="0"/>
-            <a:chExt cx="1012764" cy="277340"/>
+            <a:chExt cx="1070521" cy="277340"/>
           </a:xfrm>
         </p:grpSpPr>
         <p:sp>
@@ -6482,7 +6482,7 @@
           <p:spPr>
             <a:xfrm flipH="false" flipV="false" rot="0">
               <a:off x="0" y="0"/>
-              <a:ext cx="1012764" cy="277340"/>
+              <a:ext cx="1070521" cy="277340"/>
             </a:xfrm>
             <a:custGeom>
               <a:avLst/>
@@ -6491,9 +6491,9 @@
               <a:cxnLst/>
               <a:rect r="r" b="b" t="t" l="l"/>
               <a:pathLst>
-                <a:path h="277340" w="1012764">
+                <a:path h="277340" w="1070521">
                   <a:moveTo>
-                    <a:pt x="809564" y="0"/>
+                    <a:pt x="867321" y="0"/>
                   </a:moveTo>
                   <a:lnTo>
                     <a:pt x="0" y="0"/>
@@ -6502,10 +6502,10 @@
                     <a:pt x="203200" y="277340"/>
                   </a:lnTo>
                   <a:lnTo>
-                    <a:pt x="1012764" y="277340"/>
-                  </a:lnTo>
-                  <a:lnTo>
-                    <a:pt x="809564" y="0"/>
+                    <a:pt x="1070521" y="277340"/>
+                  </a:lnTo>
+                  <a:lnTo>
+                    <a:pt x="867321" y="0"/>
                   </a:lnTo>
                   <a:close/>
                 </a:path>
@@ -6530,7 +6530,7 @@
           <p:spPr>
             <a:xfrm>
               <a:off x="101600" y="-19050"/>
-              <a:ext cx="809564" cy="296390"/>
+              <a:ext cx="867321" cy="296390"/>
             </a:xfrm>
             <a:prstGeom prst="rect">
               <a:avLst/>
@@ -6658,8 +6658,8 @@
         </p:nvSpPr>
         <p:spPr>
           <a:xfrm flipH="false" flipV="false" rot="0">
-            <a:off x="4556940" y="256829"/>
-            <a:ext cx="12978186" cy="9620080"/>
+            <a:off x="5098195" y="1519661"/>
+            <a:ext cx="2779871" cy="3501663"/>
           </a:xfrm>
           <a:custGeom>
             <a:avLst/>
@@ -6668,18 +6668,18 @@
             <a:cxnLst/>
             <a:rect r="r" b="b" t="t" l="l"/>
             <a:pathLst>
-              <a:path h="9620080" w="12978186">
+              <a:path h="3501663" w="2779871">
                 <a:moveTo>
                   <a:pt x="0" y="0"/>
                 </a:moveTo>
                 <a:lnTo>
-                  <a:pt x="12978186" y="0"/>
-                </a:lnTo>
-                <a:lnTo>
-                  <a:pt x="12978186" y="9620080"/>
-                </a:lnTo>
-                <a:lnTo>
-                  <a:pt x="0" y="9620080"/>
+                  <a:pt x="2779872" y="0"/>
+                </a:lnTo>
+                <a:lnTo>
+                  <a:pt x="2779872" y="3501662"/>
+                </a:lnTo>
+                <a:lnTo>
+                  <a:pt x="0" y="3501662"/>
                 </a:lnTo>
                 <a:lnTo>
                   <a:pt x="0" y="0"/>
@@ -6698,7 +6698,1643 @@
       </p:sp>
       <p:sp>
         <p:nvSpPr>
-          <p:cNvPr name="TextBox 8" id="8"/>
+          <p:cNvPr name="Freeform 8" id="8"/>
+          <p:cNvSpPr/>
+          <p:nvPr/>
+        </p:nvSpPr>
+        <p:spPr>
+          <a:xfrm flipH="false" flipV="false" rot="0">
+            <a:off x="5646362" y="377550"/>
+            <a:ext cx="1580715" cy="570814"/>
+          </a:xfrm>
+          <a:custGeom>
+            <a:avLst/>
+            <a:gdLst/>
+            <a:ahLst/>
+            <a:cxnLst/>
+            <a:rect r="r" b="b" t="t" l="l"/>
+            <a:pathLst>
+              <a:path h="570814" w="1580715">
+                <a:moveTo>
+                  <a:pt x="0" y="0"/>
+                </a:moveTo>
+                <a:lnTo>
+                  <a:pt x="1580715" y="0"/>
+                </a:lnTo>
+                <a:lnTo>
+                  <a:pt x="1580715" y="570814"/>
+                </a:lnTo>
+                <a:lnTo>
+                  <a:pt x="0" y="570814"/>
+                </a:lnTo>
+                <a:lnTo>
+                  <a:pt x="0" y="0"/>
+                </a:lnTo>
+                <a:close/>
+              </a:path>
+            </a:pathLst>
+          </a:custGeom>
+          <a:blipFill>
+            <a:blip r:embed="rId6"/>
+            <a:stretch>
+              <a:fillRect l="0" t="0" r="0" b="0"/>
+            </a:stretch>
+          </a:blipFill>
+        </p:spPr>
+      </p:sp>
+      <p:sp>
+        <p:nvSpPr>
+          <p:cNvPr name="Freeform 9" id="9"/>
+          <p:cNvSpPr/>
+          <p:nvPr/>
+        </p:nvSpPr>
+        <p:spPr>
+          <a:xfrm flipH="false" flipV="false" rot="0">
+            <a:off x="5098195" y="5852013"/>
+            <a:ext cx="2779871" cy="4214177"/>
+          </a:xfrm>
+          <a:custGeom>
+            <a:avLst/>
+            <a:gdLst/>
+            <a:ahLst/>
+            <a:cxnLst/>
+            <a:rect r="r" b="b" t="t" l="l"/>
+            <a:pathLst>
+              <a:path h="4214177" w="2779871">
+                <a:moveTo>
+                  <a:pt x="0" y="0"/>
+                </a:moveTo>
+                <a:lnTo>
+                  <a:pt x="2779872" y="0"/>
+                </a:lnTo>
+                <a:lnTo>
+                  <a:pt x="2779872" y="4214178"/>
+                </a:lnTo>
+                <a:lnTo>
+                  <a:pt x="0" y="4214178"/>
+                </a:lnTo>
+                <a:lnTo>
+                  <a:pt x="0" y="0"/>
+                </a:lnTo>
+                <a:close/>
+              </a:path>
+            </a:pathLst>
+          </a:custGeom>
+          <a:blipFill>
+            <a:blip r:embed="rId7"/>
+            <a:stretch>
+              <a:fillRect l="0" t="0" r="0" b="-2526"/>
+            </a:stretch>
+          </a:blipFill>
+        </p:spPr>
+      </p:sp>
+      <p:grpSp>
+        <p:nvGrpSpPr>
+          <p:cNvPr name="Group 10" id="10"/>
+          <p:cNvGrpSpPr/>
+          <p:nvPr/>
+        </p:nvGrpSpPr>
+        <p:grpSpPr>
+          <a:xfrm rot="0">
+            <a:off x="6300624" y="1034089"/>
+            <a:ext cx="272191" cy="446412"/>
+            <a:chOff x="0" y="0"/>
+            <a:chExt cx="494051" cy="810280"/>
+          </a:xfrm>
+        </p:grpSpPr>
+        <p:sp>
+          <p:nvSpPr>
+            <p:cNvPr name="Freeform 11" id="11"/>
+            <p:cNvSpPr/>
+            <p:nvPr/>
+          </p:nvSpPr>
+          <p:spPr>
+            <a:xfrm flipH="false" flipV="false" rot="0">
+              <a:off x="0" y="0"/>
+              <a:ext cx="494051" cy="810280"/>
+            </a:xfrm>
+            <a:custGeom>
+              <a:avLst/>
+              <a:gdLst/>
+              <a:ahLst/>
+              <a:cxnLst/>
+              <a:rect r="r" b="b" t="t" l="l"/>
+              <a:pathLst>
+                <a:path h="810280" w="494051">
+                  <a:moveTo>
+                    <a:pt x="247026" y="810280"/>
+                  </a:moveTo>
+                  <a:lnTo>
+                    <a:pt x="0" y="403880"/>
+                  </a:lnTo>
+                  <a:lnTo>
+                    <a:pt x="203200" y="403880"/>
+                  </a:lnTo>
+                  <a:lnTo>
+                    <a:pt x="203200" y="0"/>
+                  </a:lnTo>
+                  <a:lnTo>
+                    <a:pt x="290851" y="0"/>
+                  </a:lnTo>
+                  <a:lnTo>
+                    <a:pt x="290851" y="403880"/>
+                  </a:lnTo>
+                  <a:lnTo>
+                    <a:pt x="494051" y="403880"/>
+                  </a:lnTo>
+                  <a:lnTo>
+                    <a:pt x="247026" y="810280"/>
+                  </a:lnTo>
+                  <a:close/>
+                </a:path>
+              </a:pathLst>
+            </a:custGeom>
+            <a:solidFill>
+              <a:srgbClr val="FFFFFF"/>
+            </a:solidFill>
+          </p:spPr>
+        </p:sp>
+        <p:sp>
+          <p:nvSpPr>
+            <p:cNvPr name="TextBox 12" id="12"/>
+            <p:cNvSpPr txBox="true"/>
+            <p:nvPr/>
+          </p:nvSpPr>
+          <p:spPr>
+            <a:xfrm>
+              <a:off x="203200" y="-19050"/>
+              <a:ext cx="87651" cy="727730"/>
+            </a:xfrm>
+            <a:prstGeom prst="rect">
+              <a:avLst/>
+            </a:prstGeom>
+          </p:spPr>
+          <p:txBody>
+            <a:bodyPr anchor="ctr" rtlCol="false" tIns="50800" lIns="50800" bIns="50800" rIns="50800"/>
+            <a:lstStyle/>
+            <a:p>
+              <a:pPr algn="ctr">
+                <a:lnSpc>
+                  <a:spcPts val="2859"/>
+                </a:lnSpc>
+              </a:pPr>
+            </a:p>
+          </p:txBody>
+        </p:sp>
+      </p:grpSp>
+      <p:grpSp>
+        <p:nvGrpSpPr>
+          <p:cNvPr name="Group 13" id="13"/>
+          <p:cNvGrpSpPr/>
+          <p:nvPr/>
+        </p:nvGrpSpPr>
+        <p:grpSpPr>
+          <a:xfrm rot="0">
+            <a:off x="6234996" y="5105827"/>
+            <a:ext cx="403448" cy="661683"/>
+            <a:chOff x="0" y="0"/>
+            <a:chExt cx="494051" cy="810280"/>
+          </a:xfrm>
+        </p:grpSpPr>
+        <p:sp>
+          <p:nvSpPr>
+            <p:cNvPr name="Freeform 14" id="14"/>
+            <p:cNvSpPr/>
+            <p:nvPr/>
+          </p:nvSpPr>
+          <p:spPr>
+            <a:xfrm flipH="false" flipV="false" rot="0">
+              <a:off x="0" y="0"/>
+              <a:ext cx="494051" cy="810280"/>
+            </a:xfrm>
+            <a:custGeom>
+              <a:avLst/>
+              <a:gdLst/>
+              <a:ahLst/>
+              <a:cxnLst/>
+              <a:rect r="r" b="b" t="t" l="l"/>
+              <a:pathLst>
+                <a:path h="810280" w="494051">
+                  <a:moveTo>
+                    <a:pt x="247026" y="810280"/>
+                  </a:moveTo>
+                  <a:lnTo>
+                    <a:pt x="0" y="403880"/>
+                  </a:lnTo>
+                  <a:lnTo>
+                    <a:pt x="203200" y="403880"/>
+                  </a:lnTo>
+                  <a:lnTo>
+                    <a:pt x="203200" y="0"/>
+                  </a:lnTo>
+                  <a:lnTo>
+                    <a:pt x="290851" y="0"/>
+                  </a:lnTo>
+                  <a:lnTo>
+                    <a:pt x="290851" y="403880"/>
+                  </a:lnTo>
+                  <a:lnTo>
+                    <a:pt x="494051" y="403880"/>
+                  </a:lnTo>
+                  <a:lnTo>
+                    <a:pt x="247026" y="810280"/>
+                  </a:lnTo>
+                  <a:close/>
+                </a:path>
+              </a:pathLst>
+            </a:custGeom>
+            <a:solidFill>
+              <a:srgbClr val="FFFFFF"/>
+            </a:solidFill>
+          </p:spPr>
+        </p:sp>
+        <p:sp>
+          <p:nvSpPr>
+            <p:cNvPr name="TextBox 15" id="15"/>
+            <p:cNvSpPr txBox="true"/>
+            <p:nvPr/>
+          </p:nvSpPr>
+          <p:spPr>
+            <a:xfrm>
+              <a:off x="203200" y="-19050"/>
+              <a:ext cx="87651" cy="727730"/>
+            </a:xfrm>
+            <a:prstGeom prst="rect">
+              <a:avLst/>
+            </a:prstGeom>
+          </p:spPr>
+          <p:txBody>
+            <a:bodyPr anchor="ctr" rtlCol="false" tIns="50800" lIns="50800" bIns="50800" rIns="50800"/>
+            <a:lstStyle/>
+            <a:p>
+              <a:pPr algn="ctr">
+                <a:lnSpc>
+                  <a:spcPts val="2859"/>
+                </a:lnSpc>
+              </a:pPr>
+            </a:p>
+          </p:txBody>
+        </p:sp>
+      </p:grpSp>
+      <p:sp>
+        <p:nvSpPr>
+          <p:cNvPr name="Freeform 16" id="16"/>
+          <p:cNvSpPr/>
+          <p:nvPr/>
+        </p:nvSpPr>
+        <p:spPr>
+          <a:xfrm flipH="false" flipV="false" rot="0">
+            <a:off x="8379096" y="377550"/>
+            <a:ext cx="2809214" cy="827979"/>
+          </a:xfrm>
+          <a:custGeom>
+            <a:avLst/>
+            <a:gdLst/>
+            <a:ahLst/>
+            <a:cxnLst/>
+            <a:rect r="r" b="b" t="t" l="l"/>
+            <a:pathLst>
+              <a:path h="827979" w="2809214">
+                <a:moveTo>
+                  <a:pt x="0" y="0"/>
+                </a:moveTo>
+                <a:lnTo>
+                  <a:pt x="2809215" y="0"/>
+                </a:lnTo>
+                <a:lnTo>
+                  <a:pt x="2809215" y="827979"/>
+                </a:lnTo>
+                <a:lnTo>
+                  <a:pt x="0" y="827979"/>
+                </a:lnTo>
+                <a:lnTo>
+                  <a:pt x="0" y="0"/>
+                </a:lnTo>
+                <a:close/>
+              </a:path>
+            </a:pathLst>
+          </a:custGeom>
+          <a:blipFill>
+            <a:blip r:embed="rId8"/>
+            <a:stretch>
+              <a:fillRect l="0" t="0" r="0" b="0"/>
+            </a:stretch>
+          </a:blipFill>
+        </p:spPr>
+      </p:sp>
+      <p:sp>
+        <p:nvSpPr>
+          <p:cNvPr name="Freeform 17" id="17"/>
+          <p:cNvSpPr/>
+          <p:nvPr/>
+        </p:nvSpPr>
+        <p:spPr>
+          <a:xfrm flipH="false" flipV="false" rot="0">
+            <a:off x="8105451" y="6872354"/>
+            <a:ext cx="2794607" cy="3193836"/>
+          </a:xfrm>
+          <a:custGeom>
+            <a:avLst/>
+            <a:gdLst/>
+            <a:ahLst/>
+            <a:cxnLst/>
+            <a:rect r="r" b="b" t="t" l="l"/>
+            <a:pathLst>
+              <a:path h="3193836" w="2794607">
+                <a:moveTo>
+                  <a:pt x="0" y="0"/>
+                </a:moveTo>
+                <a:lnTo>
+                  <a:pt x="2794606" y="0"/>
+                </a:lnTo>
+                <a:lnTo>
+                  <a:pt x="2794606" y="3193837"/>
+                </a:lnTo>
+                <a:lnTo>
+                  <a:pt x="0" y="3193837"/>
+                </a:lnTo>
+                <a:lnTo>
+                  <a:pt x="0" y="0"/>
+                </a:lnTo>
+                <a:close/>
+              </a:path>
+            </a:pathLst>
+          </a:custGeom>
+          <a:blipFill>
+            <a:blip r:embed="rId9"/>
+            <a:stretch>
+              <a:fillRect l="0" t="0" r="0" b="0"/>
+            </a:stretch>
+          </a:blipFill>
+        </p:spPr>
+      </p:sp>
+      <p:grpSp>
+        <p:nvGrpSpPr>
+          <p:cNvPr name="Group 18" id="18"/>
+          <p:cNvGrpSpPr/>
+          <p:nvPr/>
+        </p:nvGrpSpPr>
+        <p:grpSpPr>
+          <a:xfrm rot="2700000">
+            <a:off x="8110383" y="1176747"/>
+            <a:ext cx="204405" cy="690010"/>
+            <a:chOff x="0" y="0"/>
+            <a:chExt cx="494051" cy="1667767"/>
+          </a:xfrm>
+        </p:grpSpPr>
+        <p:sp>
+          <p:nvSpPr>
+            <p:cNvPr name="Freeform 19" id="19"/>
+            <p:cNvSpPr/>
+            <p:nvPr/>
+          </p:nvSpPr>
+          <p:spPr>
+            <a:xfrm flipH="false" flipV="false" rot="0">
+              <a:off x="0" y="0"/>
+              <a:ext cx="494051" cy="1667767"/>
+            </a:xfrm>
+            <a:custGeom>
+              <a:avLst/>
+              <a:gdLst/>
+              <a:ahLst/>
+              <a:cxnLst/>
+              <a:rect r="r" b="b" t="t" l="l"/>
+              <a:pathLst>
+                <a:path h="1667767" w="494051">
+                  <a:moveTo>
+                    <a:pt x="247026" y="1667767"/>
+                  </a:moveTo>
+                  <a:lnTo>
+                    <a:pt x="0" y="1261367"/>
+                  </a:lnTo>
+                  <a:lnTo>
+                    <a:pt x="203200" y="1261367"/>
+                  </a:lnTo>
+                  <a:lnTo>
+                    <a:pt x="203200" y="0"/>
+                  </a:lnTo>
+                  <a:lnTo>
+                    <a:pt x="290851" y="0"/>
+                  </a:lnTo>
+                  <a:lnTo>
+                    <a:pt x="290851" y="1261367"/>
+                  </a:lnTo>
+                  <a:lnTo>
+                    <a:pt x="494051" y="1261367"/>
+                  </a:lnTo>
+                  <a:lnTo>
+                    <a:pt x="247026" y="1667767"/>
+                  </a:lnTo>
+                  <a:close/>
+                </a:path>
+              </a:pathLst>
+            </a:custGeom>
+            <a:solidFill>
+              <a:srgbClr val="FFFFFF"/>
+            </a:solidFill>
+          </p:spPr>
+        </p:sp>
+        <p:sp>
+          <p:nvSpPr>
+            <p:cNvPr name="TextBox 20" id="20"/>
+            <p:cNvSpPr txBox="true"/>
+            <p:nvPr/>
+          </p:nvSpPr>
+          <p:spPr>
+            <a:xfrm>
+              <a:off x="203200" y="-19050"/>
+              <a:ext cx="87651" cy="1585217"/>
+            </a:xfrm>
+            <a:prstGeom prst="rect">
+              <a:avLst/>
+            </a:prstGeom>
+          </p:spPr>
+          <p:txBody>
+            <a:bodyPr anchor="ctr" rtlCol="false" tIns="50800" lIns="50800" bIns="50800" rIns="50800"/>
+            <a:lstStyle/>
+            <a:p>
+              <a:pPr algn="ctr">
+                <a:lnSpc>
+                  <a:spcPts val="2859"/>
+                </a:lnSpc>
+              </a:pPr>
+            </a:p>
+          </p:txBody>
+        </p:sp>
+      </p:grpSp>
+      <p:grpSp>
+        <p:nvGrpSpPr>
+          <p:cNvPr name="Group 21" id="21"/>
+          <p:cNvGrpSpPr/>
+          <p:nvPr/>
+        </p:nvGrpSpPr>
+        <p:grpSpPr>
+          <a:xfrm rot="5400000">
+            <a:off x="8003248" y="3102872"/>
+            <a:ext cx="204405" cy="335239"/>
+            <a:chOff x="0" y="0"/>
+            <a:chExt cx="494051" cy="810280"/>
+          </a:xfrm>
+        </p:grpSpPr>
+        <p:sp>
+          <p:nvSpPr>
+            <p:cNvPr name="Freeform 22" id="22"/>
+            <p:cNvSpPr/>
+            <p:nvPr/>
+          </p:nvSpPr>
+          <p:spPr>
+            <a:xfrm flipH="false" flipV="false" rot="0">
+              <a:off x="0" y="0"/>
+              <a:ext cx="494051" cy="810280"/>
+            </a:xfrm>
+            <a:custGeom>
+              <a:avLst/>
+              <a:gdLst/>
+              <a:ahLst/>
+              <a:cxnLst/>
+              <a:rect r="r" b="b" t="t" l="l"/>
+              <a:pathLst>
+                <a:path h="810280" w="494051">
+                  <a:moveTo>
+                    <a:pt x="247026" y="810280"/>
+                  </a:moveTo>
+                  <a:lnTo>
+                    <a:pt x="0" y="403880"/>
+                  </a:lnTo>
+                  <a:lnTo>
+                    <a:pt x="203200" y="403880"/>
+                  </a:lnTo>
+                  <a:lnTo>
+                    <a:pt x="203200" y="0"/>
+                  </a:lnTo>
+                  <a:lnTo>
+                    <a:pt x="290851" y="0"/>
+                  </a:lnTo>
+                  <a:lnTo>
+                    <a:pt x="290851" y="403880"/>
+                  </a:lnTo>
+                  <a:lnTo>
+                    <a:pt x="494051" y="403880"/>
+                  </a:lnTo>
+                  <a:lnTo>
+                    <a:pt x="247026" y="810280"/>
+                  </a:lnTo>
+                  <a:close/>
+                </a:path>
+              </a:pathLst>
+            </a:custGeom>
+            <a:solidFill>
+              <a:srgbClr val="FFFFFF"/>
+            </a:solidFill>
+          </p:spPr>
+        </p:sp>
+        <p:sp>
+          <p:nvSpPr>
+            <p:cNvPr name="TextBox 23" id="23"/>
+            <p:cNvSpPr txBox="true"/>
+            <p:nvPr/>
+          </p:nvSpPr>
+          <p:spPr>
+            <a:xfrm>
+              <a:off x="203200" y="-19050"/>
+              <a:ext cx="87651" cy="727730"/>
+            </a:xfrm>
+            <a:prstGeom prst="rect">
+              <a:avLst/>
+            </a:prstGeom>
+          </p:spPr>
+          <p:txBody>
+            <a:bodyPr anchor="ctr" rtlCol="false" tIns="50800" lIns="50800" bIns="50800" rIns="50800"/>
+            <a:lstStyle/>
+            <a:p>
+              <a:pPr algn="ctr">
+                <a:lnSpc>
+                  <a:spcPts val="2859"/>
+                </a:lnSpc>
+              </a:pPr>
+            </a:p>
+          </p:txBody>
+        </p:sp>
+      </p:grpSp>
+      <p:grpSp>
+        <p:nvGrpSpPr>
+          <p:cNvPr name="Group 24" id="24"/>
+          <p:cNvGrpSpPr/>
+          <p:nvPr/>
+        </p:nvGrpSpPr>
+        <p:grpSpPr>
+          <a:xfrm rot="8212146">
+            <a:off x="8080525" y="4791531"/>
+            <a:ext cx="240990" cy="2310617"/>
+            <a:chOff x="0" y="0"/>
+            <a:chExt cx="523047" cy="5014979"/>
+          </a:xfrm>
+        </p:grpSpPr>
+        <p:sp>
+          <p:nvSpPr>
+            <p:cNvPr name="Freeform 25" id="25"/>
+            <p:cNvSpPr/>
+            <p:nvPr/>
+          </p:nvSpPr>
+          <p:spPr>
+            <a:xfrm flipH="false" flipV="false" rot="0">
+              <a:off x="0" y="0"/>
+              <a:ext cx="523047" cy="5014979"/>
+            </a:xfrm>
+            <a:custGeom>
+              <a:avLst/>
+              <a:gdLst/>
+              <a:ahLst/>
+              <a:cxnLst/>
+              <a:rect r="r" b="b" t="t" l="l"/>
+              <a:pathLst>
+                <a:path h="5014979" w="523047">
+                  <a:moveTo>
+                    <a:pt x="261523" y="5014979"/>
+                  </a:moveTo>
+                  <a:lnTo>
+                    <a:pt x="0" y="4608579"/>
+                  </a:lnTo>
+                  <a:lnTo>
+                    <a:pt x="203200" y="4608579"/>
+                  </a:lnTo>
+                  <a:lnTo>
+                    <a:pt x="203200" y="0"/>
+                  </a:lnTo>
+                  <a:lnTo>
+                    <a:pt x="319847" y="0"/>
+                  </a:lnTo>
+                  <a:lnTo>
+                    <a:pt x="319847" y="4608579"/>
+                  </a:lnTo>
+                  <a:lnTo>
+                    <a:pt x="523047" y="4608579"/>
+                  </a:lnTo>
+                  <a:lnTo>
+                    <a:pt x="261523" y="5014979"/>
+                  </a:lnTo>
+                  <a:close/>
+                </a:path>
+              </a:pathLst>
+            </a:custGeom>
+            <a:solidFill>
+              <a:srgbClr val="FFFFFF"/>
+            </a:solidFill>
+          </p:spPr>
+        </p:sp>
+        <p:sp>
+          <p:nvSpPr>
+            <p:cNvPr name="TextBox 26" id="26"/>
+            <p:cNvSpPr txBox="true"/>
+            <p:nvPr/>
+          </p:nvSpPr>
+          <p:spPr>
+            <a:xfrm>
+              <a:off x="203200" y="-19050"/>
+              <a:ext cx="116647" cy="4932429"/>
+            </a:xfrm>
+            <a:prstGeom prst="rect">
+              <a:avLst/>
+            </a:prstGeom>
+          </p:spPr>
+          <p:txBody>
+            <a:bodyPr anchor="ctr" rtlCol="false" tIns="50800" lIns="50800" bIns="50800" rIns="50800"/>
+            <a:lstStyle/>
+            <a:p>
+              <a:pPr algn="ctr">
+                <a:lnSpc>
+                  <a:spcPts val="2859"/>
+                </a:lnSpc>
+              </a:pPr>
+            </a:p>
+          </p:txBody>
+        </p:sp>
+      </p:grpSp>
+      <p:sp>
+        <p:nvSpPr>
+          <p:cNvPr name="Freeform 27" id="27"/>
+          <p:cNvSpPr/>
+          <p:nvPr/>
+        </p:nvSpPr>
+        <p:spPr>
+          <a:xfrm flipH="false" flipV="false" rot="0">
+            <a:off x="14749362" y="162879"/>
+            <a:ext cx="2376011" cy="1731641"/>
+          </a:xfrm>
+          <a:custGeom>
+            <a:avLst/>
+            <a:gdLst/>
+            <a:ahLst/>
+            <a:cxnLst/>
+            <a:rect r="r" b="b" t="t" l="l"/>
+            <a:pathLst>
+              <a:path h="1731641" w="2376011">
+                <a:moveTo>
+                  <a:pt x="0" y="0"/>
+                </a:moveTo>
+                <a:lnTo>
+                  <a:pt x="2376011" y="0"/>
+                </a:lnTo>
+                <a:lnTo>
+                  <a:pt x="2376011" y="1731642"/>
+                </a:lnTo>
+                <a:lnTo>
+                  <a:pt x="0" y="1731642"/>
+                </a:lnTo>
+                <a:lnTo>
+                  <a:pt x="0" y="0"/>
+                </a:lnTo>
+                <a:close/>
+              </a:path>
+            </a:pathLst>
+          </a:custGeom>
+          <a:blipFill>
+            <a:blip r:embed="rId10"/>
+            <a:stretch>
+              <a:fillRect l="0" t="0" r="-2249" b="0"/>
+            </a:stretch>
+          </a:blipFill>
+        </p:spPr>
+      </p:sp>
+      <p:sp>
+        <p:nvSpPr>
+          <p:cNvPr name="Freeform 28" id="28"/>
+          <p:cNvSpPr/>
+          <p:nvPr/>
+        </p:nvSpPr>
+        <p:spPr>
+          <a:xfrm flipH="false" flipV="false" rot="0">
+            <a:off x="13840052" y="1983571"/>
+            <a:ext cx="2136250" cy="2158896"/>
+          </a:xfrm>
+          <a:custGeom>
+            <a:avLst/>
+            <a:gdLst/>
+            <a:ahLst/>
+            <a:cxnLst/>
+            <a:rect r="r" b="b" t="t" l="l"/>
+            <a:pathLst>
+              <a:path h="2158896" w="2136250">
+                <a:moveTo>
+                  <a:pt x="0" y="0"/>
+                </a:moveTo>
+                <a:lnTo>
+                  <a:pt x="2136250" y="0"/>
+                </a:lnTo>
+                <a:lnTo>
+                  <a:pt x="2136250" y="2158897"/>
+                </a:lnTo>
+                <a:lnTo>
+                  <a:pt x="0" y="2158897"/>
+                </a:lnTo>
+                <a:lnTo>
+                  <a:pt x="0" y="0"/>
+                </a:lnTo>
+                <a:close/>
+              </a:path>
+            </a:pathLst>
+          </a:custGeom>
+          <a:blipFill>
+            <a:blip r:embed="rId11"/>
+            <a:stretch>
+              <a:fillRect l="0" t="0" r="0" b="0"/>
+            </a:stretch>
+          </a:blipFill>
+        </p:spPr>
+      </p:sp>
+      <p:grpSp>
+        <p:nvGrpSpPr>
+          <p:cNvPr name="Group 29" id="29"/>
+          <p:cNvGrpSpPr/>
+          <p:nvPr/>
+        </p:nvGrpSpPr>
+        <p:grpSpPr>
+          <a:xfrm rot="-5400000">
+            <a:off x="12866634" y="-1047469"/>
+            <a:ext cx="204405" cy="3377320"/>
+            <a:chOff x="0" y="0"/>
+            <a:chExt cx="494051" cy="8163046"/>
+          </a:xfrm>
+        </p:grpSpPr>
+        <p:sp>
+          <p:nvSpPr>
+            <p:cNvPr name="Freeform 30" id="30"/>
+            <p:cNvSpPr/>
+            <p:nvPr/>
+          </p:nvSpPr>
+          <p:spPr>
+            <a:xfrm flipH="false" flipV="false" rot="0">
+              <a:off x="0" y="0"/>
+              <a:ext cx="494051" cy="8163046"/>
+            </a:xfrm>
+            <a:custGeom>
+              <a:avLst/>
+              <a:gdLst/>
+              <a:ahLst/>
+              <a:cxnLst/>
+              <a:rect r="r" b="b" t="t" l="l"/>
+              <a:pathLst>
+                <a:path h="8163046" w="494051">
+                  <a:moveTo>
+                    <a:pt x="247026" y="8163046"/>
+                  </a:moveTo>
+                  <a:lnTo>
+                    <a:pt x="0" y="7756646"/>
+                  </a:lnTo>
+                  <a:lnTo>
+                    <a:pt x="203200" y="7756646"/>
+                  </a:lnTo>
+                  <a:lnTo>
+                    <a:pt x="203200" y="0"/>
+                  </a:lnTo>
+                  <a:lnTo>
+                    <a:pt x="290851" y="0"/>
+                  </a:lnTo>
+                  <a:lnTo>
+                    <a:pt x="290851" y="7756646"/>
+                  </a:lnTo>
+                  <a:lnTo>
+                    <a:pt x="494051" y="7756646"/>
+                  </a:lnTo>
+                  <a:lnTo>
+                    <a:pt x="247026" y="8163046"/>
+                  </a:lnTo>
+                  <a:close/>
+                </a:path>
+              </a:pathLst>
+            </a:custGeom>
+            <a:solidFill>
+              <a:srgbClr val="FFFFFF"/>
+            </a:solidFill>
+          </p:spPr>
+        </p:sp>
+        <p:sp>
+          <p:nvSpPr>
+            <p:cNvPr name="TextBox 31" id="31"/>
+            <p:cNvSpPr txBox="true"/>
+            <p:nvPr/>
+          </p:nvSpPr>
+          <p:spPr>
+            <a:xfrm>
+              <a:off x="203200" y="-19050"/>
+              <a:ext cx="87651" cy="8080496"/>
+            </a:xfrm>
+            <a:prstGeom prst="rect">
+              <a:avLst/>
+            </a:prstGeom>
+          </p:spPr>
+          <p:txBody>
+            <a:bodyPr anchor="ctr" rtlCol="false" tIns="50800" lIns="50800" bIns="50800" rIns="50800"/>
+            <a:lstStyle/>
+            <a:p>
+              <a:pPr algn="ctr">
+                <a:lnSpc>
+                  <a:spcPts val="2859"/>
+                </a:lnSpc>
+              </a:pPr>
+            </a:p>
+          </p:txBody>
+        </p:sp>
+      </p:grpSp>
+      <p:grpSp>
+        <p:nvGrpSpPr>
+          <p:cNvPr name="Group 32" id="32"/>
+          <p:cNvGrpSpPr/>
+          <p:nvPr/>
+        </p:nvGrpSpPr>
+        <p:grpSpPr>
+          <a:xfrm rot="-3850067">
+            <a:off x="12385196" y="101290"/>
+            <a:ext cx="204405" cy="2592690"/>
+            <a:chOff x="0" y="0"/>
+            <a:chExt cx="494051" cy="6266580"/>
+          </a:xfrm>
+        </p:grpSpPr>
+        <p:sp>
+          <p:nvSpPr>
+            <p:cNvPr name="Freeform 33" id="33"/>
+            <p:cNvSpPr/>
+            <p:nvPr/>
+          </p:nvSpPr>
+          <p:spPr>
+            <a:xfrm flipH="false" flipV="false" rot="0">
+              <a:off x="0" y="0"/>
+              <a:ext cx="494051" cy="6266580"/>
+            </a:xfrm>
+            <a:custGeom>
+              <a:avLst/>
+              <a:gdLst/>
+              <a:ahLst/>
+              <a:cxnLst/>
+              <a:rect r="r" b="b" t="t" l="l"/>
+              <a:pathLst>
+                <a:path h="6266580" w="494051">
+                  <a:moveTo>
+                    <a:pt x="247026" y="6266580"/>
+                  </a:moveTo>
+                  <a:lnTo>
+                    <a:pt x="0" y="5860180"/>
+                  </a:lnTo>
+                  <a:lnTo>
+                    <a:pt x="203200" y="5860180"/>
+                  </a:lnTo>
+                  <a:lnTo>
+                    <a:pt x="203200" y="0"/>
+                  </a:lnTo>
+                  <a:lnTo>
+                    <a:pt x="290851" y="0"/>
+                  </a:lnTo>
+                  <a:lnTo>
+                    <a:pt x="290851" y="5860180"/>
+                  </a:lnTo>
+                  <a:lnTo>
+                    <a:pt x="494051" y="5860180"/>
+                  </a:lnTo>
+                  <a:lnTo>
+                    <a:pt x="247026" y="6266580"/>
+                  </a:lnTo>
+                  <a:close/>
+                </a:path>
+              </a:pathLst>
+            </a:custGeom>
+            <a:solidFill>
+              <a:srgbClr val="FFFFFF"/>
+            </a:solidFill>
+          </p:spPr>
+        </p:sp>
+        <p:sp>
+          <p:nvSpPr>
+            <p:cNvPr name="TextBox 34" id="34"/>
+            <p:cNvSpPr txBox="true"/>
+            <p:nvPr/>
+          </p:nvSpPr>
+          <p:spPr>
+            <a:xfrm>
+              <a:off x="203200" y="-19050"/>
+              <a:ext cx="87651" cy="6184030"/>
+            </a:xfrm>
+            <a:prstGeom prst="rect">
+              <a:avLst/>
+            </a:prstGeom>
+          </p:spPr>
+          <p:txBody>
+            <a:bodyPr anchor="ctr" rtlCol="false" tIns="50800" lIns="50800" bIns="50800" rIns="50800"/>
+            <a:lstStyle/>
+            <a:p>
+              <a:pPr algn="ctr">
+                <a:lnSpc>
+                  <a:spcPts val="2859"/>
+                </a:lnSpc>
+              </a:pPr>
+            </a:p>
+          </p:txBody>
+        </p:sp>
+      </p:grpSp>
+      <p:sp>
+        <p:nvSpPr>
+          <p:cNvPr name="Freeform 35" id="35"/>
+          <p:cNvSpPr/>
+          <p:nvPr/>
+        </p:nvSpPr>
+        <p:spPr>
+          <a:xfrm flipH="false" flipV="false" rot="0">
+            <a:off x="14909591" y="7268680"/>
+            <a:ext cx="2465306" cy="2797511"/>
+          </a:xfrm>
+          <a:custGeom>
+            <a:avLst/>
+            <a:gdLst/>
+            <a:ahLst/>
+            <a:cxnLst/>
+            <a:rect r="r" b="b" t="t" l="l"/>
+            <a:pathLst>
+              <a:path h="2797511" w="2465306">
+                <a:moveTo>
+                  <a:pt x="0" y="0"/>
+                </a:moveTo>
+                <a:lnTo>
+                  <a:pt x="2465306" y="0"/>
+                </a:lnTo>
+                <a:lnTo>
+                  <a:pt x="2465306" y="2797511"/>
+                </a:lnTo>
+                <a:lnTo>
+                  <a:pt x="0" y="2797511"/>
+                </a:lnTo>
+                <a:lnTo>
+                  <a:pt x="0" y="0"/>
+                </a:lnTo>
+                <a:close/>
+              </a:path>
+            </a:pathLst>
+          </a:custGeom>
+          <a:blipFill>
+            <a:blip r:embed="rId12"/>
+            <a:stretch>
+              <a:fillRect l="0" t="0" r="0" b="0"/>
+            </a:stretch>
+          </a:blipFill>
+        </p:spPr>
+      </p:sp>
+      <p:grpSp>
+        <p:nvGrpSpPr>
+          <p:cNvPr name="Group 36" id="36"/>
+          <p:cNvGrpSpPr/>
+          <p:nvPr/>
+        </p:nvGrpSpPr>
+        <p:grpSpPr>
+          <a:xfrm rot="-5400000">
+            <a:off x="12752750" y="7729557"/>
+            <a:ext cx="231014" cy="3762211"/>
+            <a:chOff x="0" y="0"/>
+            <a:chExt cx="558366" cy="9093334"/>
+          </a:xfrm>
+        </p:grpSpPr>
+        <p:sp>
+          <p:nvSpPr>
+            <p:cNvPr name="Freeform 37" id="37"/>
+            <p:cNvSpPr/>
+            <p:nvPr/>
+          </p:nvSpPr>
+          <p:spPr>
+            <a:xfrm flipH="false" flipV="false" rot="0">
+              <a:off x="0" y="0"/>
+              <a:ext cx="558366" cy="9093334"/>
+            </a:xfrm>
+            <a:custGeom>
+              <a:avLst/>
+              <a:gdLst/>
+              <a:ahLst/>
+              <a:cxnLst/>
+              <a:rect r="r" b="b" t="t" l="l"/>
+              <a:pathLst>
+                <a:path h="9093334" w="558366">
+                  <a:moveTo>
+                    <a:pt x="279183" y="9093334"/>
+                  </a:moveTo>
+                  <a:lnTo>
+                    <a:pt x="0" y="8686934"/>
+                  </a:lnTo>
+                  <a:lnTo>
+                    <a:pt x="203200" y="8686934"/>
+                  </a:lnTo>
+                  <a:lnTo>
+                    <a:pt x="203200" y="0"/>
+                  </a:lnTo>
+                  <a:lnTo>
+                    <a:pt x="355166" y="0"/>
+                  </a:lnTo>
+                  <a:lnTo>
+                    <a:pt x="355166" y="8686934"/>
+                  </a:lnTo>
+                  <a:lnTo>
+                    <a:pt x="558366" y="8686934"/>
+                  </a:lnTo>
+                  <a:lnTo>
+                    <a:pt x="279183" y="9093334"/>
+                  </a:lnTo>
+                  <a:close/>
+                </a:path>
+              </a:pathLst>
+            </a:custGeom>
+            <a:solidFill>
+              <a:srgbClr val="FFFFFF"/>
+            </a:solidFill>
+          </p:spPr>
+        </p:sp>
+        <p:sp>
+          <p:nvSpPr>
+            <p:cNvPr name="TextBox 38" id="38"/>
+            <p:cNvSpPr txBox="true"/>
+            <p:nvPr/>
+          </p:nvSpPr>
+          <p:spPr>
+            <a:xfrm>
+              <a:off x="203200" y="-19050"/>
+              <a:ext cx="151966" cy="9010784"/>
+            </a:xfrm>
+            <a:prstGeom prst="rect">
+              <a:avLst/>
+            </a:prstGeom>
+          </p:spPr>
+          <p:txBody>
+            <a:bodyPr anchor="ctr" rtlCol="false" tIns="50800" lIns="50800" bIns="50800" rIns="50800"/>
+            <a:lstStyle/>
+            <a:p>
+              <a:pPr algn="ctr">
+                <a:lnSpc>
+                  <a:spcPts val="2859"/>
+                </a:lnSpc>
+              </a:pPr>
+            </a:p>
+          </p:txBody>
+        </p:sp>
+      </p:grpSp>
+      <p:grpSp>
+        <p:nvGrpSpPr>
+          <p:cNvPr name="Group 39" id="39"/>
+          <p:cNvGrpSpPr/>
+          <p:nvPr/>
+        </p:nvGrpSpPr>
+        <p:grpSpPr>
+          <a:xfrm rot="-61394">
+            <a:off x="15335386" y="4319306"/>
+            <a:ext cx="208347" cy="2683934"/>
+            <a:chOff x="0" y="0"/>
+            <a:chExt cx="503580" cy="6487118"/>
+          </a:xfrm>
+        </p:grpSpPr>
+        <p:sp>
+          <p:nvSpPr>
+            <p:cNvPr name="Freeform 40" id="40"/>
+            <p:cNvSpPr/>
+            <p:nvPr/>
+          </p:nvSpPr>
+          <p:spPr>
+            <a:xfrm flipH="false" flipV="false" rot="0">
+              <a:off x="0" y="0"/>
+              <a:ext cx="503580" cy="6487118"/>
+            </a:xfrm>
+            <a:custGeom>
+              <a:avLst/>
+              <a:gdLst/>
+              <a:ahLst/>
+              <a:cxnLst/>
+              <a:rect r="r" b="b" t="t" l="l"/>
+              <a:pathLst>
+                <a:path h="6487118" w="503580">
+                  <a:moveTo>
+                    <a:pt x="251790" y="6487118"/>
+                  </a:moveTo>
+                  <a:lnTo>
+                    <a:pt x="0" y="6080718"/>
+                  </a:lnTo>
+                  <a:lnTo>
+                    <a:pt x="203200" y="6080718"/>
+                  </a:lnTo>
+                  <a:lnTo>
+                    <a:pt x="203200" y="0"/>
+                  </a:lnTo>
+                  <a:lnTo>
+                    <a:pt x="300380" y="0"/>
+                  </a:lnTo>
+                  <a:lnTo>
+                    <a:pt x="300380" y="6080718"/>
+                  </a:lnTo>
+                  <a:lnTo>
+                    <a:pt x="503580" y="6080718"/>
+                  </a:lnTo>
+                  <a:lnTo>
+                    <a:pt x="251790" y="6487118"/>
+                  </a:lnTo>
+                  <a:close/>
+                </a:path>
+              </a:pathLst>
+            </a:custGeom>
+            <a:solidFill>
+              <a:srgbClr val="FFFFFF"/>
+            </a:solidFill>
+          </p:spPr>
+        </p:sp>
+        <p:sp>
+          <p:nvSpPr>
+            <p:cNvPr name="TextBox 41" id="41"/>
+            <p:cNvSpPr txBox="true"/>
+            <p:nvPr/>
+          </p:nvSpPr>
+          <p:spPr>
+            <a:xfrm>
+              <a:off x="203200" y="-19050"/>
+              <a:ext cx="97180" cy="6404568"/>
+            </a:xfrm>
+            <a:prstGeom prst="rect">
+              <a:avLst/>
+            </a:prstGeom>
+          </p:spPr>
+          <p:txBody>
+            <a:bodyPr anchor="ctr" rtlCol="false" tIns="50800" lIns="50800" bIns="50800" rIns="50800"/>
+            <a:lstStyle/>
+            <a:p>
+              <a:pPr algn="ctr">
+                <a:lnSpc>
+                  <a:spcPts val="2859"/>
+                </a:lnSpc>
+              </a:pPr>
+            </a:p>
+          </p:txBody>
+        </p:sp>
+      </p:grpSp>
+      <p:grpSp>
+        <p:nvGrpSpPr>
+          <p:cNvPr name="Group 42" id="42"/>
+          <p:cNvGrpSpPr/>
+          <p:nvPr/>
+        </p:nvGrpSpPr>
+        <p:grpSpPr>
+          <a:xfrm rot="-61394">
+            <a:off x="16688631" y="2146759"/>
+            <a:ext cx="204405" cy="4685166"/>
+            <a:chOff x="0" y="0"/>
+            <a:chExt cx="494051" cy="11324135"/>
+          </a:xfrm>
+        </p:grpSpPr>
+        <p:sp>
+          <p:nvSpPr>
+            <p:cNvPr name="Freeform 43" id="43"/>
+            <p:cNvSpPr/>
+            <p:nvPr/>
+          </p:nvSpPr>
+          <p:spPr>
+            <a:xfrm flipH="false" flipV="false" rot="0">
+              <a:off x="0" y="0"/>
+              <a:ext cx="494051" cy="11324135"/>
+            </a:xfrm>
+            <a:custGeom>
+              <a:avLst/>
+              <a:gdLst/>
+              <a:ahLst/>
+              <a:cxnLst/>
+              <a:rect r="r" b="b" t="t" l="l"/>
+              <a:pathLst>
+                <a:path h="11324135" w="494051">
+                  <a:moveTo>
+                    <a:pt x="247026" y="11324135"/>
+                  </a:moveTo>
+                  <a:lnTo>
+                    <a:pt x="0" y="10917735"/>
+                  </a:lnTo>
+                  <a:lnTo>
+                    <a:pt x="203200" y="10917735"/>
+                  </a:lnTo>
+                  <a:lnTo>
+                    <a:pt x="203200" y="0"/>
+                  </a:lnTo>
+                  <a:lnTo>
+                    <a:pt x="290851" y="0"/>
+                  </a:lnTo>
+                  <a:lnTo>
+                    <a:pt x="290851" y="10917735"/>
+                  </a:lnTo>
+                  <a:lnTo>
+                    <a:pt x="494051" y="10917735"/>
+                  </a:lnTo>
+                  <a:lnTo>
+                    <a:pt x="247026" y="11324135"/>
+                  </a:lnTo>
+                  <a:close/>
+                </a:path>
+              </a:pathLst>
+            </a:custGeom>
+            <a:solidFill>
+              <a:srgbClr val="FFFFFF"/>
+            </a:solidFill>
+          </p:spPr>
+        </p:sp>
+        <p:sp>
+          <p:nvSpPr>
+            <p:cNvPr name="TextBox 44" id="44"/>
+            <p:cNvSpPr txBox="true"/>
+            <p:nvPr/>
+          </p:nvSpPr>
+          <p:spPr>
+            <a:xfrm>
+              <a:off x="203200" y="-19050"/>
+              <a:ext cx="87651" cy="11241585"/>
+            </a:xfrm>
+            <a:prstGeom prst="rect">
+              <a:avLst/>
+            </a:prstGeom>
+          </p:spPr>
+          <p:txBody>
+            <a:bodyPr anchor="ctr" rtlCol="false" tIns="50800" lIns="50800" bIns="50800" rIns="50800"/>
+            <a:lstStyle/>
+            <a:p>
+              <a:pPr algn="ctr">
+                <a:lnSpc>
+                  <a:spcPts val="2859"/>
+                </a:lnSpc>
+              </a:pPr>
+            </a:p>
+          </p:txBody>
+        </p:sp>
+      </p:grpSp>
+      <p:sp>
+        <p:nvSpPr>
+          <p:cNvPr name="Freeform 45" id="45"/>
+          <p:cNvSpPr/>
+          <p:nvPr/>
+        </p:nvSpPr>
+        <p:spPr>
+          <a:xfrm flipH="false" flipV="false" rot="0">
+            <a:off x="11747278" y="4434332"/>
+            <a:ext cx="2140399" cy="4768958"/>
+          </a:xfrm>
+          <a:custGeom>
+            <a:avLst/>
+            <a:gdLst/>
+            <a:ahLst/>
+            <a:cxnLst/>
+            <a:rect r="r" b="b" t="t" l="l"/>
+            <a:pathLst>
+              <a:path h="4768958" w="2140399">
+                <a:moveTo>
+                  <a:pt x="0" y="0"/>
+                </a:moveTo>
+                <a:lnTo>
+                  <a:pt x="2140399" y="0"/>
+                </a:lnTo>
+                <a:lnTo>
+                  <a:pt x="2140399" y="4768958"/>
+                </a:lnTo>
+                <a:lnTo>
+                  <a:pt x="0" y="4768958"/>
+                </a:lnTo>
+                <a:lnTo>
+                  <a:pt x="0" y="0"/>
+                </a:lnTo>
+                <a:close/>
+              </a:path>
+            </a:pathLst>
+          </a:custGeom>
+          <a:blipFill>
+            <a:blip r:embed="rId13"/>
+            <a:stretch>
+              <a:fillRect l="0" t="0" r="0" b="0"/>
+            </a:stretch>
+          </a:blipFill>
+        </p:spPr>
+      </p:sp>
+      <p:grpSp>
+        <p:nvGrpSpPr>
+          <p:cNvPr name="Group 46" id="46"/>
+          <p:cNvGrpSpPr/>
+          <p:nvPr/>
+        </p:nvGrpSpPr>
+        <p:grpSpPr>
+          <a:xfrm rot="-5400000">
+            <a:off x="11251708" y="4650145"/>
+            <a:ext cx="231014" cy="511343"/>
+            <a:chOff x="0" y="0"/>
+            <a:chExt cx="558366" cy="1235924"/>
+          </a:xfrm>
+        </p:grpSpPr>
+        <p:sp>
+          <p:nvSpPr>
+            <p:cNvPr name="Freeform 47" id="47"/>
+            <p:cNvSpPr/>
+            <p:nvPr/>
+          </p:nvSpPr>
+          <p:spPr>
+            <a:xfrm flipH="false" flipV="false" rot="0">
+              <a:off x="0" y="0"/>
+              <a:ext cx="558366" cy="1235924"/>
+            </a:xfrm>
+            <a:custGeom>
+              <a:avLst/>
+              <a:gdLst/>
+              <a:ahLst/>
+              <a:cxnLst/>
+              <a:rect r="r" b="b" t="t" l="l"/>
+              <a:pathLst>
+                <a:path h="1235924" w="558366">
+                  <a:moveTo>
+                    <a:pt x="279183" y="1235924"/>
+                  </a:moveTo>
+                  <a:lnTo>
+                    <a:pt x="0" y="829524"/>
+                  </a:lnTo>
+                  <a:lnTo>
+                    <a:pt x="203200" y="829524"/>
+                  </a:lnTo>
+                  <a:lnTo>
+                    <a:pt x="203200" y="0"/>
+                  </a:lnTo>
+                  <a:lnTo>
+                    <a:pt x="355166" y="0"/>
+                  </a:lnTo>
+                  <a:lnTo>
+                    <a:pt x="355166" y="829524"/>
+                  </a:lnTo>
+                  <a:lnTo>
+                    <a:pt x="558366" y="829524"/>
+                  </a:lnTo>
+                  <a:lnTo>
+                    <a:pt x="279183" y="1235924"/>
+                  </a:lnTo>
+                  <a:close/>
+                </a:path>
+              </a:pathLst>
+            </a:custGeom>
+            <a:solidFill>
+              <a:srgbClr val="FFFFFF"/>
+            </a:solidFill>
+          </p:spPr>
+        </p:sp>
+        <p:sp>
+          <p:nvSpPr>
+            <p:cNvPr name="TextBox 48" id="48"/>
+            <p:cNvSpPr txBox="true"/>
+            <p:nvPr/>
+          </p:nvSpPr>
+          <p:spPr>
+            <a:xfrm>
+              <a:off x="203200" y="-19050"/>
+              <a:ext cx="151966" cy="1153374"/>
+            </a:xfrm>
+            <a:prstGeom prst="rect">
+              <a:avLst/>
+            </a:prstGeom>
+          </p:spPr>
+          <p:txBody>
+            <a:bodyPr anchor="ctr" rtlCol="false" tIns="50800" lIns="50800" bIns="50800" rIns="50800"/>
+            <a:lstStyle/>
+            <a:p>
+              <a:pPr algn="ctr">
+                <a:lnSpc>
+                  <a:spcPts val="2859"/>
+                </a:lnSpc>
+              </a:pPr>
+            </a:p>
+          </p:txBody>
+        </p:sp>
+      </p:grpSp>
+      <p:grpSp>
+        <p:nvGrpSpPr>
+          <p:cNvPr name="Group 49" id="49"/>
+          <p:cNvGrpSpPr/>
+          <p:nvPr/>
+        </p:nvGrpSpPr>
+        <p:grpSpPr>
+          <a:xfrm rot="-5400000">
+            <a:off x="11173205" y="7274730"/>
+            <a:ext cx="231014" cy="603122"/>
+            <a:chOff x="0" y="0"/>
+            <a:chExt cx="558366" cy="1457757"/>
+          </a:xfrm>
+        </p:grpSpPr>
+        <p:sp>
+          <p:nvSpPr>
+            <p:cNvPr name="Freeform 50" id="50"/>
+            <p:cNvSpPr/>
+            <p:nvPr/>
+          </p:nvSpPr>
+          <p:spPr>
+            <a:xfrm flipH="false" flipV="false" rot="0">
+              <a:off x="0" y="0"/>
+              <a:ext cx="558366" cy="1457757"/>
+            </a:xfrm>
+            <a:custGeom>
+              <a:avLst/>
+              <a:gdLst/>
+              <a:ahLst/>
+              <a:cxnLst/>
+              <a:rect r="r" b="b" t="t" l="l"/>
+              <a:pathLst>
+                <a:path h="1457757" w="558366">
+                  <a:moveTo>
+                    <a:pt x="279183" y="1457757"/>
+                  </a:moveTo>
+                  <a:lnTo>
+                    <a:pt x="0" y="1051357"/>
+                  </a:lnTo>
+                  <a:lnTo>
+                    <a:pt x="203200" y="1051357"/>
+                  </a:lnTo>
+                  <a:lnTo>
+                    <a:pt x="203200" y="0"/>
+                  </a:lnTo>
+                  <a:lnTo>
+                    <a:pt x="355166" y="0"/>
+                  </a:lnTo>
+                  <a:lnTo>
+                    <a:pt x="355166" y="1051357"/>
+                  </a:lnTo>
+                  <a:lnTo>
+                    <a:pt x="558366" y="1051357"/>
+                  </a:lnTo>
+                  <a:lnTo>
+                    <a:pt x="279183" y="1457757"/>
+                  </a:lnTo>
+                  <a:close/>
+                </a:path>
+              </a:pathLst>
+            </a:custGeom>
+            <a:solidFill>
+              <a:srgbClr val="FFFFFF"/>
+            </a:solidFill>
+          </p:spPr>
+        </p:sp>
+        <p:sp>
+          <p:nvSpPr>
+            <p:cNvPr name="TextBox 51" id="51"/>
+            <p:cNvSpPr txBox="true"/>
+            <p:nvPr/>
+          </p:nvSpPr>
+          <p:spPr>
+            <a:xfrm>
+              <a:off x="203200" y="-19050"/>
+              <a:ext cx="151966" cy="1375207"/>
+            </a:xfrm>
+            <a:prstGeom prst="rect">
+              <a:avLst/>
+            </a:prstGeom>
+          </p:spPr>
+          <p:txBody>
+            <a:bodyPr anchor="ctr" rtlCol="false" tIns="50800" lIns="50800" bIns="50800" rIns="50800"/>
+            <a:lstStyle/>
+            <a:p>
+              <a:pPr algn="ctr">
+                <a:lnSpc>
+                  <a:spcPts val="2859"/>
+                </a:lnSpc>
+              </a:pPr>
+            </a:p>
+          </p:txBody>
+        </p:sp>
+      </p:grpSp>
+      <p:grpSp>
+        <p:nvGrpSpPr>
+          <p:cNvPr name="Group 52" id="52"/>
+          <p:cNvGrpSpPr/>
+          <p:nvPr/>
+        </p:nvGrpSpPr>
+        <p:grpSpPr>
+          <a:xfrm rot="5400000">
+            <a:off x="14259314" y="7541735"/>
+            <a:ext cx="231014" cy="834734"/>
+            <a:chOff x="0" y="0"/>
+            <a:chExt cx="558366" cy="2017569"/>
+          </a:xfrm>
+        </p:grpSpPr>
+        <p:sp>
+          <p:nvSpPr>
+            <p:cNvPr name="Freeform 53" id="53"/>
+            <p:cNvSpPr/>
+            <p:nvPr/>
+          </p:nvSpPr>
+          <p:spPr>
+            <a:xfrm flipH="false" flipV="false" rot="0">
+              <a:off x="0" y="0"/>
+              <a:ext cx="558366" cy="2017569"/>
+            </a:xfrm>
+            <a:custGeom>
+              <a:avLst/>
+              <a:gdLst/>
+              <a:ahLst/>
+              <a:cxnLst/>
+              <a:rect r="r" b="b" t="t" l="l"/>
+              <a:pathLst>
+                <a:path h="2017569" w="558366">
+                  <a:moveTo>
+                    <a:pt x="279183" y="2017569"/>
+                  </a:moveTo>
+                  <a:lnTo>
+                    <a:pt x="0" y="1611169"/>
+                  </a:lnTo>
+                  <a:lnTo>
+                    <a:pt x="203200" y="1611169"/>
+                  </a:lnTo>
+                  <a:lnTo>
+                    <a:pt x="203200" y="0"/>
+                  </a:lnTo>
+                  <a:lnTo>
+                    <a:pt x="355166" y="0"/>
+                  </a:lnTo>
+                  <a:lnTo>
+                    <a:pt x="355166" y="1611169"/>
+                  </a:lnTo>
+                  <a:lnTo>
+                    <a:pt x="558366" y="1611169"/>
+                  </a:lnTo>
+                  <a:lnTo>
+                    <a:pt x="279183" y="2017569"/>
+                  </a:lnTo>
+                  <a:close/>
+                </a:path>
+              </a:pathLst>
+            </a:custGeom>
+            <a:solidFill>
+              <a:srgbClr val="FFFFFF"/>
+            </a:solidFill>
+          </p:spPr>
+        </p:sp>
+        <p:sp>
+          <p:nvSpPr>
+            <p:cNvPr name="TextBox 54" id="54"/>
+            <p:cNvSpPr txBox="true"/>
+            <p:nvPr/>
+          </p:nvSpPr>
+          <p:spPr>
+            <a:xfrm>
+              <a:off x="203200" y="-19050"/>
+              <a:ext cx="151966" cy="1935019"/>
+            </a:xfrm>
+            <a:prstGeom prst="rect">
+              <a:avLst/>
+            </a:prstGeom>
+          </p:spPr>
+          <p:txBody>
+            <a:bodyPr anchor="ctr" rtlCol="false" tIns="50800" lIns="50800" bIns="50800" rIns="50800"/>
+            <a:lstStyle/>
+            <a:p>
+              <a:pPr algn="ctr">
+                <a:lnSpc>
+                  <a:spcPts val="2859"/>
+                </a:lnSpc>
+              </a:pPr>
+            </a:p>
+          </p:txBody>
+        </p:sp>
+      </p:grpSp>
+      <p:sp>
+        <p:nvSpPr>
+          <p:cNvPr name="Freeform 55" id="55"/>
+          <p:cNvSpPr/>
+          <p:nvPr/>
+        </p:nvSpPr>
+        <p:spPr>
+          <a:xfrm flipH="false" flipV="false" rot="0">
+            <a:off x="8379096" y="1899536"/>
+            <a:ext cx="2608055" cy="3701756"/>
+          </a:xfrm>
+          <a:custGeom>
+            <a:avLst/>
+            <a:gdLst/>
+            <a:ahLst/>
+            <a:cxnLst/>
+            <a:rect r="r" b="b" t="t" l="l"/>
+            <a:pathLst>
+              <a:path h="3701756" w="2608055">
+                <a:moveTo>
+                  <a:pt x="0" y="0"/>
+                </a:moveTo>
+                <a:lnTo>
+                  <a:pt x="2608056" y="0"/>
+                </a:lnTo>
+                <a:lnTo>
+                  <a:pt x="2608056" y="3701756"/>
+                </a:lnTo>
+                <a:lnTo>
+                  <a:pt x="0" y="3701756"/>
+                </a:lnTo>
+                <a:lnTo>
+                  <a:pt x="0" y="0"/>
+                </a:lnTo>
+                <a:close/>
+              </a:path>
+            </a:pathLst>
+          </a:custGeom>
+          <a:blipFill>
+            <a:blip r:embed="rId14"/>
+            <a:stretch>
+              <a:fillRect l="0" t="0" r="0" b="0"/>
+            </a:stretch>
+          </a:blipFill>
+        </p:spPr>
+      </p:sp>
+      <p:sp>
+        <p:nvSpPr>
+          <p:cNvPr name="TextBox 56" id="56"/>
           <p:cNvSpPr txBox="true"/>
           <p:nvPr/>
         </p:nvSpPr>
@@ -6739,7 +8375,7 @@
       </p:sp>
       <p:sp>
         <p:nvSpPr>
-          <p:cNvPr name="TextBox 9" id="9"/>
+          <p:cNvPr name="TextBox 57" id="57"/>
           <p:cNvSpPr txBox="true"/>
           <p:nvPr/>
         </p:nvSpPr>

</xml_diff>